<commit_message>
auto: claude session 2026-06-29 18:53:34
</commit_message>
<xml_diff>
--- a/slides/C2F1G4.pptx
+++ b/slides/C2F1G4.pptx
@@ -6249,7 +6249,32 @@
                 </a:solidFill>
                 <a:latin typeface="Arial"/>
               </a:rPr>
-              <a:t>Roles: Guest, Receptionist, Hotel Manager,</a:t>
+              <a:t>Roles: Guest, Receptionist, Hotel Manager, Heads of Concierge &amp; Housekeeping</a:t>
+            </a:r>
+          </a:p>
+          <a:p>
+            <a:pPr algn="l">
+              <a:spcAft>
+                <a:spcPts val="700"/>
+              </a:spcAft>
+            </a:pPr>
+            <a:r>
+              <a:rPr sz="1800" b="1" i="0">
+                <a:solidFill>
+                  <a:srgbClr val="0065BD"/>
+                </a:solidFill>
+                <a:latin typeface="Arial"/>
+              </a:rPr>
+              <a:t>▪  </a:t>
+            </a:r>
+            <a:r>
+              <a:rPr sz="1800" b="0" i="0">
+                <a:solidFill>
+                  <a:srgbClr val="20252A"/>
+                </a:solidFill>
+                <a:latin typeface="Arial"/>
+              </a:rPr>
+              <a:t>Concrete process steps (not one abstract process):</a:t>
             </a:r>
           </a:p>
           <a:p>
@@ -6274,7 +6299,57 @@
                 </a:solidFill>
                 <a:latin typeface="Arial"/>
               </a:rPr>
-              <a:t>Heads of Concierge &amp; Housekeeping</a:t>
+              <a:t>submit request → check availability → calculate price → reserve</a:t>
+            </a:r>
+          </a:p>
+          <a:p>
+            <a:pPr algn="l" lvl="1">
+              <a:spcAft>
+                <a:spcPts val="400"/>
+              </a:spcAft>
+            </a:pPr>
+            <a:r>
+              <a:rPr sz="1600" b="0" i="0">
+                <a:solidFill>
+                  <a:srgbClr val="64A0C8"/>
+                </a:solidFill>
+                <a:latin typeface="Arial"/>
+              </a:rPr>
+              <a:t>–  </a:t>
+            </a:r>
+            <a:r>
+              <a:rPr sz="1600" b="0" i="0">
+                <a:solidFill>
+                  <a:srgbClr val="20252A"/>
+                </a:solidFill>
+                <a:latin typeface="Arial"/>
+              </a:rPr>
+              <a:t>process payment (external) → submit special requests</a:t>
+            </a:r>
+          </a:p>
+          <a:p>
+            <a:pPr algn="l" lvl="1">
+              <a:spcAft>
+                <a:spcPts val="400"/>
+              </a:spcAft>
+            </a:pPr>
+            <a:r>
+              <a:rPr sz="1600" b="0" i="0">
+                <a:solidFill>
+                  <a:srgbClr val="64A0C8"/>
+                </a:solidFill>
+                <a:latin typeface="Arial"/>
+              </a:rPr>
+              <a:t>–  </a:t>
+            </a:r>
+            <a:r>
+              <a:rPr sz="1600" b="0" i="0">
+                <a:solidFill>
+                  <a:srgbClr val="20252A"/>
+                </a:solidFill>
+                <a:latin typeface="Arial"/>
+              </a:rPr>
+              <a:t>arrival schedule → daily briefing → check-in → issue key card</a:t>
             </a:r>
           </a:p>
           <a:p>
@@ -6299,157 +6374,7 @@
                 </a:solidFill>
                 <a:latin typeface="Arial"/>
               </a:rPr>
-              <a:t>Concrete process steps (not one abstract process):</a:t>
-            </a:r>
-          </a:p>
-          <a:p>
-            <a:pPr algn="l" lvl="1">
-              <a:spcAft>
-                <a:spcPts val="400"/>
-              </a:spcAft>
-            </a:pPr>
-            <a:r>
-              <a:rPr sz="1600" b="0" i="0">
-                <a:solidFill>
-                  <a:srgbClr val="64A0C8"/>
-                </a:solidFill>
-                <a:latin typeface="Arial"/>
-              </a:rPr>
-              <a:t>–  </a:t>
-            </a:r>
-            <a:r>
-              <a:rPr sz="1600" b="0" i="0">
-                <a:solidFill>
-                  <a:srgbClr val="20252A"/>
-                </a:solidFill>
-                <a:latin typeface="Arial"/>
-              </a:rPr>
-              <a:t>submit request → check availability → price → reserve</a:t>
-            </a:r>
-          </a:p>
-          <a:p>
-            <a:pPr algn="l" lvl="1">
-              <a:spcAft>
-                <a:spcPts val="400"/>
-              </a:spcAft>
-            </a:pPr>
-            <a:r>
-              <a:rPr sz="1600" b="0" i="0">
-                <a:solidFill>
-                  <a:srgbClr val="64A0C8"/>
-                </a:solidFill>
-                <a:latin typeface="Arial"/>
-              </a:rPr>
-              <a:t>–  </a:t>
-            </a:r>
-            <a:r>
-              <a:rPr sz="1600" b="0" i="0">
-                <a:solidFill>
-                  <a:srgbClr val="20252A"/>
-                </a:solidFill>
-                <a:latin typeface="Arial"/>
-              </a:rPr>
-              <a:t>external payment → submit special requests</a:t>
-            </a:r>
-          </a:p>
-          <a:p>
-            <a:pPr algn="l" lvl="1">
-              <a:spcAft>
-                <a:spcPts val="400"/>
-              </a:spcAft>
-            </a:pPr>
-            <a:r>
-              <a:rPr sz="1600" b="0" i="0">
-                <a:solidFill>
-                  <a:srgbClr val="64A0C8"/>
-                </a:solidFill>
-                <a:latin typeface="Arial"/>
-              </a:rPr>
-              <a:t>–  </a:t>
-            </a:r>
-            <a:r>
-              <a:rPr sz="1600" b="0" i="0">
-                <a:solidFill>
-                  <a:srgbClr val="20252A"/>
-                </a:solidFill>
-                <a:latin typeface="Arial"/>
-              </a:rPr>
-              <a:t>arrival schedule → briefing → check-in → key card</a:t>
-            </a:r>
-          </a:p>
-          <a:p>
-            <a:pPr algn="l">
-              <a:spcAft>
-                <a:spcPts val="700"/>
-              </a:spcAft>
-            </a:pPr>
-            <a:r>
-              <a:rPr sz="1800" b="1" i="0">
-                <a:solidFill>
-                  <a:srgbClr val="0065BD"/>
-                </a:solidFill>
-                <a:latin typeface="Arial"/>
-              </a:rPr>
-              <a:t>▪  </a:t>
-            </a:r>
-            <a:r>
-              <a:rPr sz="1800" b="0" i="0">
-                <a:solidFill>
-                  <a:srgbClr val="20252A"/>
-                </a:solidFill>
-                <a:latin typeface="Arial"/>
-              </a:rPr>
-              <a:t>Business objects: Reservation, Room Availability,</a:t>
-            </a:r>
-          </a:p>
-          <a:p>
-            <a:pPr algn="l" lvl="1">
-              <a:spcAft>
-                <a:spcPts val="400"/>
-              </a:spcAft>
-            </a:pPr>
-            <a:r>
-              <a:rPr sz="1600" b="0" i="0">
-                <a:solidFill>
-                  <a:srgbClr val="64A0C8"/>
-                </a:solidFill>
-                <a:latin typeface="Arial"/>
-              </a:rPr>
-              <a:t>–  </a:t>
-            </a:r>
-            <a:r>
-              <a:rPr sz="1600" b="0" i="0">
-                <a:solidFill>
-                  <a:srgbClr val="20252A"/>
-                </a:solidFill>
-                <a:latin typeface="Arial"/>
-              </a:rPr>
-              <a:t>Pricing, Open Costs, Special Request, Arrival</a:t>
-            </a:r>
-          </a:p>
-          <a:p>
-            <a:pPr algn="l" lvl="1">
-              <a:spcAft>
-                <a:spcPts val="400"/>
-              </a:spcAft>
-            </a:pPr>
-            <a:r>
-              <a:rPr sz="1600" b="0" i="0">
-                <a:solidFill>
-                  <a:srgbClr val="64A0C8"/>
-                </a:solidFill>
-                <a:latin typeface="Arial"/>
-              </a:rPr>
-              <a:t>–  </a:t>
-            </a:r>
-            <a:r>
-              <a:rPr sz="1600" b="0" i="0">
-                <a:solidFill>
-                  <a:srgbClr val="20252A"/>
-                </a:solidFill>
-                <a:latin typeface="Arial"/>
-              </a:rPr>
-              <a:t>Schedule, Briefing Report, Key Card</a:t>
+              <a:t>Business objects: Reservation, Room Availability, Pricing, Open Costs, Special Request, Arrival Schedule, Briefing Report, Key Card</a:t>
             </a:r>
           </a:p>
         </p:txBody>
@@ -6838,57 +6763,7 @@
                 </a:solidFill>
                 <a:latin typeface="Arial"/>
               </a:rPr>
-              <a:t>Internal functions: availability check, pricing,</a:t>
-            </a:r>
-          </a:p>
-          <a:p>
-            <a:pPr algn="l" lvl="1">
-              <a:spcAft>
-                <a:spcPts val="400"/>
-              </a:spcAft>
-            </a:pPr>
-            <a:r>
-              <a:rPr sz="1600" b="0" i="0">
-                <a:solidFill>
-                  <a:srgbClr val="64A0C8"/>
-                </a:solidFill>
-                <a:latin typeface="Arial"/>
-              </a:rPr>
-              <a:t>–  </a:t>
-            </a:r>
-            <a:r>
-              <a:rPr sz="1600" b="0" i="0">
-                <a:solidFill>
-                  <a:srgbClr val="20252A"/>
-                </a:solidFill>
-                <a:latin typeface="Arial"/>
-              </a:rPr>
-              <a:t>reservation mgmt, payment handling,</a:t>
-            </a:r>
-          </a:p>
-          <a:p>
-            <a:pPr algn="l" lvl="1">
-              <a:spcAft>
-                <a:spcPts val="400"/>
-              </a:spcAft>
-            </a:pPr>
-            <a:r>
-              <a:rPr sz="1600" b="0" i="0">
-                <a:solidFill>
-                  <a:srgbClr val="64A0C8"/>
-                </a:solidFill>
-                <a:latin typeface="Arial"/>
-              </a:rPr>
-              <a:t>–  </a:t>
-            </a:r>
-            <a:r>
-              <a:rPr sz="1600" b="0" i="0">
-                <a:solidFill>
-                  <a:srgbClr val="20252A"/>
-                </a:solidFill>
-                <a:latin typeface="Arial"/>
-              </a:rPr>
-              <a:t>briefing-report generation, check-in / key-card mgmt</a:t>
+              <a:t>Internal functions: availability check, pricing, reservation mgmt, payment handling, briefing-report generation, check-in / key-card mgmt</a:t>
             </a:r>
           </a:p>
           <a:p>
@@ -6913,32 +6788,7 @@
                 </a:solidFill>
                 <a:latin typeface="Arial"/>
               </a:rPr>
-              <a:t>Around it: Web Booking System, External Booking</a:t>
-            </a:r>
-          </a:p>
-          <a:p>
-            <a:pPr algn="l" lvl="1">
-              <a:spcAft>
-                <a:spcPts val="400"/>
-              </a:spcAft>
-            </a:pPr>
-            <a:r>
-              <a:rPr sz="1600" b="0" i="0">
-                <a:solidFill>
-                  <a:srgbClr val="64A0C8"/>
-                </a:solidFill>
-                <a:latin typeface="Arial"/>
-              </a:rPr>
-              <a:t>–  </a:t>
-            </a:r>
-            <a:r>
-              <a:rPr sz="1600" b="0" i="0">
-                <a:solidFill>
-                  <a:srgbClr val="20252A"/>
-                </a:solidFill>
-                <a:latin typeface="Arial"/>
-              </a:rPr>
-              <a:t>Platform, External Payment Service, Door Access App</a:t>
+              <a:t>Around it: Web Booking System, External Booking Platform, External Payment Service, Door Access App</a:t>
             </a:r>
           </a:p>
           <a:p>
@@ -6963,32 +6813,7 @@
                 </a:solidFill>
                 <a:latin typeface="Arial"/>
               </a:rPr>
-              <a:t>Data objects: Reservation, Room Availability,</a:t>
-            </a:r>
-          </a:p>
-          <a:p>
-            <a:pPr algn="l" lvl="1">
-              <a:spcAft>
-                <a:spcPts val="400"/>
-              </a:spcAft>
-            </a:pPr>
-            <a:r>
-              <a:rPr sz="1600" b="0" i="0">
-                <a:solidFill>
-                  <a:srgbClr val="64A0C8"/>
-                </a:solidFill>
-                <a:latin typeface="Arial"/>
-              </a:rPr>
-              <a:t>–  </a:t>
-            </a:r>
-            <a:r>
-              <a:rPr sz="1600" b="0" i="0">
-                <a:solidFill>
-                  <a:srgbClr val="20252A"/>
-                </a:solidFill>
-                <a:latin typeface="Arial"/>
-              </a:rPr>
-              <a:t>Pricing, Guest Profile, Open Costs, Room Status</a:t>
+              <a:t>Data objects: Reservation, Room Availability, Pricing, Guest Profile, Open Costs, Room Status</a:t>
             </a:r>
           </a:p>
           <a:p>
@@ -7013,32 +6838,7 @@
                 </a:solidFill>
                 <a:latin typeface="Arial"/>
               </a:rPr>
-              <a:t>Interfaces shown explicitly: Web, Booking-Platform,</a:t>
-            </a:r>
-          </a:p>
-          <a:p>
-            <a:pPr algn="l" lvl="1">
-              <a:spcAft>
-                <a:spcPts val="400"/>
-              </a:spcAft>
-            </a:pPr>
-            <a:r>
-              <a:rPr sz="1600" b="0" i="0">
-                <a:solidFill>
-                  <a:srgbClr val="64A0C8"/>
-                </a:solidFill>
-                <a:latin typeface="Arial"/>
-              </a:rPr>
-              <a:t>–  </a:t>
-            </a:r>
-            <a:r>
-              <a:rPr sz="1600" b="0" i="0">
-                <a:solidFill>
-                  <a:srgbClr val="20252A"/>
-                </a:solidFill>
-                <a:latin typeface="Arial"/>
-              </a:rPr>
-              <a:t>Payment-Gateway</a:t>
+              <a:t>Interfaces shown explicitly: Web, Booking-Platform, Payment-Gateway</a:t>
             </a:r>
           </a:p>
         </p:txBody>

</xml_diff>

<commit_message>
Polish slides per tutorial requirements: summary slide, topic picture, larger text, no em dashes, neutral footer
Co-Authored-By: Claude Fable 5 <noreply@anthropic.com>
</commit_message>
<xml_diff>
--- a/slides/C2F1G4.pptx
+++ b/slides/C2F1G4.pptx
@@ -32,6 +32,7 @@
     <p:sldId id="268" r:id="rId27"/>
     <p:sldId id="269" r:id="rId28"/>
     <p:sldId id="270" r:id="rId29"/>
+    <p:sldId id="271" r:id="rId30"/>
   </p:sldIdLst>
   <p:sldSz cx="9144000" cy="5143500" type="screen16x9"/>
   <p:notesSz cx="9925050" cy="6665913"/>
@@ -918,12 +919,12 @@
           <a:lstStyle/>
           <a:p>
             <a:r>
-              <a:t>SPEAKER Katrin (P1) · ~15 s</a:t>
-            </a:r>
-          </a:p>
-          <a:p>
-            <a:r>
-              <a:t>Hook: “Where luxury feels effortless — but behind the desk, five systems have to cooperate for every check-in.” Say the team name (C2F1G4) and move straight on. VERIFY team-member names/spelling before submission (roster inferred from repo commits).</a:t>
+              <a:t>SPEAKER Katrin (P1), about 15 seconds.</a:t>
+            </a:r>
+          </a:p>
+          <a:p>
+            <a:r>
+              <a:t>Hook: "At ArchiHotel, luxury feels effortless. But behind the desk, five systems have to cooperate for every single check-in." Say the team name, then move straight on. VERIFY the name spellings before submission, the roster comes from repo commits.</a:t>
             </a:r>
           </a:p>
         </p:txBody>
@@ -993,12 +994,12 @@
           <a:lstStyle/>
           <a:p>
             <a:r>
-              <a:t>SPEAKER Demir → Katrin (P5/P1) · ~60 s</a:t>
-            </a:r>
-          </a:p>
-          <a:p>
-            <a:r>
-              <a:t>Value: the model makes five-plus cooperating systems transparent, supports impact analysis (walk one example: HMS down → which services stop), and speeds up onboarding. Limitations: it's an as-is snapshot without governance, has no quantities or SLAs, and abstraction hides detail by design.</a:t>
+              <a:t>SPEAKER Demir, then Katrin (P5/P1), about 60 seconds.</a:t>
+            </a:r>
+          </a:p>
+          <a:p>
+            <a:r>
+              <a:t>Value: the model gives one shared picture across more than five systems, supports impact analysis (walk one example: HMS down, which services stop?), and speeds up onboarding. Limitations: it's an as-is snapshot with no governance process, it has no quantities or SLAs, and every abstraction choice hides detail on purpose.</a:t>
             </a:r>
           </a:p>
         </p:txBody>
@@ -1068,12 +1069,12 @@
           <a:lstStyle/>
           <a:p>
             <a:r>
-              <a:t>SPEAKER Katrin (P1) · ~60 s</a:t>
-            </a:r>
-          </a:p>
-          <a:p>
-            <a:r>
-              <a:t>Missing: reservation-side infrastructure specs, external booking-platform interfaces, failure/volume data. Challenges — use the real ones: the abstraction-level trade-off, keeping the two views consistent, and coArchi merge conflicts/duplicates from modelling in parallel (the kickoff literally warns about this — we hit it and merged 11 duplicate elements). Close: thank you — questions? Everyone stays up front for Q&amp;A.</a:t>
+              <a:t>SPEAKER Katrin (P1), about 60 seconds.</a:t>
+            </a:r>
+          </a:p>
+          <a:p>
+            <a:r>
+              <a:t>Missing: infrastructure specs for the reservation side, the interfaces to external booking platforms, and any failure or volume data. Challenges, use the real ones: choosing the abstraction level, keeping the two views consistent while both evolved, and coArchi merge conflicts from modeling in parallel. We hit that one for real and merged eleven duplicate elements late. The kickoff literally warns about it.</a:t>
             </a:r>
           </a:p>
         </p:txBody>
@@ -1143,7 +1144,12 @@
           <a:lstStyle/>
           <a:p>
             <a:r>
-              <a:t>Q&amp;A backup (3–5 min — they will ask each member something). Following slides: full detailed view, full abstract view, model facts &amp; figures.</a:t>
+              <a:t>SPEAKER Katrin (P1), about 30 seconds.</a:t>
+            </a:r>
+          </a:p>
+          <a:p>
+            <a:r>
+              <a:t>Recap in three sentences: we modeled reservation handling and check-in across all three ArchiMate layers, everything converges on the HMS, and the model's value is transparency and impact analysis, with the limits of a snapshot. Thank the audience. KEEP THIS SLIDE UP during the discussion. Everyone stays up front, they will ask each member something.</a:t>
             </a:r>
           </a:p>
         </p:txBody>
@@ -1213,7 +1219,7 @@
           <a:lstStyle/>
           <a:p>
             <a:r>
-              <a:t>Backup: complete detailed view for zoom-in questions.</a:t>
+              <a:t>Q&amp;A backup, 5 minutes of discussion. Following slides: full detailed view, full abstract view, model facts.</a:t>
             </a:r>
           </a:p>
         </p:txBody>
@@ -1283,7 +1289,7 @@
           <a:lstStyle/>
           <a:p>
             <a:r>
-              <a:t>Backup: complete abstract view — use for questions on F2/F3 services (briefing, laundry, transfer).</a:t>
+              <a:t>Backup: complete detailed view for zoom-in questions.</a:t>
             </a:r>
           </a:p>
         </p:txBody>
@@ -1353,7 +1359,77 @@
           <a:lstStyle/>
           <a:p>
             <a:r>
-              <a:t>Backup: numbers and workflow facts for Q&amp;A.</a:t>
+              <a:t>Backup: complete abstract view. Useful for questions about the other focus areas, like briefing, laundry or transfer.</a:t>
+            </a:r>
+          </a:p>
+        </p:txBody>
+      </p:sp>
+      <p:sp>
+        <p:nvSpPr>
+          <p:cNvPr id="4" name="Slide Number Placeholder 3"/>
+          <p:cNvSpPr>
+            <a:spLocks noGrp="1"/>
+          </p:cNvSpPr>
+          <p:nvPr>
+            <p:ph type="sldNum" idx="5" sz="quarter"/>
+          </p:nvPr>
+        </p:nvSpPr>
+        <p:spPr/>
+      </p:sp>
+    </p:spTree>
+  </p:cSld>
+  <p:clrMapOvr>
+    <a:masterClrMapping/>
+  </p:clrMapOvr>
+</p:notes>
+</file>
+
+<file path=ppt/notesSlides/notesSlide16.xml><?xml version="1.0" encoding="utf-8"?>
+<p:notes xmlns:a="http://schemas.openxmlformats.org/drawingml/2006/main" xmlns:p="http://schemas.openxmlformats.org/presentationml/2006/main" xmlns:r="http://schemas.openxmlformats.org/officeDocument/2006/relationships">
+  <p:cSld>
+    <p:spTree>
+      <p:nvGrpSpPr>
+        <p:cNvPr id="1" name=""/>
+        <p:cNvGrpSpPr/>
+        <p:nvPr/>
+      </p:nvGrpSpPr>
+      <p:grpSpPr>
+        <a:xfrm>
+          <a:off x="0" y="0"/>
+          <a:ext cx="0" cy="0"/>
+          <a:chOff x="0" y="0"/>
+          <a:chExt cx="0" cy="0"/>
+        </a:xfrm>
+      </p:grpSpPr>
+      <p:sp>
+        <p:nvSpPr>
+          <p:cNvPr id="2" name="Slide Image Placeholder 1"/>
+          <p:cNvSpPr>
+            <a:spLocks noGrp="1"/>
+          </p:cNvSpPr>
+          <p:nvPr>
+            <p:ph type="sldImg" idx="2"/>
+          </p:nvPr>
+        </p:nvSpPr>
+        <p:spPr/>
+      </p:sp>
+      <p:sp>
+        <p:nvSpPr>
+          <p:cNvPr id="3" name="Notes Placeholder 2"/>
+          <p:cNvSpPr>
+            <a:spLocks noGrp="1"/>
+          </p:cNvSpPr>
+          <p:nvPr>
+            <p:ph type="body" idx="3" sz="quarter"/>
+          </p:nvPr>
+        </p:nvSpPr>
+        <p:spPr/>
+        <p:txBody>
+          <a:bodyPr/>
+          <a:lstStyle/>
+          <a:p>
+            <a:r>
+              <a:t>Backup: numbers and workflow facts for the discussion.</a:t>
             </a:r>
           </a:p>
         </p:txBody>
@@ -1423,12 +1499,12 @@
           <a:lstStyle/>
           <a:p>
             <a:r>
-              <a:t>SPEAKER Katrin (P1) · ~20 s</a:t>
-            </a:r>
-          </a:p>
-          <a:p>
-            <a:r>
-              <a:t>One sentence: we split the model one layer per person, with Angel aligning the layers and Katrin owning the abstract view and final consistency. This sets up the reflection answer on “how we worked” later. (Photos can replace the initials if the team wants.)</a:t>
+              <a:t>SPEAKER Katrin (P1), about 20 seconds.</a:t>
+            </a:r>
+          </a:p>
+          <a:p>
+            <a:r>
+              <a:t>One sentence: we split the model one layer per person. Angel kept the layers consistent with each other, and Katrin owned the abstract view and the final quality pass. This sets up the reflection answer on how we worked. Photos can replace the initials if the team prefers.</a:t>
             </a:r>
           </a:p>
         </p:txBody>
@@ -1498,12 +1574,12 @@
           <a:lstStyle/>
           <a:p>
             <a:r>
-              <a:t>SPEAKER Katrin (P1) · ~45 s</a:t>
-            </a:r>
-          </a:p>
-          <a:p>
-            <a:r>
-              <a:t>Walk the service cards left to right: a guest books, arrives, pays, and the staff is briefed daily — all on the shared Hotel Management System. Point at the red box: our focus area F1 is reservation handling and check-in, the guest's pre-arrival-to-arrival journey. Hand over to Angel.</a:t>
+              <a:t>SPEAKER Katrin (P1), about 45 seconds.</a:t>
+            </a:r>
+          </a:p>
+          <a:p>
+            <a:r>
+              <a:t>Walk the four services: a guest books, arrives and checks in, pays, and every morning the staff aligns on one shared picture. All of it runs on the Hotel Management System. Point at the red box: our focus area F1 covers reservation handling and check-in, the guest journey from booking to arrival. Payment touches it too. Hand over to Angel.</a:t>
             </a:r>
           </a:p>
         </p:txBody>
@@ -1573,12 +1649,12 @@
           <a:lstStyle/>
           <a:p>
             <a:r>
-              <a:t>SPEAKER Angel (P2) · ~90 s</a:t>
-            </a:r>
-          </a:p>
-          <a:p>
-            <a:r>
-              <a:t>Say explicitly: “Don't try to read this — it's the map.” CLICK 1: the three layer bands — business (yellow), application (blue), technology (green). CLICK 2: the key stakeholders — the Guest at the top left, the Receptionist who runs check-in. CLICK 3: everything converges on the Hotel Management System, hosted on the AWS Cloud Server — the technology backbone. Main services along the top: reservation, check-in/out, briefing, room access. Hand to Soyeong.</a:t>
+              <a:t>SPEAKER Angel (P2), about 90 seconds.</a:t>
+            </a:r>
+          </a:p>
+          <a:p>
+            <a:r>
+              <a:t>Say it explicitly: "Don't try to read this. It's the map." CLICK 1: the three layer bands, business in yellow, application in blue, technology in green. CLICK 2: the key stakeholders, the Guest at the top left and the Receptionist who runs check-in. CLICK 3: everything converges on the Hotel Management System, hosted on the AWS Cloud Server. That server is the technology backbone. Name the main services along the top: reservation, check-in and check-out, daily briefing, room access. Hand over to Soyeong.</a:t>
             </a:r>
           </a:p>
         </p:txBody>
@@ -1648,12 +1724,12 @@
           <a:lstStyle/>
           <a:p>
             <a:r>
-              <a:t>SPEAKER Soyeong (P3) · ~45 s</a:t>
-            </a:r>
-          </a:p>
-          <a:p>
-            <a:r>
-              <a:t>Same map, now with the F1 slice boxed in red: the chain from Handle Reservation to Conduct Check-In/Out, the services above them, and the application/technology support below. “We'll zoom into this in three steps: business, application, technology.”</a:t>
+              <a:t>SPEAKER Soyeong (P3), about 45 seconds.</a:t>
+            </a:r>
+          </a:p>
+          <a:p>
+            <a:r>
+              <a:t>Same map, now with the F1 slice boxed in red: the chain from Handle Reservation to Conduct Check-In/Out, the services above them, and the application and technology support below. "We'll zoom into this in three steps: business, application, technology."</a:t>
             </a:r>
           </a:p>
         </p:txBody>
@@ -1723,12 +1799,12 @@
           <a:lstStyle/>
           <a:p>
             <a:r>
-              <a:t>SPEAKER Soyeong (P3) · ~75 s</a:t>
-            </a:r>
-          </a:p>
-          <a:p>
-            <a:r>
-              <a:t>CLICK 1: the Guest triggers everything — website or external booking platform. CLICK 2: walk the chain: Submit Reservation Request → Verify Room Availability → Calculate Total Price → Confirm and Allocate Room → Process Payment → Submit Special Request → Add Reservation to Arrival Schedule. CLICK 3: payment realises the Payment business service, delivered by the External Payment Service. CLICK 4: every step reads or writes a business object — Reservation, Room Availability, Pricing, Open Costs, Special Request, Arrival Schedule.</a:t>
+              <a:t>SPEAKER Soyeong (P3), about 75 seconds.</a:t>
+            </a:r>
+          </a:p>
+          <a:p>
+            <a:r>
+              <a:t>CLICK 1: the Guest triggers everything, through the website or an external booking platform. CLICK 2: walk the chain: Submit Reservation Request, Verify Room Availability, Calculate Total Price, Confirm and Allocate Room, Process Payment, Submit Special Request, Add Reservation to Arrival Schedule. CLICK 3: payment is its own business service, delivered by the External Payment Service. CLICK 4: every step reads or writes a business object, from Reservation to Arrival Schedule.</a:t>
             </a:r>
           </a:p>
         </p:txBody>
@@ -1798,12 +1874,12 @@
           <a:lstStyle/>
           <a:p>
             <a:r>
-              <a:t>SPEAKER Soyeong → Fiona (P3/P4) · ~75 s</a:t>
-            </a:r>
-          </a:p>
-          <a:p>
-            <a:r>
-              <a:t>CLICK 1: the Receptionist is assigned to Conduct Check-In/Out. CLICK 2: three steps — Identify Reservation, Verify Guest Identity, Issue and Configure Key Card. CLICK 3: together they realise the Check-In/Out Service. CLICK 4: any open costs settle through the Payment service, backed by the external provider. Handover line: “so much for the people — now the systems underneath”, Fiona takes over.</a:t>
+              <a:t>SPEAKER Soyeong, then Fiona (P3/P4), about 75 seconds.</a:t>
+            </a:r>
+          </a:p>
+          <a:p>
+            <a:r>
+              <a:t>CLICK 1: the Receptionist is assigned to the whole Conduct Check-In/Out process. CLICK 2: three steps: Identify Reservation, Verify Guest Identity, Issue and Configure Key Card. CLICK 3: together they realize the Check-In/Out Service the guest experiences. CLICK 4: open costs settle through the Payment service, backed by the external provider. Handover line: "So much for the people. Now the systems underneath." Fiona takes over.</a:t>
             </a:r>
           </a:p>
         </p:txBody>
@@ -1873,12 +1949,12 @@
           <a:lstStyle/>
           <a:p>
             <a:r>
-              <a:t>SPEAKER Fiona (P4) · ~90 s</a:t>
-            </a:r>
-          </a:p>
-          <a:p>
-            <a:r>
-              <a:t>CLICK 1: the HMS is the central component — its functions are modelled explicitly: Check Room Availability, Calculate Pricing, Reserve Room, Issue Key Card. CLICK 2: those functions are exposed upward as application services (Reservation Management, Check-In, Key Verification) — each serves a business process from the previous slides. CLICK 3: application events chain the flow: Reservation Request Received → Availability Confirmed → Reservation Approved → Payment Confirmed → Check In Completed. CLICK 4: pick ONE realization example and explain the pattern: the Reservation data object is the digital record that realises the Reservation business object — same pattern for guest profile, pricing and room status.</a:t>
+              <a:t>SPEAKER Fiona (P4), about 90 seconds.</a:t>
+            </a:r>
+          </a:p>
+          <a:p>
+            <a:r>
+              <a:t>CLICK 1: the HMS is the central component. Its functions are modeled explicitly: Check Room Availability, Calculate Pricing, Reserve Room, Issue Key Card. CLICK 2: those functions are exposed upward as application services like Reservation Management, Check-In and Key Verification. Each one serves a business process from the previous slides. CLICK 3: application events chain the flow: Reservation Request Received, Availability Confirmed, Reservation Approved, Payment Confirmed, Check In Completed. CLICK 4: pick one realization example and explain the pattern: the Reservation data object is the digital record behind the Reservation business object. Guest profile, pricing and room status follow the same pattern.</a:t>
             </a:r>
           </a:p>
         </p:txBody>
@@ -1948,12 +2024,12 @@
           <a:lstStyle/>
           <a:p>
             <a:r>
-              <a:t>SPEAKER Demir (P5) · ~90 s</a:t>
-            </a:r>
-          </a:p>
-          <a:p>
-            <a:r>
-              <a:t>CLICK 1: the guest taps the key card — the Door Card Reader detects it. CLICK 2: the Grant Room Access function chain runs: Detect Card → Read Access Rights → Verify Authorization → Unlock Door → Activate Room Circuit. CLICK 3: the Door System Software reads the Access Rights artifact and writes the Access Log. CLICK 4: communication is explicit — the RFID path to the card, hotel Wi-Fi and Internet to the AWS-hosted HMS. CLICK 5: end the story: “this is how a reservation made online becomes a door that opens.”</a:t>
+              <a:t>SPEAKER Demir (P5), about 90 seconds.</a:t>
+            </a:r>
+          </a:p>
+          <a:p>
+            <a:r>
+              <a:t>CLICK 1: the guest taps the key card and the Door Card Reader detects it. CLICK 2: the Grant Room Access chain runs: Detect Card, Read Access Rights, Verify Authorization, Unlock Door, Activate Room Circuit. CLICK 3: the Door System Software reads the Access Rights artifact and writes the Access Log. CLICK 4: communication is modeled explicitly: the RFID path to the card, hotel Wi-Fi and Internet up to the AWS-hosted HMS. CLICK 5: close the loop: "This is how a reservation made online becomes a door that opens."</a:t>
             </a:r>
           </a:p>
         </p:txBody>
@@ -12806,7 +12882,7 @@
           <a:lstStyle/>
           <a:p>
             <a:r>
-              <a:t>ArchiHotel — Reservation Handling &amp; Check-In</a:t>
+              <a:t>ArchiHotel: Reservation Handling &amp; Check-In</a:t>
             </a:r>
           </a:p>
         </p:txBody>
@@ -12827,17 +12903,17 @@
           <a:lstStyle/>
           <a:p>
             <a:r>
-              <a:t>Team C2F1G4 — Katrin Schwab · Soyeong Jeong · Fiona Aurelia · Angel Choi · Demir Eroglu</a:t>
-            </a:r>
-          </a:p>
-          <a:p>
-            <a:r>
-              <a:t>Technical University of Munich — School of Computation, Information and Technology</a:t>
-            </a:r>
-          </a:p>
-          <a:p>
-            <a:r>
-              <a:t>Enterprise Architecture Management and Reference Models — Case Study Final Presentation</a:t>
+              <a:t>Team C2F1G4: Katrin Schwab · Soyeong Jeong · Fiona Aurelia · Angel Choi · Demir Eroglu</a:t>
+            </a:r>
+          </a:p>
+          <a:p>
+            <a:r>
+              <a:t>Technical University of Munich, School of Computation, Information and Technology</a:t>
+            </a:r>
+          </a:p>
+          <a:p>
+            <a:r>
+              <a:t>EAM and Reference Models, Case Study Final Presentation</a:t>
             </a:r>
           </a:p>
           <a:p>
@@ -12847,6 +12923,76 @@
           </a:p>
         </p:txBody>
       </p:sp>
+      <p:sp>
+        <p:nvSpPr>
+          <p:cNvPr id="4" name="Rectangle 3"/>
+          <p:cNvSpPr/>
+          <p:nvPr/>
+        </p:nvSpPr>
+        <p:spPr>
+          <a:xfrm>
+            <a:off x="1673352" y="2886075"/>
+            <a:ext cx="5797296" cy="1908810"/>
+          </a:xfrm>
+          <a:prstGeom prst="rect">
+            <a:avLst/>
+          </a:prstGeom>
+          <a:solidFill>
+            <a:srgbClr val="FFFFFF"/>
+          </a:solidFill>
+          <a:ln w="6350">
+            <a:solidFill>
+              <a:srgbClr val="D0D8DF"/>
+            </a:solidFill>
+          </a:ln>
+          <a:effectLst/>
+        </p:spPr>
+        <p:style>
+          <a:lnRef idx="1">
+            <a:schemeClr val="accent1"/>
+          </a:lnRef>
+          <a:fillRef idx="3">
+            <a:schemeClr val="accent1"/>
+          </a:fillRef>
+          <a:effectRef idx="2">
+            <a:schemeClr val="accent1"/>
+          </a:effectRef>
+          <a:fontRef idx="minor">
+            <a:schemeClr val="lt1"/>
+          </a:fontRef>
+        </p:style>
+        <p:txBody>
+          <a:bodyPr rtlCol="0" anchor="ctr"/>
+          <a:lstStyle/>
+          <a:p>
+            <a:pPr algn="ctr"/>
+          </a:p>
+        </p:txBody>
+      </p:sp>
+      <p:pic>
+        <p:nvPicPr>
+          <p:cNvPr id="5" name="Picture 4" descr="archihotel_hero.png"/>
+          <p:cNvPicPr>
+            <a:picLocks noChangeAspect="1"/>
+          </p:cNvPicPr>
+          <p:nvPr/>
+        </p:nvPicPr>
+        <p:blipFill>
+          <a:blip r:embed="rId2"/>
+          <a:stretch>
+            <a:fillRect/>
+          </a:stretch>
+        </p:blipFill>
+        <p:spPr>
+          <a:xfrm>
+            <a:off x="1691640" y="2904363"/>
+            <a:ext cx="5760720" cy="1872234"/>
+          </a:xfrm>
+          <a:prstGeom prst="rect">
+            <a:avLst/>
+          </a:prstGeom>
+        </p:spPr>
+      </p:pic>
     </p:spTree>
   </p:cSld>
   <p:clrMapOvr>
@@ -12898,7 +13044,7 @@
           <a:lstStyle/>
           <a:p>
             <a:r>
-              <a:t>Reflection — Value &amp; Limitations</a:t>
+              <a:t>Reflection: Value &amp; Limitations</a:t>
             </a:r>
           </a:p>
         </p:txBody>
@@ -12928,8 +13074,8 @@
         </p:nvSpPr>
         <p:spPr>
           <a:xfrm>
-            <a:off x="411480" y="1508760"/>
-            <a:ext cx="4069080" cy="3108960"/>
+            <a:off x="411480" y="1554480"/>
+            <a:ext cx="4069080" cy="3017520"/>
           </a:xfrm>
           <a:prstGeom prst="roundRect">
             <a:avLst>
@@ -12976,8 +13122,8 @@
         </p:nvSpPr>
         <p:spPr>
           <a:xfrm>
-            <a:off x="411480" y="1508760"/>
-            <a:ext cx="4069080" cy="329184"/>
+            <a:off x="411480" y="1554480"/>
+            <a:ext cx="4069080" cy="365760"/>
           </a:xfrm>
           <a:prstGeom prst="roundRect">
             <a:avLst>
@@ -13012,12 +13158,12 @@
           <a:p>
             <a:pPr algn="ctr"/>
             <a:r>
-              <a:rPr b="1" sz="1300">
+              <a:rPr b="1" sz="1600">
                 <a:solidFill>
                   <a:srgbClr val="FFFFFF"/>
                 </a:solidFill>
               </a:rPr>
-              <a:t>Value of the EA model</a:t>
+              <a:t>Value</a:t>
             </a:r>
           </a:p>
         </p:txBody>
@@ -13030,8 +13176,8 @@
         </p:nvSpPr>
         <p:spPr>
           <a:xfrm>
-            <a:off x="484632" y="1892807"/>
-            <a:ext cx="3922776" cy="2651760"/>
+            <a:off x="502920" y="1975104"/>
+            <a:ext cx="3886200" cy="2523744"/>
           </a:xfrm>
           <a:prstGeom prst="rect">
             <a:avLst/>
@@ -13046,46 +13192,46 @@
           <a:p>
             <a:pPr>
               <a:spcAft>
-                <a:spcPts val="300"/>
+                <a:spcPts val="600"/>
               </a:spcAft>
             </a:pPr>
             <a:r>
-              <a:rPr sz="1150">
+              <a:rPr sz="1600">
                 <a:solidFill>
                   <a:srgbClr val="20252A"/>
                 </a:solidFill>
               </a:rPr>
-              <a:t>Transparency across 5+ cooperating systems — one shared picture instead of tribal knowledge</a:t>
+              <a:t>One shared picture of five cooperating systems</a:t>
             </a:r>
           </a:p>
           <a:p>
             <a:pPr>
               <a:spcAft>
-                <a:spcPts val="300"/>
+                <a:spcPts val="600"/>
               </a:spcAft>
             </a:pPr>
             <a:r>
-              <a:rPr sz="1150">
+              <a:rPr sz="1600">
                 <a:solidFill>
                   <a:srgbClr val="20252A"/>
                 </a:solidFill>
               </a:rPr>
-              <a:t>Impact analysis becomes concrete: “what breaks if the HMS is down?” — trace the serving arrows</a:t>
+              <a:t>Impact analysis: what breaks if the HMS is down?</a:t>
             </a:r>
           </a:p>
           <a:p>
             <a:pPr>
               <a:spcAft>
-                <a:spcPts val="300"/>
+                <a:spcPts val="600"/>
               </a:spcAft>
             </a:pPr>
             <a:r>
-              <a:rPr sz="1150">
+              <a:rPr sz="1600">
                 <a:solidFill>
                   <a:srgbClr val="20252A"/>
                 </a:solidFill>
               </a:rPr>
-              <a:t>Onboarding: a new receptionist or developer sees where their work sits in the whole</a:t>
+              <a:t>Faster onboarding for new staff and developers</a:t>
             </a:r>
           </a:p>
         </p:txBody>
@@ -13098,8 +13244,8 @@
         </p:nvSpPr>
         <p:spPr>
           <a:xfrm>
-            <a:off x="4663440" y="1508760"/>
-            <a:ext cx="4069080" cy="3108960"/>
+            <a:off x="4663440" y="1554480"/>
+            <a:ext cx="4069080" cy="3017520"/>
           </a:xfrm>
           <a:prstGeom prst="roundRect">
             <a:avLst>
@@ -13146,8 +13292,8 @@
         </p:nvSpPr>
         <p:spPr>
           <a:xfrm>
-            <a:off x="4663440" y="1508760"/>
-            <a:ext cx="4069080" cy="329184"/>
+            <a:off x="4663440" y="1554480"/>
+            <a:ext cx="4069080" cy="365760"/>
           </a:xfrm>
           <a:prstGeom prst="roundRect">
             <a:avLst>
@@ -13182,7 +13328,7 @@
           <a:p>
             <a:pPr algn="ctr"/>
             <a:r>
-              <a:rPr b="1" sz="1300">
+              <a:rPr b="1" sz="1600">
                 <a:solidFill>
                   <a:srgbClr val="FFFFFF"/>
                 </a:solidFill>
@@ -13200,8 +13346,8 @@
         </p:nvSpPr>
         <p:spPr>
           <a:xfrm>
-            <a:off x="4736592" y="1892807"/>
-            <a:ext cx="3922776" cy="2651760"/>
+            <a:off x="4754879" y="1975104"/>
+            <a:ext cx="3886200" cy="2523744"/>
           </a:xfrm>
           <a:prstGeom prst="rect">
             <a:avLst/>
@@ -13216,46 +13362,46 @@
           <a:p>
             <a:pPr>
               <a:spcAft>
-                <a:spcPts val="300"/>
+                <a:spcPts val="600"/>
               </a:spcAft>
             </a:pPr>
             <a:r>
-              <a:rPr sz="1150">
+              <a:rPr sz="1600">
                 <a:solidFill>
                   <a:srgbClr val="20252A"/>
                 </a:solidFill>
               </a:rPr>
-              <a:t>A point-in-time snapshot — no processes for keeping it current (governance)</a:t>
+              <a:t>A snapshot, with no process to keep it current</a:t>
             </a:r>
           </a:p>
           <a:p>
             <a:pPr>
               <a:spcAft>
-                <a:spcPts val="300"/>
+                <a:spcPts val="600"/>
               </a:spcAft>
             </a:pPr>
             <a:r>
-              <a:rPr sz="1150">
+              <a:rPr sz="1600">
                 <a:solidFill>
                   <a:srgbClr val="20252A"/>
                 </a:solidFill>
               </a:rPr>
-              <a:t>No quantities or SLAs: one AWS box says nothing about capacity or failover</a:t>
+              <a:t>No quantities, no SLAs, no capacity answers</a:t>
             </a:r>
           </a:p>
           <a:p>
             <a:pPr>
               <a:spcAft>
-                <a:spcPts val="300"/>
+                <a:spcPts val="600"/>
               </a:spcAft>
             </a:pPr>
             <a:r>
-              <a:rPr sz="1150">
+              <a:rPr sz="1600">
                 <a:solidFill>
                   <a:srgbClr val="20252A"/>
                 </a:solidFill>
               </a:rPr>
-              <a:t>Every abstraction choice hides detail — In-Room Equipment collapses many devices</a:t>
+              <a:t>Abstraction hides detail by design</a:t>
             </a:r>
           </a:p>
         </p:txBody>
@@ -13288,7 +13434,7 @@
                   <a:srgbClr val="606060"/>
                 </a:solidFill>
               </a:rPr>
-              <a:t>Schwab · Jeong · Aurelia · Choi · Eroglu — EAM Case Study ArchiHotel · C2F1G4</a:t>
+              <a:t>EAM Case Study ArchiHotel · Group C2F1G4</a:t>
             </a:r>
           </a:p>
         </p:txBody>
@@ -13378,7 +13524,7 @@
           <a:lstStyle/>
           <a:p>
             <a:r>
-              <a:t>Reflection — Missing Information &amp; Challenges</a:t>
+              <a:t>Reflection: Missing Information &amp; Challenges</a:t>
             </a:r>
           </a:p>
         </p:txBody>
@@ -13408,8 +13554,8 @@
         </p:nvSpPr>
         <p:spPr>
           <a:xfrm>
-            <a:off x="411480" y="1508760"/>
-            <a:ext cx="4069080" cy="3108960"/>
+            <a:off x="411480" y="1554480"/>
+            <a:ext cx="4069080" cy="3017520"/>
           </a:xfrm>
           <a:prstGeom prst="roundRect">
             <a:avLst>
@@ -13456,8 +13602,8 @@
         </p:nvSpPr>
         <p:spPr>
           <a:xfrm>
-            <a:off x="411480" y="1508760"/>
-            <a:ext cx="4069080" cy="329184"/>
+            <a:off x="411480" y="1554480"/>
+            <a:ext cx="4069080" cy="365760"/>
           </a:xfrm>
           <a:prstGeom prst="roundRect">
             <a:avLst>
@@ -13492,7 +13638,7 @@
           <a:p>
             <a:pPr algn="ctr"/>
             <a:r>
-              <a:rPr b="1" sz="1300">
+              <a:rPr b="1" sz="1600">
                 <a:solidFill>
                   <a:srgbClr val="FFFFFF"/>
                 </a:solidFill>
@@ -13510,8 +13656,8 @@
         </p:nvSpPr>
         <p:spPr>
           <a:xfrm>
-            <a:off x="484632" y="1892807"/>
-            <a:ext cx="3922776" cy="2651760"/>
+            <a:off x="502920" y="1975104"/>
+            <a:ext cx="3886200" cy="2523744"/>
           </a:xfrm>
           <a:prstGeom prst="rect">
             <a:avLst/>
@@ -13526,46 +13672,46 @@
           <a:p>
             <a:pPr>
               <a:spcAft>
-                <a:spcPts val="300"/>
+                <a:spcPts val="600"/>
               </a:spcAft>
             </a:pPr>
             <a:r>
-              <a:rPr sz="1150">
+              <a:rPr sz="1600">
                 <a:solidFill>
                   <a:srgbClr val="20252A"/>
                 </a:solidFill>
               </a:rPr>
-              <a:t>No infrastructure specs for the reservation side — hosting had to stay abstract</a:t>
+              <a:t>No infrastructure specs for the reservation side</a:t>
             </a:r>
           </a:p>
           <a:p>
             <a:pPr>
               <a:spcAft>
-                <a:spcPts val="300"/>
+                <a:spcPts val="600"/>
               </a:spcAft>
             </a:pPr>
             <a:r>
-              <a:rPr sz="1150">
+              <a:rPr sz="1600">
                 <a:solidFill>
                   <a:srgbClr val="20252A"/>
                 </a:solidFill>
               </a:rPr>
-              <a:t>Interfaces to external booking platforms are underspecified</a:t>
+              <a:t>Interfaces to external booking platforms unclear</a:t>
             </a:r>
           </a:p>
           <a:p>
             <a:pPr>
               <a:spcAft>
-                <a:spcPts val="300"/>
+                <a:spcPts val="600"/>
               </a:spcAft>
             </a:pPr>
             <a:r>
-              <a:rPr sz="1150">
+              <a:rPr sz="1600">
                 <a:solidFill>
                   <a:srgbClr val="20252A"/>
                 </a:solidFill>
               </a:rPr>
-              <a:t>No failure or volume data — capacity questions can't be answered from the model</a:t>
+              <a:t>No failure or volume data</a:t>
             </a:r>
           </a:p>
         </p:txBody>
@@ -13578,8 +13724,8 @@
         </p:nvSpPr>
         <p:spPr>
           <a:xfrm>
-            <a:off x="4663440" y="1508760"/>
-            <a:ext cx="4069080" cy="3108960"/>
+            <a:off x="4663440" y="1554480"/>
+            <a:ext cx="4069080" cy="3017520"/>
           </a:xfrm>
           <a:prstGeom prst="roundRect">
             <a:avLst>
@@ -13626,8 +13772,8 @@
         </p:nvSpPr>
         <p:spPr>
           <a:xfrm>
-            <a:off x="4663440" y="1508760"/>
-            <a:ext cx="4069080" cy="329184"/>
+            <a:off x="4663440" y="1554480"/>
+            <a:ext cx="4069080" cy="365760"/>
           </a:xfrm>
           <a:prstGeom prst="roundRect">
             <a:avLst>
@@ -13662,7 +13808,7 @@
           <a:p>
             <a:pPr algn="ctr"/>
             <a:r>
-              <a:rPr b="1" sz="1300">
+              <a:rPr b="1" sz="1600">
                 <a:solidFill>
                   <a:srgbClr val="FFFFFF"/>
                 </a:solidFill>
@@ -13680,8 +13826,8 @@
         </p:nvSpPr>
         <p:spPr>
           <a:xfrm>
-            <a:off x="4736592" y="1892807"/>
-            <a:ext cx="3922776" cy="2651760"/>
+            <a:off x="4754879" y="1975104"/>
+            <a:ext cx="3886200" cy="2523744"/>
           </a:xfrm>
           <a:prstGeom prst="rect">
             <a:avLst/>
@@ -13696,46 +13842,46 @@
           <a:p>
             <a:pPr>
               <a:spcAft>
-                <a:spcPts val="300"/>
+                <a:spcPts val="600"/>
               </a:spcAft>
             </a:pPr>
             <a:r>
-              <a:rPr sz="1150">
+              <a:rPr sz="1600">
                 <a:solidFill>
                   <a:srgbClr val="20252A"/>
                 </a:solidFill>
               </a:rPr>
-              <a:t>Choosing the abstraction level — when is a box one system or five?</a:t>
+              <a:t>Finding the right abstraction level</a:t>
             </a:r>
           </a:p>
           <a:p>
             <a:pPr>
               <a:spcAft>
-                <a:spcPts val="300"/>
+                <a:spcPts val="600"/>
               </a:spcAft>
             </a:pPr>
             <a:r>
-              <a:rPr sz="1150">
+              <a:rPr sz="1600">
                 <a:solidFill>
                   <a:srgbClr val="20252A"/>
                 </a:solidFill>
               </a:rPr>
-              <a:t>Keeping abstract and detailed views consistent while both evolved</a:t>
+              <a:t>Keeping the abstract and detailed views consistent</a:t>
             </a:r>
           </a:p>
           <a:p>
             <a:pPr>
               <a:spcAft>
-                <a:spcPts val="300"/>
+                <a:spcPts val="600"/>
               </a:spcAft>
             </a:pPr>
             <a:r>
-              <a:rPr sz="1150">
+              <a:rPr sz="1600">
                 <a:solidFill>
                   <a:srgbClr val="20252A"/>
                 </a:solidFill>
               </a:rPr>
-              <a:t>Parallel modelling with coArchi: merge conflicts and duplicate elements — we merged 11 duplicates late</a:t>
+              <a:t>Merge conflicts and duplicates from modeling in parallel</a:t>
             </a:r>
           </a:p>
         </p:txBody>
@@ -13768,7 +13914,7 @@
                   <a:srgbClr val="606060"/>
                 </a:solidFill>
               </a:rPr>
-              <a:t>Schwab · Jeong · Aurelia · Choi · Eroglu — EAM Case Study ArchiHotel · C2F1G4</a:t>
+              <a:t>EAM Case Study ArchiHotel · Group C2F1G4</a:t>
             </a:r>
           </a:p>
         </p:txBody>
@@ -13827,7 +13973,28 @@
       <p:grpSpPr/>
       <p:sp>
         <p:nvSpPr>
-          <p:cNvPr id="2" name="Title 1"/>
+          <p:cNvPr id="3" name="Text Placeholder 2"/>
+          <p:cNvSpPr>
+            <a:spLocks noGrp="1"/>
+          </p:cNvSpPr>
+          <p:nvPr>
+            <p:ph type="body" idx="13" sz="quarter"/>
+          </p:nvPr>
+        </p:nvSpPr>
+        <p:spPr/>
+        <p:txBody>
+          <a:bodyPr/>
+          <a:lstStyle/>
+          <a:p>
+            <a:r>
+              <a:t>Thank you! Questions?</a:t>
+            </a:r>
+          </a:p>
+        </p:txBody>
+      </p:sp>
+      <p:sp>
+        <p:nvSpPr>
+          <p:cNvPr id="4" name="Title 3"/>
           <p:cNvSpPr>
             <a:spLocks noGrp="1"/>
           </p:cNvSpPr>
@@ -13841,7 +14008,259 @@
           <a:lstStyle/>
           <a:p>
             <a:r>
-              <a:t>Backup</a:t>
+              <a:t>Summary</a:t>
+            </a:r>
+          </a:p>
+        </p:txBody>
+      </p:sp>
+      <p:sp>
+        <p:nvSpPr>
+          <p:cNvPr id="5" name="Text Placeholder 4"/>
+          <p:cNvSpPr>
+            <a:spLocks noGrp="1"/>
+          </p:cNvSpPr>
+          <p:nvPr>
+            <p:ph type="body" idx="14" sz="quarter"/>
+          </p:nvPr>
+        </p:nvSpPr>
+        <p:spPr/>
+        <p:txBody>
+          <a:bodyPr/>
+          <a:lstStyle/>
+          <a:p/>
+        </p:txBody>
+      </p:sp>
+      <p:sp>
+        <p:nvSpPr>
+          <p:cNvPr id="6" name="TextBox 5"/>
+          <p:cNvSpPr txBox="1"/>
+          <p:nvPr/>
+        </p:nvSpPr>
+        <p:spPr>
+          <a:xfrm>
+            <a:off x="411480" y="1691640"/>
+            <a:ext cx="4480560" cy="3017520"/>
+          </a:xfrm>
+          <a:prstGeom prst="rect">
+            <a:avLst/>
+          </a:prstGeom>
+          <a:noFill/>
+        </p:spPr>
+        <p:txBody>
+          <a:bodyPr wrap="square">
+            <a:spAutoFit/>
+          </a:bodyPr>
+          <a:lstStyle/>
+          <a:p>
+            <a:pPr algn="l">
+              <a:spcAft>
+                <a:spcPts val="1000"/>
+              </a:spcAft>
+            </a:pPr>
+            <a:r>
+              <a:rPr sz="1700">
+                <a:solidFill>
+                  <a:srgbClr val="20252A"/>
+                </a:solidFill>
+              </a:rPr>
+              <a:t>F1 modeled across all three layers</a:t>
+            </a:r>
+          </a:p>
+          <a:p>
+            <a:pPr algn="l">
+              <a:spcAft>
+                <a:spcPts val="1000"/>
+              </a:spcAft>
+            </a:pPr>
+            <a:r>
+              <a:rPr sz="1700">
+                <a:solidFill>
+                  <a:srgbClr val="20252A"/>
+                </a:solidFill>
+              </a:rPr>
+              <a:t>Everything converges on the HMS</a:t>
+            </a:r>
+          </a:p>
+          <a:p>
+            <a:pPr algn="l">
+              <a:spcAft>
+                <a:spcPts val="1000"/>
+              </a:spcAft>
+            </a:pPr>
+            <a:r>
+              <a:rPr sz="1700">
+                <a:solidFill>
+                  <a:srgbClr val="20252A"/>
+                </a:solidFill>
+              </a:rPr>
+              <a:t>The map first, then one story per layer</a:t>
+            </a:r>
+          </a:p>
+          <a:p>
+            <a:pPr algn="l">
+              <a:spcAft>
+                <a:spcPts val="1000"/>
+              </a:spcAft>
+            </a:pPr>
+            <a:r>
+              <a:rPr sz="1700">
+                <a:solidFill>
+                  <a:srgbClr val="20252A"/>
+                </a:solidFill>
+              </a:rPr>
+              <a:t>Value: transparency and impact analysis</a:t>
+            </a:r>
+          </a:p>
+          <a:p>
+            <a:pPr algn="l">
+              <a:spcAft>
+                <a:spcPts val="1000"/>
+              </a:spcAft>
+            </a:pPr>
+            <a:r>
+              <a:rPr sz="1700">
+                <a:solidFill>
+                  <a:srgbClr val="20252A"/>
+                </a:solidFill>
+              </a:rPr>
+              <a:t>Limits: a snapshot, no quantities</a:t>
+            </a:r>
+          </a:p>
+        </p:txBody>
+      </p:sp>
+      <p:sp>
+        <p:nvSpPr>
+          <p:cNvPr id="7" name="Rectangle 6"/>
+          <p:cNvSpPr/>
+          <p:nvPr/>
+        </p:nvSpPr>
+        <p:spPr>
+          <a:xfrm>
+            <a:off x="5102352" y="1861468"/>
+            <a:ext cx="3785615" cy="2586422"/>
+          </a:xfrm>
+          <a:prstGeom prst="rect">
+            <a:avLst/>
+          </a:prstGeom>
+          <a:solidFill>
+            <a:srgbClr val="FFFFFF"/>
+          </a:solidFill>
+          <a:ln w="6350">
+            <a:solidFill>
+              <a:srgbClr val="D0D8DF"/>
+            </a:solidFill>
+          </a:ln>
+          <a:effectLst/>
+        </p:spPr>
+        <p:style>
+          <a:lnRef idx="1">
+            <a:schemeClr val="accent1"/>
+          </a:lnRef>
+          <a:fillRef idx="3">
+            <a:schemeClr val="accent1"/>
+          </a:fillRef>
+          <a:effectRef idx="2">
+            <a:schemeClr val="accent1"/>
+          </a:effectRef>
+          <a:fontRef idx="minor">
+            <a:schemeClr val="lt1"/>
+          </a:fontRef>
+        </p:style>
+        <p:txBody>
+          <a:bodyPr rtlCol="0" anchor="ctr"/>
+          <a:lstStyle/>
+          <a:p>
+            <a:pPr algn="ctr"/>
+          </a:p>
+        </p:txBody>
+      </p:sp>
+      <p:pic>
+        <p:nvPicPr>
+          <p:cNvPr id="8" name="Picture 7" descr="abstract_full.png"/>
+          <p:cNvPicPr>
+            <a:picLocks noChangeAspect="1"/>
+          </p:cNvPicPr>
+          <p:nvPr/>
+        </p:nvPicPr>
+        <p:blipFill>
+          <a:blip r:embed="rId2"/>
+          <a:stretch>
+            <a:fillRect/>
+          </a:stretch>
+        </p:blipFill>
+        <p:spPr>
+          <a:xfrm>
+            <a:off x="5120640" y="1879756"/>
+            <a:ext cx="3749039" cy="2549846"/>
+          </a:xfrm>
+          <a:prstGeom prst="rect">
+            <a:avLst/>
+          </a:prstGeom>
+        </p:spPr>
+      </p:pic>
+      <p:sp>
+        <p:nvSpPr>
+          <p:cNvPr id="9" name="TextBox 8"/>
+          <p:cNvSpPr txBox="1"/>
+          <p:nvPr/>
+        </p:nvSpPr>
+        <p:spPr>
+          <a:xfrm>
+            <a:off x="310896" y="4864608"/>
+            <a:ext cx="6949440" cy="237744"/>
+          </a:xfrm>
+          <a:prstGeom prst="rect">
+            <a:avLst/>
+          </a:prstGeom>
+          <a:noFill/>
+        </p:spPr>
+        <p:txBody>
+          <a:bodyPr wrap="none">
+            <a:spAutoFit/>
+          </a:bodyPr>
+          <a:lstStyle/>
+          <a:p>
+            <a:r>
+              <a:rPr sz="800">
+                <a:solidFill>
+                  <a:srgbClr val="606060"/>
+                </a:solidFill>
+              </a:rPr>
+              <a:t>EAM Case Study ArchiHotel · Group C2F1G4</a:t>
+            </a:r>
+          </a:p>
+        </p:txBody>
+      </p:sp>
+      <p:sp>
+        <p:nvSpPr>
+          <p:cNvPr id="10" name="TextBox 9"/>
+          <p:cNvSpPr txBox="1"/>
+          <p:nvPr/>
+        </p:nvSpPr>
+        <p:spPr>
+          <a:xfrm>
+            <a:off x="8321040" y="4864608"/>
+            <a:ext cx="548640" cy="237744"/>
+          </a:xfrm>
+          <a:prstGeom prst="rect">
+            <a:avLst/>
+          </a:prstGeom>
+          <a:noFill/>
+        </p:spPr>
+        <p:txBody>
+          <a:bodyPr wrap="none">
+            <a:spAutoFit/>
+          </a:bodyPr>
+          <a:lstStyle/>
+          <a:p>
+            <a:pPr algn="r"/>
+            <a:r>
+              <a:rPr sz="800">
+                <a:solidFill>
+                  <a:srgbClr val="606060"/>
+                </a:solidFill>
+              </a:rPr>
+              <a:t>12</a:t>
             </a:r>
           </a:p>
         </p:txBody>
@@ -13866,28 +14285,7 @@
       <p:grpSpPr/>
       <p:sp>
         <p:nvSpPr>
-          <p:cNvPr id="3" name="Text Placeholder 2"/>
-          <p:cNvSpPr>
-            <a:spLocks noGrp="1"/>
-          </p:cNvSpPr>
-          <p:nvPr>
-            <p:ph type="body" idx="13" sz="quarter"/>
-          </p:nvPr>
-        </p:nvSpPr>
-        <p:spPr/>
-        <p:txBody>
-          <a:bodyPr/>
-          <a:lstStyle/>
-          <a:p>
-            <a:r>
-              <a:t>Detailed — F1 Reservation &amp; Check-In · 86 objects · 160 connections on the view</a:t>
-            </a:r>
-          </a:p>
-        </p:txBody>
-      </p:sp>
-      <p:sp>
-        <p:nvSpPr>
-          <p:cNvPr id="4" name="Title 3"/>
+          <p:cNvPr id="2" name="Title 1"/>
           <p:cNvSpPr>
             <a:spLocks noGrp="1"/>
           </p:cNvSpPr>
@@ -13901,229 +14299,7 @@
           <a:lstStyle/>
           <a:p>
             <a:r>
-              <a:t>Backup — Detailed View, Complete</a:t>
-            </a:r>
-          </a:p>
-        </p:txBody>
-      </p:sp>
-      <p:sp>
-        <p:nvSpPr>
-          <p:cNvPr id="5" name="Text Placeholder 4"/>
-          <p:cNvSpPr>
-            <a:spLocks noGrp="1"/>
-          </p:cNvSpPr>
-          <p:nvPr>
-            <p:ph type="body" idx="14" sz="quarter"/>
-          </p:nvPr>
-        </p:nvSpPr>
-        <p:spPr/>
-        <p:txBody>
-          <a:bodyPr/>
-          <a:lstStyle/>
-          <a:p/>
-        </p:txBody>
-      </p:sp>
-      <p:sp>
-        <p:nvSpPr>
-          <p:cNvPr id="6" name="Rectangle 5"/>
-          <p:cNvSpPr/>
-          <p:nvPr/>
-        </p:nvSpPr>
-        <p:spPr>
-          <a:xfrm>
-            <a:off x="3312768" y="1463040"/>
-            <a:ext cx="2701342" cy="3438144"/>
-          </a:xfrm>
-          <a:prstGeom prst="rect">
-            <a:avLst/>
-          </a:prstGeom>
-          <a:solidFill>
-            <a:srgbClr val="FFFFFF"/>
-          </a:solidFill>
-          <a:ln w="6350">
-            <a:solidFill>
-              <a:srgbClr val="D0D8DF"/>
-            </a:solidFill>
-          </a:ln>
-          <a:effectLst/>
-        </p:spPr>
-        <p:style>
-          <a:lnRef idx="1">
-            <a:schemeClr val="accent1"/>
-          </a:lnRef>
-          <a:fillRef idx="3">
-            <a:schemeClr val="accent1"/>
-          </a:fillRef>
-          <a:effectRef idx="2">
-            <a:schemeClr val="accent1"/>
-          </a:effectRef>
-          <a:fontRef idx="minor">
-            <a:schemeClr val="lt1"/>
-          </a:fontRef>
-        </p:style>
-        <p:txBody>
-          <a:bodyPr rtlCol="0" anchor="ctr"/>
-          <a:lstStyle/>
-          <a:p>
-            <a:pPr algn="ctr"/>
-          </a:p>
-        </p:txBody>
-      </p:sp>
-      <p:pic>
-        <p:nvPicPr>
-          <p:cNvPr id="7" name="Picture 6" descr="detailed_full.png"/>
-          <p:cNvPicPr>
-            <a:picLocks noChangeAspect="1"/>
-          </p:cNvPicPr>
-          <p:nvPr/>
-        </p:nvPicPr>
-        <p:blipFill>
-          <a:blip r:embed="rId2"/>
-          <a:stretch>
-            <a:fillRect/>
-          </a:stretch>
-        </p:blipFill>
-        <p:spPr>
-          <a:xfrm>
-            <a:off x="3331056" y="1481328"/>
-            <a:ext cx="2664766" cy="3401568"/>
-          </a:xfrm>
-          <a:prstGeom prst="rect">
-            <a:avLst/>
-          </a:prstGeom>
-        </p:spPr>
-      </p:pic>
-      <p:sp>
-        <p:nvSpPr>
-          <p:cNvPr id="8" name="TextBox 7"/>
-          <p:cNvSpPr txBox="1"/>
-          <p:nvPr/>
-        </p:nvSpPr>
-        <p:spPr>
-          <a:xfrm>
-            <a:off x="320040" y="1645920"/>
-            <a:ext cx="1920240" cy="2743200"/>
-          </a:xfrm>
-          <a:prstGeom prst="rect">
-            <a:avLst/>
-          </a:prstGeom>
-          <a:noFill/>
-        </p:spPr>
-        <p:txBody>
-          <a:bodyPr wrap="square">
-            <a:spAutoFit/>
-          </a:bodyPr>
-          <a:lstStyle/>
-          <a:p>
-            <a:pPr algn="l">
-              <a:spcAft>
-                <a:spcPts val="400"/>
-              </a:spcAft>
-            </a:pPr>
-            <a:r>
-              <a:rPr sz="1050">
-                <a:solidFill>
-                  <a:srgbClr val="20252A"/>
-                </a:solidFill>
-              </a:rPr>
-              <a:t>All three layers in one view.</a:t>
-            </a:r>
-          </a:p>
-          <a:p>
-            <a:pPr algn="l">
-              <a:spcAft>
-                <a:spcPts val="400"/>
-              </a:spcAft>
-            </a:pPr>
-            <a:r>
-              <a:rPr sz="1050">
-                <a:solidFill>
-                  <a:srgbClr val="20252A"/>
-                </a:solidFill>
-              </a:rPr>
-              <a:t>Business on top, application centre, technology at the bottom.</a:t>
-            </a:r>
-          </a:p>
-          <a:p>
-            <a:pPr algn="l">
-              <a:spcAft>
-                <a:spcPts val="400"/>
-              </a:spcAft>
-            </a:pPr>
-            <a:r>
-              <a:rPr sz="1050">
-                <a:solidFill>
-                  <a:srgbClr val="20252A"/>
-                </a:solidFill>
-              </a:rPr>
-              <a:t>PDF export in the submission shows it at full resolution.</a:t>
-            </a:r>
-          </a:p>
-        </p:txBody>
-      </p:sp>
-      <p:sp>
-        <p:nvSpPr>
-          <p:cNvPr id="9" name="TextBox 8"/>
-          <p:cNvSpPr txBox="1"/>
-          <p:nvPr/>
-        </p:nvSpPr>
-        <p:spPr>
-          <a:xfrm>
-            <a:off x="310896" y="4864608"/>
-            <a:ext cx="6949440" cy="237744"/>
-          </a:xfrm>
-          <a:prstGeom prst="rect">
-            <a:avLst/>
-          </a:prstGeom>
-          <a:noFill/>
-        </p:spPr>
-        <p:txBody>
-          <a:bodyPr wrap="none">
-            <a:spAutoFit/>
-          </a:bodyPr>
-          <a:lstStyle/>
-          <a:p>
-            <a:r>
-              <a:rPr sz="800">
-                <a:solidFill>
-                  <a:srgbClr val="606060"/>
-                </a:solidFill>
-              </a:rPr>
-              <a:t>Schwab · Jeong · Aurelia · Choi · Eroglu — EAM Case Study ArchiHotel · C2F1G4</a:t>
-            </a:r>
-          </a:p>
-        </p:txBody>
-      </p:sp>
-      <p:sp>
-        <p:nvSpPr>
-          <p:cNvPr id="10" name="TextBox 9"/>
-          <p:cNvSpPr txBox="1"/>
-          <p:nvPr/>
-        </p:nvSpPr>
-        <p:spPr>
-          <a:xfrm>
-            <a:off x="8321040" y="4864608"/>
-            <a:ext cx="548640" cy="237744"/>
-          </a:xfrm>
-          <a:prstGeom prst="rect">
-            <a:avLst/>
-          </a:prstGeom>
-          <a:noFill/>
-        </p:spPr>
-        <p:txBody>
-          <a:bodyPr wrap="none">
-            <a:spAutoFit/>
-          </a:bodyPr>
-          <a:lstStyle/>
-          <a:p>
-            <a:pPr algn="r"/>
-            <a:r>
-              <a:rPr sz="800">
-                <a:solidFill>
-                  <a:srgbClr val="606060"/>
-                </a:solidFill>
-              </a:rPr>
-              <a:t>13</a:t>
+              <a:t>Backup</a:t>
             </a:r>
           </a:p>
         </p:txBody>
@@ -14162,7 +14338,7 @@
           <a:lstStyle/>
           <a:p>
             <a:r>
-              <a:t>Abstract — ArchiHotel EA · all services · 72 objects · 98 connections on the view</a:t>
+              <a:t>Detailed · F1 Reservation &amp; Check-In · 86 objects · 160 connections</a:t>
             </a:r>
           </a:p>
         </p:txBody>
@@ -14183,7 +14359,7 @@
           <a:lstStyle/>
           <a:p>
             <a:r>
-              <a:t>Backup — Abstract View, Complete</a:t>
+              <a:t>Backup: Detailed View, Complete</a:t>
             </a:r>
           </a:p>
         </p:txBody>
@@ -14213,8 +14389,8 @@
         </p:nvSpPr>
         <p:spPr>
           <a:xfrm>
-            <a:off x="2053048" y="1463040"/>
-            <a:ext cx="5037903" cy="3438144"/>
+            <a:off x="3312768" y="1463040"/>
+            <a:ext cx="2701342" cy="3438144"/>
           </a:xfrm>
           <a:prstGeom prst="rect">
             <a:avLst/>
@@ -14253,7 +14429,7 @@
       </p:sp>
       <p:pic>
         <p:nvPicPr>
-          <p:cNvPr id="7" name="Picture 6" descr="abstract_full.png"/>
+          <p:cNvPr id="7" name="Picture 6" descr="detailed_full.png"/>
           <p:cNvPicPr>
             <a:picLocks noChangeAspect="1"/>
           </p:cNvPicPr>
@@ -14267,8 +14443,8 @@
         </p:blipFill>
         <p:spPr>
           <a:xfrm>
-            <a:off x="2071336" y="1481328"/>
-            <a:ext cx="5001327" cy="3401568"/>
+            <a:off x="3331056" y="1481328"/>
+            <a:ext cx="2664766" cy="3401568"/>
           </a:xfrm>
           <a:prstGeom prst="rect">
             <a:avLst/>
@@ -14303,7 +14479,7 @@
                   <a:srgbClr val="606060"/>
                 </a:solidFill>
               </a:rPr>
-              <a:t>Schwab · Jeong · Aurelia · Choi · Eroglu — EAM Case Study ArchiHotel · C2F1G4</a:t>
+              <a:t>EAM Case Study ArchiHotel · Group C2F1G4</a:t>
             </a:r>
           </a:p>
         </p:txBody>
@@ -14374,7 +14550,11 @@
         <p:txBody>
           <a:bodyPr/>
           <a:lstStyle/>
-          <a:p/>
+          <a:p>
+            <a:r>
+              <a:t>Abstract · ArchiHotel EA · 72 objects · 98 connections</a:t>
+            </a:r>
+          </a:p>
         </p:txBody>
       </p:sp>
       <p:sp>
@@ -14393,7 +14573,7 @@
           <a:lstStyle/>
           <a:p>
             <a:r>
-              <a:t>Backup — Model Facts</a:t>
+              <a:t>Backup: Abstract View, Complete</a:t>
             </a:r>
           </a:p>
         </p:txBody>
@@ -14417,14 +14597,224 @@
       </p:sp>
       <p:sp>
         <p:nvSpPr>
+          <p:cNvPr id="6" name="Rectangle 5"/>
+          <p:cNvSpPr/>
+          <p:nvPr/>
+        </p:nvSpPr>
+        <p:spPr>
+          <a:xfrm>
+            <a:off x="2053048" y="1463040"/>
+            <a:ext cx="5037903" cy="3438144"/>
+          </a:xfrm>
+          <a:prstGeom prst="rect">
+            <a:avLst/>
+          </a:prstGeom>
+          <a:solidFill>
+            <a:srgbClr val="FFFFFF"/>
+          </a:solidFill>
+          <a:ln w="6350">
+            <a:solidFill>
+              <a:srgbClr val="D0D8DF"/>
+            </a:solidFill>
+          </a:ln>
+          <a:effectLst/>
+        </p:spPr>
+        <p:style>
+          <a:lnRef idx="1">
+            <a:schemeClr val="accent1"/>
+          </a:lnRef>
+          <a:fillRef idx="3">
+            <a:schemeClr val="accent1"/>
+          </a:fillRef>
+          <a:effectRef idx="2">
+            <a:schemeClr val="accent1"/>
+          </a:effectRef>
+          <a:fontRef idx="minor">
+            <a:schemeClr val="lt1"/>
+          </a:fontRef>
+        </p:style>
+        <p:txBody>
+          <a:bodyPr rtlCol="0" anchor="ctr"/>
+          <a:lstStyle/>
+          <a:p>
+            <a:pPr algn="ctr"/>
+          </a:p>
+        </p:txBody>
+      </p:sp>
+      <p:pic>
+        <p:nvPicPr>
+          <p:cNvPr id="7" name="Picture 6" descr="abstract_full.png"/>
+          <p:cNvPicPr>
+            <a:picLocks noChangeAspect="1"/>
+          </p:cNvPicPr>
+          <p:nvPr/>
+        </p:nvPicPr>
+        <p:blipFill>
+          <a:blip r:embed="rId2"/>
+          <a:stretch>
+            <a:fillRect/>
+          </a:stretch>
+        </p:blipFill>
+        <p:spPr>
+          <a:xfrm>
+            <a:off x="2071336" y="1481328"/>
+            <a:ext cx="5001327" cy="3401568"/>
+          </a:xfrm>
+          <a:prstGeom prst="rect">
+            <a:avLst/>
+          </a:prstGeom>
+        </p:spPr>
+      </p:pic>
+      <p:sp>
+        <p:nvSpPr>
+          <p:cNvPr id="8" name="TextBox 7"/>
+          <p:cNvSpPr txBox="1"/>
+          <p:nvPr/>
+        </p:nvSpPr>
+        <p:spPr>
+          <a:xfrm>
+            <a:off x="310896" y="4864608"/>
+            <a:ext cx="6949440" cy="237744"/>
+          </a:xfrm>
+          <a:prstGeom prst="rect">
+            <a:avLst/>
+          </a:prstGeom>
+          <a:noFill/>
+        </p:spPr>
+        <p:txBody>
+          <a:bodyPr wrap="none">
+            <a:spAutoFit/>
+          </a:bodyPr>
+          <a:lstStyle/>
+          <a:p>
+            <a:r>
+              <a:rPr sz="800">
+                <a:solidFill>
+                  <a:srgbClr val="606060"/>
+                </a:solidFill>
+              </a:rPr>
+              <a:t>EAM Case Study ArchiHotel · Group C2F1G4</a:t>
+            </a:r>
+          </a:p>
+        </p:txBody>
+      </p:sp>
+      <p:sp>
+        <p:nvSpPr>
+          <p:cNvPr id="9" name="TextBox 8"/>
+          <p:cNvSpPr txBox="1"/>
+          <p:nvPr/>
+        </p:nvSpPr>
+        <p:spPr>
+          <a:xfrm>
+            <a:off x="8321040" y="4864608"/>
+            <a:ext cx="548640" cy="237744"/>
+          </a:xfrm>
+          <a:prstGeom prst="rect">
+            <a:avLst/>
+          </a:prstGeom>
+          <a:noFill/>
+        </p:spPr>
+        <p:txBody>
+          <a:bodyPr wrap="none">
+            <a:spAutoFit/>
+          </a:bodyPr>
+          <a:lstStyle/>
+          <a:p>
+            <a:pPr algn="r"/>
+            <a:r>
+              <a:rPr sz="800">
+                <a:solidFill>
+                  <a:srgbClr val="606060"/>
+                </a:solidFill>
+              </a:rPr>
+              <a:t>15</a:t>
+            </a:r>
+          </a:p>
+        </p:txBody>
+      </p:sp>
+    </p:spTree>
+  </p:cSld>
+  <p:clrMapOvr>
+    <a:masterClrMapping/>
+  </p:clrMapOvr>
+</p:sld>
+</file>
+
+<file path=ppt/slides/slide16.xml><?xml version="1.0" encoding="utf-8"?>
+<p:sld xmlns:a="http://schemas.openxmlformats.org/drawingml/2006/main" xmlns:p="http://schemas.openxmlformats.org/presentationml/2006/main" xmlns:r="http://schemas.openxmlformats.org/officeDocument/2006/relationships">
+  <p:cSld>
+    <p:spTree>
+      <p:nvGrpSpPr>
+        <p:cNvPr id="1" name=""/>
+        <p:cNvGrpSpPr/>
+        <p:nvPr/>
+      </p:nvGrpSpPr>
+      <p:grpSpPr/>
+      <p:sp>
+        <p:nvSpPr>
+          <p:cNvPr id="3" name="Text Placeholder 2"/>
+          <p:cNvSpPr>
+            <a:spLocks noGrp="1"/>
+          </p:cNvSpPr>
+          <p:nvPr>
+            <p:ph type="body" idx="13" sz="quarter"/>
+          </p:nvPr>
+        </p:nvSpPr>
+        <p:spPr/>
+        <p:txBody>
+          <a:bodyPr/>
+          <a:lstStyle/>
+          <a:p/>
+        </p:txBody>
+      </p:sp>
+      <p:sp>
+        <p:nvSpPr>
+          <p:cNvPr id="4" name="Title 3"/>
+          <p:cNvSpPr>
+            <a:spLocks noGrp="1"/>
+          </p:cNvSpPr>
+          <p:nvPr>
+            <p:ph type="title"/>
+          </p:nvPr>
+        </p:nvSpPr>
+        <p:spPr/>
+        <p:txBody>
+          <a:bodyPr/>
+          <a:lstStyle/>
+          <a:p>
+            <a:r>
+              <a:t>Backup: Model Facts</a:t>
+            </a:r>
+          </a:p>
+        </p:txBody>
+      </p:sp>
+      <p:sp>
+        <p:nvSpPr>
+          <p:cNvPr id="5" name="Text Placeholder 4"/>
+          <p:cNvSpPr>
+            <a:spLocks noGrp="1"/>
+          </p:cNvSpPr>
+          <p:nvPr>
+            <p:ph type="body" idx="14" sz="quarter"/>
+          </p:nvPr>
+        </p:nvSpPr>
+        <p:spPr/>
+        <p:txBody>
+          <a:bodyPr/>
+          <a:lstStyle/>
+          <a:p/>
+        </p:txBody>
+      </p:sp>
+      <p:sp>
+        <p:nvSpPr>
           <p:cNvPr id="6" name="Rounded Rectangle 5"/>
           <p:cNvSpPr/>
           <p:nvPr/>
         </p:nvSpPr>
         <p:spPr>
           <a:xfrm>
-            <a:off x="411480" y="1508760"/>
-            <a:ext cx="4069080" cy="3108960"/>
+            <a:off x="411480" y="1554480"/>
+            <a:ext cx="4069080" cy="3017520"/>
           </a:xfrm>
           <a:prstGeom prst="roundRect">
             <a:avLst>
@@ -14471,8 +14861,8 @@
         </p:nvSpPr>
         <p:spPr>
           <a:xfrm>
-            <a:off x="411480" y="1508760"/>
-            <a:ext cx="4069080" cy="329184"/>
+            <a:off x="411480" y="1554480"/>
+            <a:ext cx="4069080" cy="365760"/>
           </a:xfrm>
           <a:prstGeom prst="roundRect">
             <a:avLst>
@@ -14507,7 +14897,7 @@
           <a:p>
             <a:pPr algn="ctr"/>
             <a:r>
-              <a:rPr b="1" sz="1300">
+              <a:rPr b="1" sz="1500">
                 <a:solidFill>
                   <a:srgbClr val="FFFFFF"/>
                 </a:solidFill>
@@ -14525,8 +14915,8 @@
         </p:nvSpPr>
         <p:spPr>
           <a:xfrm>
-            <a:off x="484632" y="1892807"/>
-            <a:ext cx="3922776" cy="2651760"/>
+            <a:off x="502920" y="1975104"/>
+            <a:ext cx="3886200" cy="2523744"/>
           </a:xfrm>
           <a:prstGeom prst="rect">
             <a:avLst/>
@@ -14541,61 +14931,61 @@
           <a:p>
             <a:pPr>
               <a:spcAft>
-                <a:spcPts val="300"/>
+                <a:spcPts val="600"/>
               </a:spcAft>
             </a:pPr>
             <a:r>
-              <a:rPr sz="1150">
+              <a:rPr sz="1400">
                 <a:solidFill>
                   <a:srgbClr val="20252A"/>
                 </a:solidFill>
               </a:rPr>
-              <a:t>One .archimate file · two views (as required)</a:t>
+              <a:t>One .archimate file with two views</a:t>
             </a:r>
           </a:p>
           <a:p>
             <a:pPr>
               <a:spcAft>
-                <a:spcPts val="300"/>
+                <a:spcPts val="600"/>
               </a:spcAft>
             </a:pPr>
             <a:r>
-              <a:rPr sz="1150">
+              <a:rPr sz="1400">
                 <a:solidFill>
                   <a:srgbClr val="20252A"/>
                 </a:solidFill>
               </a:rPr>
-              <a:t>Abstract view: 72 objects, 98 connections</a:t>
+              <a:t>Abstract: 72 objects, 98 connections</a:t>
             </a:r>
           </a:p>
           <a:p>
             <a:pPr>
               <a:spcAft>
-                <a:spcPts val="300"/>
+                <a:spcPts val="600"/>
               </a:spcAft>
             </a:pPr>
             <a:r>
-              <a:rPr sz="1150">
+              <a:rPr sz="1400">
                 <a:solidFill>
                   <a:srgbClr val="20252A"/>
                 </a:solidFill>
               </a:rPr>
-              <a:t>Detailed F1 view: 86 objects, 160 connections</a:t>
+              <a:t>Detailed F1: 86 objects, 160 connections</a:t>
             </a:r>
           </a:p>
           <a:p>
             <a:pPr>
               <a:spcAft>
-                <a:spcPts val="300"/>
+                <a:spcPts val="600"/>
               </a:spcAft>
             </a:pPr>
             <a:r>
-              <a:rPr sz="1150">
+              <a:rPr sz="1400">
                 <a:solidFill>
                   <a:srgbClr val="20252A"/>
                 </a:solidFill>
               </a:rPr>
-              <a:t>Naming: noun phrases for structure, verb phrases for behaviour</a:t>
+              <a:t>Nouns for structure, verbs for behavior</a:t>
             </a:r>
           </a:p>
         </p:txBody>
@@ -14608,8 +14998,8 @@
         </p:nvSpPr>
         <p:spPr>
           <a:xfrm>
-            <a:off x="4663440" y="1508760"/>
-            <a:ext cx="4069080" cy="3108960"/>
+            <a:off x="4663440" y="1554480"/>
+            <a:ext cx="4069080" cy="3017520"/>
           </a:xfrm>
           <a:prstGeom prst="roundRect">
             <a:avLst>
@@ -14656,8 +15046,8 @@
         </p:nvSpPr>
         <p:spPr>
           <a:xfrm>
-            <a:off x="4663440" y="1508760"/>
-            <a:ext cx="4069080" cy="329184"/>
+            <a:off x="4663440" y="1554480"/>
+            <a:ext cx="4069080" cy="365760"/>
           </a:xfrm>
           <a:prstGeom prst="roundRect">
             <a:avLst>
@@ -14692,7 +15082,7 @@
           <a:p>
             <a:pPr algn="ctr"/>
             <a:r>
-              <a:rPr b="1" sz="1300">
+              <a:rPr b="1" sz="1500">
                 <a:solidFill>
                   <a:srgbClr val="FFFFFF"/>
                 </a:solidFill>
@@ -14710,8 +15100,8 @@
         </p:nvSpPr>
         <p:spPr>
           <a:xfrm>
-            <a:off x="4736592" y="1892807"/>
-            <a:ext cx="3922776" cy="2651760"/>
+            <a:off x="4754879" y="1975104"/>
+            <a:ext cx="3886200" cy="2523744"/>
           </a:xfrm>
           <a:prstGeom prst="rect">
             <a:avLst/>
@@ -14726,46 +15116,46 @@
           <a:p>
             <a:pPr>
               <a:spcAft>
-                <a:spcPts val="300"/>
+                <a:spcPts val="600"/>
               </a:spcAft>
             </a:pPr>
             <a:r>
-              <a:rPr sz="1150">
+              <a:rPr sz="1400">
                 <a:solidFill>
                   <a:srgbClr val="20252A"/>
                 </a:solidFill>
               </a:rPr>
-              <a:t>Archi + coArchi plugin, shared GitHub repository</a:t>
+              <a:t>Archi with coArchi, shared GitHub repository</a:t>
             </a:r>
           </a:p>
           <a:p>
             <a:pPr>
               <a:spcAft>
-                <a:spcPts val="300"/>
+                <a:spcPts val="600"/>
               </a:spcAft>
             </a:pPr>
             <a:r>
-              <a:rPr sz="1150">
+              <a:rPr sz="1400">
                 <a:solidFill>
                   <a:srgbClr val="20252A"/>
                 </a:solidFill>
               </a:rPr>
-              <a:t>One layer per person, weekly alignment on the cross-layer relationships</a:t>
+              <a:t>One layer per person, regular alignment</a:t>
             </a:r>
           </a:p>
           <a:p>
             <a:pPr>
               <a:spcAft>
-                <a:spcPts val="300"/>
+                <a:spcPts val="600"/>
               </a:spcAft>
             </a:pPr>
             <a:r>
-              <a:rPr sz="1150">
+              <a:rPr sz="1400">
                 <a:solidFill>
                   <a:srgbClr val="20252A"/>
                 </a:solidFill>
               </a:rPr>
-              <a:t>Independent model audit before submission (fix PRs merged)</a:t>
+              <a:t>Independent model audit before submission</a:t>
             </a:r>
           </a:p>
         </p:txBody>
@@ -14798,7 +15188,7 @@
                   <a:srgbClr val="606060"/>
                 </a:solidFill>
               </a:rPr>
-              <a:t>Schwab · Jeong · Aurelia · Choi · Eroglu — EAM Case Study ArchiHotel · C2F1G4</a:t>
+              <a:t>EAM Case Study ArchiHotel · Group C2F1G4</a:t>
             </a:r>
           </a:p>
         </p:txBody>
@@ -14832,7 +15222,7 @@
                   <a:srgbClr val="606060"/>
                 </a:solidFill>
               </a:rPr>
-              <a:t>15</a:t>
+              <a:t>16</a:t>
             </a:r>
           </a:p>
         </p:txBody>
@@ -14871,7 +15261,7 @@
           <a:lstStyle/>
           <a:p>
             <a:r>
-              <a:t>One layer per person — merged into one model</a:t>
+              <a:t>One layer per person, merged into one model</a:t>
             </a:r>
           </a:p>
         </p:txBody>
@@ -14922,8 +15312,8 @@
         </p:nvSpPr>
         <p:spPr>
           <a:xfrm>
-            <a:off x="713231" y="1600200"/>
-            <a:ext cx="768096" cy="768096"/>
+            <a:off x="676655" y="1691640"/>
+            <a:ext cx="841248" cy="841248"/>
           </a:xfrm>
           <a:prstGeom prst="ellipse">
             <a:avLst/>
@@ -14956,7 +15346,7 @@
           <a:p>
             <a:pPr algn="ctr"/>
             <a:r>
-              <a:rPr sz="2200" b="1">
+              <a:rPr sz="2400" b="1">
                 <a:solidFill>
                   <a:srgbClr val="FFFFFF"/>
                 </a:solidFill>
@@ -14974,8 +15364,8 @@
         </p:nvSpPr>
         <p:spPr>
           <a:xfrm>
-            <a:off x="283463" y="2487168"/>
-            <a:ext cx="1627632" cy="1371600"/>
+            <a:off x="228599" y="2670048"/>
+            <a:ext cx="1737360" cy="1371600"/>
           </a:xfrm>
           <a:prstGeom prst="rect">
             <a:avLst/>
@@ -14994,7 +15384,7 @@
               </a:spcAft>
             </a:pPr>
             <a:r>
-              <a:rPr sz="1100" b="1">
+              <a:rPr sz="1250" b="1">
                 <a:solidFill>
                   <a:srgbClr val="20252A"/>
                 </a:solidFill>
@@ -15009,12 +15399,12 @@
               </a:spcAft>
             </a:pPr>
             <a:r>
-              <a:rPr sz="950">
+              <a:rPr sz="1150">
                 <a:solidFill>
                   <a:srgbClr val="606060"/>
                 </a:solidFill>
               </a:rPr>
-              <a:t>Abstract EA view · model QA &amp; integration</a:t>
+              <a:t>Abstract view &amp; QA</a:t>
             </a:r>
           </a:p>
         </p:txBody>
@@ -15027,8 +15417,8 @@
         </p:nvSpPr>
         <p:spPr>
           <a:xfrm>
-            <a:off x="2450591" y="1600200"/>
-            <a:ext cx="768096" cy="768096"/>
+            <a:off x="2414015" y="1691640"/>
+            <a:ext cx="841248" cy="841248"/>
           </a:xfrm>
           <a:prstGeom prst="ellipse">
             <a:avLst/>
@@ -15061,7 +15451,7 @@
           <a:p>
             <a:pPr algn="ctr"/>
             <a:r>
-              <a:rPr sz="2200" b="1">
+              <a:rPr sz="2400" b="1">
                 <a:solidFill>
                   <a:srgbClr val="FFFFFF"/>
                 </a:solidFill>
@@ -15079,8 +15469,8 @@
         </p:nvSpPr>
         <p:spPr>
           <a:xfrm>
-            <a:off x="2020823" y="2487168"/>
-            <a:ext cx="1627632" cy="1371600"/>
+            <a:off x="1965959" y="2670048"/>
+            <a:ext cx="1737360" cy="1371600"/>
           </a:xfrm>
           <a:prstGeom prst="rect">
             <a:avLst/>
@@ -15099,7 +15489,7 @@
               </a:spcAft>
             </a:pPr>
             <a:r>
-              <a:rPr sz="1100" b="1">
+              <a:rPr sz="1250" b="1">
                 <a:solidFill>
                   <a:srgbClr val="20252A"/>
                 </a:solidFill>
@@ -15114,12 +15504,12 @@
               </a:spcAft>
             </a:pPr>
             <a:r>
-              <a:rPr sz="950">
+              <a:rPr sz="1150">
                 <a:solidFill>
                   <a:srgbClr val="606060"/>
                 </a:solidFill>
               </a:rPr>
-              <a:t>Business layer — Reservation &amp; Check-In</a:t>
+              <a:t>Business layer</a:t>
             </a:r>
           </a:p>
         </p:txBody>
@@ -15132,8 +15522,8 @@
         </p:nvSpPr>
         <p:spPr>
           <a:xfrm>
-            <a:off x="4187951" y="1600200"/>
-            <a:ext cx="768096" cy="768096"/>
+            <a:off x="4151375" y="1691640"/>
+            <a:ext cx="841248" cy="841248"/>
           </a:xfrm>
           <a:prstGeom prst="ellipse">
             <a:avLst/>
@@ -15166,7 +15556,7 @@
           <a:p>
             <a:pPr algn="ctr"/>
             <a:r>
-              <a:rPr sz="2200" b="1">
+              <a:rPr sz="2400" b="1">
                 <a:solidFill>
                   <a:srgbClr val="FFFFFF"/>
                 </a:solidFill>
@@ -15184,8 +15574,8 @@
         </p:nvSpPr>
         <p:spPr>
           <a:xfrm>
-            <a:off x="3758183" y="2487168"/>
-            <a:ext cx="1627632" cy="1371600"/>
+            <a:off x="3703320" y="2670048"/>
+            <a:ext cx="1737360" cy="1371600"/>
           </a:xfrm>
           <a:prstGeom prst="rect">
             <a:avLst/>
@@ -15204,7 +15594,7 @@
               </a:spcAft>
             </a:pPr>
             <a:r>
-              <a:rPr sz="1100" b="1">
+              <a:rPr sz="1250" b="1">
                 <a:solidFill>
                   <a:srgbClr val="20252A"/>
                 </a:solidFill>
@@ -15219,12 +15609,12 @@
               </a:spcAft>
             </a:pPr>
             <a:r>
-              <a:rPr sz="950">
+              <a:rPr sz="1150">
                 <a:solidFill>
                   <a:srgbClr val="606060"/>
                 </a:solidFill>
               </a:rPr>
-              <a:t>Application layer — HMS internals</a:t>
+              <a:t>Application layer</a:t>
             </a:r>
           </a:p>
         </p:txBody>
@@ -15237,8 +15627,8 @@
         </p:nvSpPr>
         <p:spPr>
           <a:xfrm>
-            <a:off x="5925311" y="1600200"/>
-            <a:ext cx="768096" cy="768096"/>
+            <a:off x="5888735" y="1691640"/>
+            <a:ext cx="841248" cy="841248"/>
           </a:xfrm>
           <a:prstGeom prst="ellipse">
             <a:avLst/>
@@ -15271,7 +15661,7 @@
           <a:p>
             <a:pPr algn="ctr"/>
             <a:r>
-              <a:rPr sz="2200" b="1">
+              <a:rPr sz="2400" b="1">
                 <a:solidFill>
                   <a:srgbClr val="FFFFFF"/>
                 </a:solidFill>
@@ -15289,8 +15679,8 @@
         </p:nvSpPr>
         <p:spPr>
           <a:xfrm>
-            <a:off x="5495543" y="2487168"/>
-            <a:ext cx="1627632" cy="1371600"/>
+            <a:off x="5440679" y="2670048"/>
+            <a:ext cx="1737360" cy="1371600"/>
           </a:xfrm>
           <a:prstGeom prst="rect">
             <a:avLst/>
@@ -15309,7 +15699,7 @@
               </a:spcAft>
             </a:pPr>
             <a:r>
-              <a:rPr sz="1100" b="1">
+              <a:rPr sz="1250" b="1">
                 <a:solidFill>
                   <a:srgbClr val="20252A"/>
                 </a:solidFill>
@@ -15324,12 +15714,12 @@
               </a:spcAft>
             </a:pPr>
             <a:r>
-              <a:rPr sz="950">
+              <a:rPr sz="1150">
                 <a:solidFill>
                   <a:srgbClr val="606060"/>
                 </a:solidFill>
               </a:rPr>
-              <a:t>Cross-layer alignment &amp; consolidation</a:t>
+              <a:t>Layer alignment</a:t>
             </a:r>
           </a:p>
         </p:txBody>
@@ -15342,8 +15732,8 @@
         </p:nvSpPr>
         <p:spPr>
           <a:xfrm>
-            <a:off x="7662671" y="1600200"/>
-            <a:ext cx="768096" cy="768096"/>
+            <a:off x="7626095" y="1691640"/>
+            <a:ext cx="841248" cy="841248"/>
           </a:xfrm>
           <a:prstGeom prst="ellipse">
             <a:avLst/>
@@ -15376,7 +15766,7 @@
           <a:p>
             <a:pPr algn="ctr"/>
             <a:r>
-              <a:rPr sz="2200" b="1">
+              <a:rPr sz="2400" b="1">
                 <a:solidFill>
                   <a:srgbClr val="FFFFFF"/>
                 </a:solidFill>
@@ -15394,8 +15784,8 @@
         </p:nvSpPr>
         <p:spPr>
           <a:xfrm>
-            <a:off x="7232903" y="2487168"/>
-            <a:ext cx="1627632" cy="1371600"/>
+            <a:off x="7178040" y="2670048"/>
+            <a:ext cx="1737360" cy="1371600"/>
           </a:xfrm>
           <a:prstGeom prst="rect">
             <a:avLst/>
@@ -15414,7 +15804,7 @@
               </a:spcAft>
             </a:pPr>
             <a:r>
-              <a:rPr sz="1100" b="1">
+              <a:rPr sz="1250" b="1">
                 <a:solidFill>
                   <a:srgbClr val="20252A"/>
                 </a:solidFill>
@@ -15429,12 +15819,12 @@
               </a:spcAft>
             </a:pPr>
             <a:r>
-              <a:rPr sz="950">
+              <a:rPr sz="1150">
                 <a:solidFill>
                   <a:srgbClr val="606060"/>
                 </a:solidFill>
               </a:rPr>
-              <a:t>Technology layer — key-card stack</a:t>
+              <a:t>Technology layer</a:t>
             </a:r>
           </a:p>
         </p:txBody>
@@ -15467,7 +15857,7 @@
                   <a:srgbClr val="606060"/>
                 </a:solidFill>
               </a:rPr>
-              <a:t>Schwab · Jeong · Aurelia · Choi · Eroglu — EAM Case Study ArchiHotel · C2F1G4</a:t>
+              <a:t>EAM Case Study ArchiHotel · Group C2F1G4</a:t>
             </a:r>
           </a:p>
         </p:txBody>
@@ -15540,7 +15930,7 @@
           <a:lstStyle/>
           <a:p>
             <a:r>
-              <a:t>A luxury hotel where “luxury feels effortless” — run on one Hotel Management System</a:t>
+              <a:t>A luxury hotel that runs on one Hotel Management System</a:t>
             </a:r>
           </a:p>
         </p:txBody>
@@ -15591,8 +15981,8 @@
         </p:nvSpPr>
         <p:spPr>
           <a:xfrm>
-            <a:off x="502920" y="1874519"/>
-            <a:ext cx="2057400" cy="1783080"/>
+            <a:off x="502920" y="1645920"/>
+            <a:ext cx="3886200" cy="1298448"/>
           </a:xfrm>
           <a:prstGeom prst="roundRect">
             <a:avLst>
@@ -15639,8 +16029,8 @@
         </p:nvSpPr>
         <p:spPr>
           <a:xfrm>
-            <a:off x="502920" y="1874519"/>
-            <a:ext cx="2057400" cy="329184"/>
+            <a:off x="502920" y="1645920"/>
+            <a:ext cx="3886200" cy="365760"/>
           </a:xfrm>
           <a:prstGeom prst="roundRect">
             <a:avLst>
@@ -15675,7 +16065,7 @@
           <a:p>
             <a:pPr algn="ctr"/>
             <a:r>
-              <a:rPr b="1" sz="1150">
+              <a:rPr b="1" sz="1400">
                 <a:solidFill>
                   <a:srgbClr val="FFFFFF"/>
                 </a:solidFill>
@@ -15693,8 +16083,8 @@
         </p:nvSpPr>
         <p:spPr>
           <a:xfrm>
-            <a:off x="576072" y="2258568"/>
-            <a:ext cx="1911095" cy="1325880"/>
+            <a:off x="594360" y="2066544"/>
+            <a:ext cx="3703320" cy="804671"/>
           </a:xfrm>
           <a:prstGeom prst="rect">
             <a:avLst/>
@@ -15709,46 +16099,16 @@
           <a:p>
             <a:pPr>
               <a:spcAft>
-                <a:spcPts val="300"/>
+                <a:spcPts val="600"/>
               </a:spcAft>
             </a:pPr>
             <a:r>
-              <a:rPr sz="1050">
+              <a:rPr sz="1500">
                 <a:solidFill>
                   <a:srgbClr val="20252A"/>
                 </a:solidFill>
               </a:rPr>
-              <a:t>Website or external booking platforms</a:t>
-            </a:r>
-          </a:p>
-          <a:p>
-            <a:pPr>
-              <a:spcAft>
-                <a:spcPts val="300"/>
-              </a:spcAft>
-            </a:pPr>
-            <a:r>
-              <a:rPr sz="1050">
-                <a:solidFill>
-                  <a:srgbClr val="20252A"/>
-                </a:solidFill>
-              </a:rPr>
-              <a:t>Availability · pricing · confirmation</a:t>
-            </a:r>
-          </a:p>
-          <a:p>
-            <a:pPr>
-              <a:spcAft>
-                <a:spcPts val="300"/>
-              </a:spcAft>
-            </a:pPr>
-            <a:r>
-              <a:rPr sz="1050">
-                <a:solidFill>
-                  <a:srgbClr val="20252A"/>
-                </a:solidFill>
-              </a:rPr>
-              <a:t>Special requests before arrival</a:t>
+              <a:t>Website and external booking platforms</a:t>
             </a:r>
           </a:p>
         </p:txBody>
@@ -15761,8 +16121,8 @@
         </p:nvSpPr>
         <p:spPr>
           <a:xfrm>
-            <a:off x="2697480" y="1874519"/>
-            <a:ext cx="2057400" cy="1783080"/>
+            <a:off x="502920" y="3154680"/>
+            <a:ext cx="3886200" cy="1298448"/>
           </a:xfrm>
           <a:prstGeom prst="roundRect">
             <a:avLst>
@@ -15809,8 +16169,8 @@
         </p:nvSpPr>
         <p:spPr>
           <a:xfrm>
-            <a:off x="2697480" y="1874519"/>
-            <a:ext cx="2057400" cy="329184"/>
+            <a:off x="502920" y="3154680"/>
+            <a:ext cx="3886200" cy="365760"/>
           </a:xfrm>
           <a:prstGeom prst="roundRect">
             <a:avLst>
@@ -15845,7 +16205,7 @@
           <a:p>
             <a:pPr algn="ctr"/>
             <a:r>
-              <a:rPr b="1" sz="1150">
+              <a:rPr b="1" sz="1400">
                 <a:solidFill>
                   <a:srgbClr val="FFFFFF"/>
                 </a:solidFill>
@@ -15863,8 +16223,8 @@
         </p:nvSpPr>
         <p:spPr>
           <a:xfrm>
-            <a:off x="2770632" y="2258568"/>
-            <a:ext cx="1911095" cy="1325880"/>
+            <a:off x="594360" y="3575304"/>
+            <a:ext cx="3703320" cy="804671"/>
           </a:xfrm>
           <a:prstGeom prst="rect">
             <a:avLst/>
@@ -15879,46 +16239,16 @@
           <a:p>
             <a:pPr>
               <a:spcAft>
-                <a:spcPts val="300"/>
+                <a:spcPts val="600"/>
               </a:spcAft>
             </a:pPr>
             <a:r>
-              <a:rPr sz="1050">
+              <a:rPr sz="1500">
                 <a:solidFill>
                   <a:srgbClr val="20252A"/>
                 </a:solidFill>
               </a:rPr>
-              <a:t>Identify reservation, verify identity</a:t>
-            </a:r>
-          </a:p>
-          <a:p>
-            <a:pPr>
-              <a:spcAft>
-                <a:spcPts val="300"/>
-              </a:spcAft>
-            </a:pPr>
-            <a:r>
-              <a:rPr sz="1050">
-                <a:solidFill>
-                  <a:srgbClr val="20252A"/>
-                </a:solidFill>
-              </a:rPr>
-              <a:t>Key card issued &amp; configured</a:t>
-            </a:r>
-          </a:p>
-          <a:p>
-            <a:pPr>
-              <a:spcAft>
-                <a:spcPts val="300"/>
-              </a:spcAft>
-            </a:pPr>
-            <a:r>
-              <a:rPr sz="1050">
-                <a:solidFill>
-                  <a:srgbClr val="20252A"/>
-                </a:solidFill>
-              </a:rPr>
-              <a:t>Open costs settled at departure</a:t>
+              <a:t>Identity check, key card, open costs</a:t>
             </a:r>
           </a:p>
         </p:txBody>
@@ -15931,8 +16261,8 @@
         </p:nvSpPr>
         <p:spPr>
           <a:xfrm>
-            <a:off x="4892040" y="1874519"/>
-            <a:ext cx="2057400" cy="1783080"/>
+            <a:off x="4754880" y="1645920"/>
+            <a:ext cx="3886200" cy="1298448"/>
           </a:xfrm>
           <a:prstGeom prst="roundRect">
             <a:avLst>
@@ -15979,8 +16309,8 @@
         </p:nvSpPr>
         <p:spPr>
           <a:xfrm>
-            <a:off x="4892040" y="1874519"/>
-            <a:ext cx="2057400" cy="329184"/>
+            <a:off x="4754880" y="1645920"/>
+            <a:ext cx="3886200" cy="365760"/>
           </a:xfrm>
           <a:prstGeom prst="roundRect">
             <a:avLst>
@@ -16015,7 +16345,7 @@
           <a:p>
             <a:pPr algn="ctr"/>
             <a:r>
-              <a:rPr b="1" sz="1150">
+              <a:rPr b="1" sz="1400">
                 <a:solidFill>
                   <a:srgbClr val="FFFFFF"/>
                 </a:solidFill>
@@ -16033,8 +16363,8 @@
         </p:nvSpPr>
         <p:spPr>
           <a:xfrm>
-            <a:off x="4965192" y="2258568"/>
-            <a:ext cx="1911095" cy="1325880"/>
+            <a:off x="4846320" y="2066544"/>
+            <a:ext cx="3703320" cy="804671"/>
           </a:xfrm>
           <a:prstGeom prst="rect">
             <a:avLst/>
@@ -16049,11 +16379,11 @@
           <a:p>
             <a:pPr>
               <a:spcAft>
-                <a:spcPts val="300"/>
+                <a:spcPts val="600"/>
               </a:spcAft>
             </a:pPr>
             <a:r>
-              <a:rPr sz="1050">
+              <a:rPr sz="1500">
                 <a:solidFill>
                   <a:srgbClr val="20252A"/>
                 </a:solidFill>
@@ -16061,21 +16391,6 @@
               <a:t>External payment service provider</a:t>
             </a:r>
           </a:p>
-          <a:p>
-            <a:pPr>
-              <a:spcAft>
-                <a:spcPts val="300"/>
-              </a:spcAft>
-            </a:pPr>
-            <a:r>
-              <a:rPr sz="1050">
-                <a:solidFill>
-                  <a:srgbClr val="20252A"/>
-                </a:solidFill>
-              </a:rPr>
-              <a:t>Open costs tracked centrally in the HMS</a:t>
-            </a:r>
-          </a:p>
         </p:txBody>
       </p:sp>
       <p:sp>
@@ -16086,8 +16401,8 @@
         </p:nvSpPr>
         <p:spPr>
           <a:xfrm>
-            <a:off x="7086600" y="1874519"/>
-            <a:ext cx="2057400" cy="1783080"/>
+            <a:off x="4754880" y="3154680"/>
+            <a:ext cx="3886200" cy="1298448"/>
           </a:xfrm>
           <a:prstGeom prst="roundRect">
             <a:avLst>
@@ -16134,8 +16449,8 @@
         </p:nvSpPr>
         <p:spPr>
           <a:xfrm>
-            <a:off x="7086600" y="1874519"/>
-            <a:ext cx="2057400" cy="329184"/>
+            <a:off x="4754880" y="3154680"/>
+            <a:ext cx="3886200" cy="365760"/>
           </a:xfrm>
           <a:prstGeom prst="roundRect">
             <a:avLst>
@@ -16170,7 +16485,7 @@
           <a:p>
             <a:pPr algn="ctr"/>
             <a:r>
-              <a:rPr b="1" sz="1150">
+              <a:rPr b="1" sz="1400">
                 <a:solidFill>
                   <a:srgbClr val="FFFFFF"/>
                 </a:solidFill>
@@ -16188,8 +16503,8 @@
         </p:nvSpPr>
         <p:spPr>
           <a:xfrm>
-            <a:off x="7159752" y="2258568"/>
-            <a:ext cx="1911095" cy="1325880"/>
+            <a:off x="4846320" y="3575304"/>
+            <a:ext cx="3703320" cy="804671"/>
           </a:xfrm>
           <a:prstGeom prst="rect">
             <a:avLst/>
@@ -16204,31 +16519,16 @@
           <a:p>
             <a:pPr>
               <a:spcAft>
-                <a:spcPts val="300"/>
+                <a:spcPts val="600"/>
               </a:spcAft>
             </a:pPr>
             <a:r>
-              <a:rPr sz="1050">
+              <a:rPr sz="1500">
                 <a:solidFill>
                   <a:srgbClr val="20252A"/>
                 </a:solidFill>
               </a:rPr>
-              <a:t>Manager + heads align the day</a:t>
-            </a:r>
-          </a:p>
-          <a:p>
-            <a:pPr>
-              <a:spcAft>
-                <a:spcPts val="300"/>
-              </a:spcAft>
-            </a:pPr>
-            <a:r>
-              <a:rPr sz="1050">
-                <a:solidFill>
-                  <a:srgbClr val="20252A"/>
-                </a:solidFill>
-              </a:rPr>
-              <a:t>Staff Portal pushes updates to phones</a:t>
+              <a:t>One shared picture of the day on staff phones</a:t>
             </a:r>
           </a:p>
         </p:txBody>
@@ -16241,8 +16541,8 @@
         </p:nvSpPr>
         <p:spPr>
           <a:xfrm>
-            <a:off x="384048" y="1572768"/>
-            <a:ext cx="4526280" cy="2240280"/>
+            <a:off x="365760" y="1508760"/>
+            <a:ext cx="4160520" cy="3108960"/>
           </a:xfrm>
           <a:prstGeom prst="roundRect">
             <a:avLst>
@@ -16287,8 +16587,8 @@
         </p:nvSpPr>
         <p:spPr>
           <a:xfrm>
-            <a:off x="384048" y="3858768"/>
-            <a:ext cx="2377440" cy="274320"/>
+            <a:off x="365760" y="4645152"/>
+            <a:ext cx="2468880" cy="292608"/>
           </a:xfrm>
           <a:prstGeom prst="roundRect">
             <a:avLst>
@@ -16323,12 +16623,12 @@
           <a:p>
             <a:pPr algn="ctr"/>
             <a:r>
-              <a:rPr sz="1200" b="1">
+              <a:rPr sz="1300" b="1">
                 <a:solidFill>
                   <a:srgbClr val="FFFFFF"/>
                 </a:solidFill>
               </a:rPr>
-              <a:t>Our Focus Area — F1</a:t>
+              <a:t>Our Focus Area: F1</a:t>
             </a:r>
           </a:p>
         </p:txBody>
@@ -16336,44 +16636,6 @@
       <p:sp>
         <p:nvSpPr>
           <p:cNvPr id="20" name="TextBox 19"/>
-          <p:cNvSpPr txBox="1"/>
-          <p:nvPr/>
-        </p:nvSpPr>
-        <p:spPr>
-          <a:xfrm>
-            <a:off x="4892040" y="3913632"/>
-            <a:ext cx="4206240" cy="457200"/>
-          </a:xfrm>
-          <a:prstGeom prst="rect">
-            <a:avLst/>
-          </a:prstGeom>
-          <a:noFill/>
-        </p:spPr>
-        <p:txBody>
-          <a:bodyPr wrap="square">
-            <a:spAutoFit/>
-          </a:bodyPr>
-          <a:lstStyle/>
-          <a:p>
-            <a:pPr algn="l">
-              <a:spcAft>
-                <a:spcPts val="400"/>
-              </a:spcAft>
-            </a:pPr>
-            <a:r>
-              <a:rPr sz="1000">
-                <a:solidFill>
-                  <a:srgbClr val="606060"/>
-                </a:solidFill>
-              </a:rPr>
-              <a:t>Payment and briefing touch F1 — the guest journey crosses all of them.</a:t>
-            </a:r>
-          </a:p>
-        </p:txBody>
-      </p:sp>
-      <p:sp>
-        <p:nvSpPr>
-          <p:cNvPr id="21" name="TextBox 20"/>
           <p:cNvSpPr txBox="1"/>
           <p:nvPr/>
         </p:nvSpPr>
@@ -16399,14 +16661,14 @@
                   <a:srgbClr val="606060"/>
                 </a:solidFill>
               </a:rPr>
-              <a:t>Schwab · Jeong · Aurelia · Choi · Eroglu — EAM Case Study ArchiHotel · C2F1G4</a:t>
-            </a:r>
-          </a:p>
-        </p:txBody>
-      </p:sp>
-      <p:sp>
-        <p:nvSpPr>
-          <p:cNvPr id="22" name="TextBox 21"/>
+              <a:t>EAM Case Study ArchiHotel · Group C2F1G4</a:t>
+            </a:r>
+          </a:p>
+        </p:txBody>
+      </p:sp>
+      <p:sp>
+        <p:nvSpPr>
+          <p:cNvPr id="21" name="TextBox 20"/>
           <p:cNvSpPr txBox="1"/>
           <p:nvPr/>
         </p:nvSpPr>
@@ -16472,7 +16734,7 @@
           <a:lstStyle/>
           <a:p>
             <a:r>
-              <a:t>Don't read the boxes — watch the structure. 72 elements · 98 relationships on this view</a:t>
+              <a:t>72 elements, 98 relationships, three layers. Please don't read the boxes.</a:t>
             </a:r>
           </a:p>
         </p:txBody>
@@ -16493,7 +16755,7 @@
           <a:lstStyle/>
           <a:p>
             <a:r>
-              <a:t>The Abstract EA Model — the Map</a:t>
+              <a:t>The Abstract EA Model</a:t>
             </a:r>
           </a:p>
         </p:txBody>
@@ -16593,7 +16855,7 @@
         </p:nvSpPr>
         <p:spPr>
           <a:xfrm>
-            <a:off x="6446520" y="1627632"/>
+            <a:off x="6446520" y="1673352"/>
             <a:ext cx="146304" cy="146304"/>
           </a:xfrm>
           <a:prstGeom prst="ellipse">
@@ -16637,7 +16899,7 @@
         </p:nvSpPr>
         <p:spPr>
           <a:xfrm>
-            <a:off x="6656832" y="1545336"/>
+            <a:off x="6656832" y="1591056"/>
             <a:ext cx="2331720" cy="822960"/>
           </a:xfrm>
           <a:prstGeom prst="rect">
@@ -16657,7 +16919,7 @@
               </a:spcAft>
             </a:pPr>
             <a:r>
-              <a:rPr sz="1100" b="1">
+              <a:rPr sz="1500" b="1">
                 <a:solidFill>
                   <a:srgbClr val="20252A"/>
                 </a:solidFill>
@@ -16672,12 +16934,12 @@
               </a:spcAft>
             </a:pPr>
             <a:r>
-              <a:rPr sz="950">
+              <a:rPr sz="1200">
                 <a:solidFill>
                   <a:srgbClr val="606060"/>
                 </a:solidFill>
               </a:rPr>
-              <a:t>Business → Application → Technology</a:t>
+              <a:t>Business, application, technology</a:t>
             </a:r>
           </a:p>
         </p:txBody>
@@ -16690,7 +16952,7 @@
         </p:nvSpPr>
         <p:spPr>
           <a:xfrm>
-            <a:off x="6446520" y="2587751"/>
+            <a:off x="6446520" y="2633472"/>
             <a:ext cx="146304" cy="146304"/>
           </a:xfrm>
           <a:prstGeom prst="ellipse">
@@ -16734,7 +16996,7 @@
         </p:nvSpPr>
         <p:spPr>
           <a:xfrm>
-            <a:off x="6656832" y="2505456"/>
+            <a:off x="6656832" y="2551176"/>
             <a:ext cx="2331720" cy="822960"/>
           </a:xfrm>
           <a:prstGeom prst="rect">
@@ -16754,7 +17016,7 @@
               </a:spcAft>
             </a:pPr>
             <a:r>
-              <a:rPr sz="1100" b="1">
+              <a:rPr sz="1500" b="1">
                 <a:solidFill>
                   <a:srgbClr val="20252A"/>
                 </a:solidFill>
@@ -16769,7 +17031,7 @@
               </a:spcAft>
             </a:pPr>
             <a:r>
-              <a:rPr sz="950">
+              <a:rPr sz="1200">
                 <a:solidFill>
                   <a:srgbClr val="606060"/>
                 </a:solidFill>
@@ -16787,7 +17049,7 @@
         </p:nvSpPr>
         <p:spPr>
           <a:xfrm>
-            <a:off x="6446520" y="3547871"/>
+            <a:off x="6446520" y="3593592"/>
             <a:ext cx="146304" cy="146304"/>
           </a:xfrm>
           <a:prstGeom prst="ellipse">
@@ -16831,7 +17093,7 @@
         </p:nvSpPr>
         <p:spPr>
           <a:xfrm>
-            <a:off x="6656832" y="3465575"/>
+            <a:off x="6656832" y="3511296"/>
             <a:ext cx="2331720" cy="822960"/>
           </a:xfrm>
           <a:prstGeom prst="rect">
@@ -16851,7 +17113,7 @@
               </a:spcAft>
             </a:pPr>
             <a:r>
-              <a:rPr sz="1100" b="1">
+              <a:rPr sz="1500" b="1">
                 <a:solidFill>
                   <a:srgbClr val="20252A"/>
                 </a:solidFill>
@@ -16866,7 +17128,7 @@
               </a:spcAft>
             </a:pPr>
             <a:r>
-              <a:rPr sz="950">
+              <a:rPr sz="1200">
                 <a:solidFill>
                   <a:srgbClr val="606060"/>
                 </a:solidFill>
@@ -16931,7 +17193,7 @@
         <p:spPr>
           <a:xfrm>
             <a:off x="691407" y="1544769"/>
-            <a:ext cx="877824" cy="219456"/>
+            <a:ext cx="987552" cy="246888"/>
           </a:xfrm>
           <a:prstGeom prst="roundRect">
             <a:avLst>
@@ -16966,7 +17228,7 @@
           <a:p>
             <a:pPr algn="ctr"/>
             <a:r>
-              <a:rPr sz="1000" b="1">
+              <a:rPr sz="1200" b="1">
                 <a:solidFill>
                   <a:srgbClr val="FFFFFF"/>
                 </a:solidFill>
@@ -17031,7 +17293,7 @@
         <p:spPr>
           <a:xfrm>
             <a:off x="691407" y="3733036"/>
-            <a:ext cx="1138428" cy="219456"/>
+            <a:ext cx="1275588" cy="246888"/>
           </a:xfrm>
           <a:prstGeom prst="roundRect">
             <a:avLst>
@@ -17066,7 +17328,7 @@
           <a:p>
             <a:pPr algn="ctr"/>
             <a:r>
-              <a:rPr sz="1000" b="1">
+              <a:rPr sz="1200" b="1">
                 <a:solidFill>
                   <a:srgbClr val="FFFFFF"/>
                 </a:solidFill>
@@ -17131,7 +17393,7 @@
         <p:spPr>
           <a:xfrm>
             <a:off x="691407" y="4361069"/>
-            <a:ext cx="1051560" cy="219456"/>
+            <a:ext cx="1179576" cy="246888"/>
           </a:xfrm>
           <a:prstGeom prst="roundRect">
             <a:avLst>
@@ -17166,7 +17428,7 @@
           <a:p>
             <a:pPr algn="ctr"/>
             <a:r>
-              <a:rPr sz="1000" b="1">
+              <a:rPr sz="1200" b="1">
                 <a:solidFill>
                   <a:srgbClr val="FFFFFF"/>
                 </a:solidFill>
@@ -17230,8 +17492,8 @@
         </p:nvSpPr>
         <p:spPr>
           <a:xfrm>
-            <a:off x="764079" y="1532666"/>
-            <a:ext cx="713232" cy="219456"/>
+            <a:off x="764079" y="1514378"/>
+            <a:ext cx="822960" cy="246888"/>
           </a:xfrm>
           <a:prstGeom prst="roundRect">
             <a:avLst>
@@ -17266,7 +17528,7 @@
           <a:p>
             <a:pPr algn="ctr"/>
             <a:r>
-              <a:rPr sz="1000" b="1">
+              <a:rPr sz="1200" b="1">
                 <a:solidFill>
                   <a:srgbClr val="FFFFFF"/>
                 </a:solidFill>
@@ -17330,8 +17592,8 @@
         </p:nvSpPr>
         <p:spPr>
           <a:xfrm>
-            <a:off x="1140655" y="2489406"/>
-            <a:ext cx="1225296" cy="219456"/>
+            <a:off x="1140655" y="2471118"/>
+            <a:ext cx="1371600" cy="246888"/>
           </a:xfrm>
           <a:prstGeom prst="roundRect">
             <a:avLst>
@@ -17366,7 +17628,7 @@
           <a:p>
             <a:pPr algn="ctr"/>
             <a:r>
-              <a:rPr sz="1000" b="1">
+              <a:rPr sz="1200" b="1">
                 <a:solidFill>
                   <a:srgbClr val="FFFFFF"/>
                 </a:solidFill>
@@ -17430,8 +17692,8 @@
         </p:nvSpPr>
         <p:spPr>
           <a:xfrm>
-            <a:off x="2270890" y="3745128"/>
-            <a:ext cx="713232" cy="219456"/>
+            <a:off x="2270890" y="3726840"/>
+            <a:ext cx="822960" cy="246888"/>
           </a:xfrm>
           <a:prstGeom prst="roundRect">
             <a:avLst>
@@ -17466,7 +17728,7 @@
           <a:p>
             <a:pPr algn="ctr"/>
             <a:r>
-              <a:rPr sz="1000" b="1">
+              <a:rPr sz="1200" b="1">
                 <a:solidFill>
                   <a:srgbClr val="FFFFFF"/>
                 </a:solidFill>
@@ -17530,8 +17792,8 @@
         </p:nvSpPr>
         <p:spPr>
           <a:xfrm>
-            <a:off x="2309513" y="4059317"/>
-            <a:ext cx="713232" cy="219456"/>
+            <a:off x="2309513" y="4041029"/>
+            <a:ext cx="822960" cy="246888"/>
           </a:xfrm>
           <a:prstGeom prst="roundRect">
             <a:avLst>
@@ -17566,7 +17828,7 @@
           <a:p>
             <a:pPr algn="ctr"/>
             <a:r>
-              <a:rPr sz="1000" b="1">
+              <a:rPr sz="1200" b="1">
                 <a:solidFill>
                   <a:srgbClr val="FFFFFF"/>
                 </a:solidFill>
@@ -17604,7 +17866,7 @@
                   <a:srgbClr val="606060"/>
                 </a:solidFill>
               </a:rPr>
-              <a:t>Schwab · Jeong · Aurelia · Choi · Eroglu — EAM Case Study ArchiHotel · C2F1G4</a:t>
+              <a:t>EAM Case Study ArchiHotel · Group C2F1G4</a:t>
             </a:r>
           </a:p>
         </p:txBody>
@@ -18155,7 +18417,7 @@
           <a:lstStyle/>
           <a:p>
             <a:r>
-              <a:t>Handle Reservation → Conduct Check-In/Out — the guest's pre-arrival to arrival journey</a:t>
+              <a:t>From booking to arrival: Handle Reservation, then Conduct Check-In/Out</a:t>
             </a:r>
           </a:p>
         </p:txBody>
@@ -18176,7 +18438,7 @@
           <a:lstStyle/>
           <a:p>
             <a:r>
-              <a:t>Focus Area F1 — Where We Zoom In</a:t>
+              <a:t>Focus Area F1: Where We Zoom In</a:t>
             </a:r>
           </a:p>
         </p:txBody>
@@ -18323,7 +18585,7 @@
         <p:spPr>
           <a:xfrm>
             <a:off x="715800" y="1776695"/>
-            <a:ext cx="2528316" cy="219456"/>
+            <a:ext cx="2715768" cy="246888"/>
           </a:xfrm>
           <a:prstGeom prst="roundRect">
             <a:avLst>
@@ -18358,12 +18620,12 @@
           <a:p>
             <a:pPr algn="ctr"/>
             <a:r>
-              <a:rPr sz="1000" b="1">
+              <a:rPr sz="1200" b="1">
                 <a:solidFill>
                   <a:srgbClr val="FFFFFF"/>
                 </a:solidFill>
               </a:rPr>
-              <a:t>F1 — Reservation &amp; Check-In</a:t>
+              <a:t>F1: Reservation &amp; Check-In</a:t>
             </a:r>
           </a:p>
         </p:txBody>
@@ -18376,8 +18638,8 @@
         </p:nvSpPr>
         <p:spPr>
           <a:xfrm>
-            <a:off x="6400800" y="1600200"/>
-            <a:ext cx="310896" cy="310896"/>
+            <a:off x="6400800" y="1645920"/>
+            <a:ext cx="329184" cy="329184"/>
           </a:xfrm>
           <a:prstGeom prst="ellipse">
             <a:avLst/>
@@ -18405,12 +18667,12 @@
           </a:fontRef>
         </p:style>
         <p:txBody>
-          <a:bodyPr rtlCol="0" anchor="ctr"/>
+          <a:bodyPr rtlCol="0" anchor="ctr" wrap="none" lIns="0" rIns="0" tIns="0" bIns="0"/>
           <a:lstStyle/>
           <a:p>
             <a:pPr algn="ctr"/>
             <a:r>
-              <a:rPr sz="1400" b="1">
+              <a:rPr sz="1500" b="1">
                 <a:solidFill>
                   <a:srgbClr val="FFFFFF"/>
                 </a:solidFill>
@@ -18428,7 +18690,7 @@
         </p:nvSpPr>
         <p:spPr>
           <a:xfrm>
-            <a:off x="6812280" y="1563624"/>
+            <a:off x="6839712" y="1618488"/>
             <a:ext cx="2194560" cy="822960"/>
           </a:xfrm>
           <a:prstGeom prst="rect">
@@ -18448,7 +18710,7 @@
               </a:spcAft>
             </a:pPr>
             <a:r>
-              <a:rPr sz="1100" b="1">
+              <a:rPr sz="1500" b="1">
                 <a:solidFill>
                   <a:srgbClr val="20252A"/>
                 </a:solidFill>
@@ -18463,12 +18725,12 @@
               </a:spcAft>
             </a:pPr>
             <a:r>
-              <a:rPr sz="950">
+              <a:rPr sz="1200">
                 <a:solidFill>
                   <a:srgbClr val="606060"/>
                 </a:solidFill>
               </a:rPr>
-              <a:t>Who does what — processes &amp; objects</a:t>
+              <a:t>Who does what</a:t>
             </a:r>
           </a:p>
         </p:txBody>
@@ -18481,8 +18743,8 @@
         </p:nvSpPr>
         <p:spPr>
           <a:xfrm>
-            <a:off x="6400800" y="2560320"/>
-            <a:ext cx="310896" cy="310896"/>
+            <a:off x="6400800" y="2606040"/>
+            <a:ext cx="329184" cy="329184"/>
           </a:xfrm>
           <a:prstGeom prst="ellipse">
             <a:avLst/>
@@ -18510,12 +18772,12 @@
           </a:fontRef>
         </p:style>
         <p:txBody>
-          <a:bodyPr rtlCol="0" anchor="ctr"/>
+          <a:bodyPr rtlCol="0" anchor="ctr" wrap="none" lIns="0" rIns="0" tIns="0" bIns="0"/>
           <a:lstStyle/>
           <a:p>
             <a:pPr algn="ctr"/>
             <a:r>
-              <a:rPr sz="1400" b="1">
+              <a:rPr sz="1500" b="1">
                 <a:solidFill>
                   <a:srgbClr val="FFFFFF"/>
                 </a:solidFill>
@@ -18533,7 +18795,7 @@
         </p:nvSpPr>
         <p:spPr>
           <a:xfrm>
-            <a:off x="6812280" y="2523744"/>
+            <a:off x="6839712" y="2578608"/>
             <a:ext cx="2194560" cy="822960"/>
           </a:xfrm>
           <a:prstGeom prst="rect">
@@ -18553,7 +18815,7 @@
               </a:spcAft>
             </a:pPr>
             <a:r>
-              <a:rPr sz="1100" b="1">
+              <a:rPr sz="1500" b="1">
                 <a:solidFill>
                   <a:srgbClr val="20252A"/>
                 </a:solidFill>
@@ -18568,12 +18830,12 @@
               </a:spcAft>
             </a:pPr>
             <a:r>
-              <a:rPr sz="950">
+              <a:rPr sz="1200">
                 <a:solidFill>
                   <a:srgbClr val="606060"/>
                 </a:solidFill>
               </a:rPr>
-              <a:t>Which systems support it — the HMS</a:t>
+              <a:t>Which systems support it</a:t>
             </a:r>
           </a:p>
         </p:txBody>
@@ -18586,8 +18848,8 @@
         </p:nvSpPr>
         <p:spPr>
           <a:xfrm>
-            <a:off x="6400800" y="3520439"/>
-            <a:ext cx="310896" cy="310896"/>
+            <a:off x="6400800" y="3566160"/>
+            <a:ext cx="329184" cy="329184"/>
           </a:xfrm>
           <a:prstGeom prst="ellipse">
             <a:avLst/>
@@ -18615,12 +18877,12 @@
           </a:fontRef>
         </p:style>
         <p:txBody>
-          <a:bodyPr rtlCol="0" anchor="ctr"/>
+          <a:bodyPr rtlCol="0" anchor="ctr" wrap="none" lIns="0" rIns="0" tIns="0" bIns="0"/>
           <a:lstStyle/>
           <a:p>
             <a:pPr algn="ctr"/>
             <a:r>
-              <a:rPr sz="1400" b="1">
+              <a:rPr sz="1500" b="1">
                 <a:solidFill>
                   <a:srgbClr val="FFFFFF"/>
                 </a:solidFill>
@@ -18638,7 +18900,7 @@
         </p:nvSpPr>
         <p:spPr>
           <a:xfrm>
-            <a:off x="6812280" y="3483863"/>
+            <a:off x="6839712" y="3538728"/>
             <a:ext cx="2194560" cy="822960"/>
           </a:xfrm>
           <a:prstGeom prst="rect">
@@ -18658,7 +18920,7 @@
               </a:spcAft>
             </a:pPr>
             <a:r>
-              <a:rPr sz="1100" b="1">
+              <a:rPr sz="1500" b="1">
                 <a:solidFill>
                   <a:srgbClr val="20252A"/>
                 </a:solidFill>
@@ -18673,12 +18935,12 @@
               </a:spcAft>
             </a:pPr>
             <a:r>
-              <a:rPr sz="950">
+              <a:rPr sz="1200">
                 <a:solidFill>
                   <a:srgbClr val="606060"/>
                 </a:solidFill>
               </a:rPr>
-              <a:t>What it runs on — down to the door</a:t>
+              <a:t>What it runs on</a:t>
             </a:r>
           </a:p>
         </p:txBody>
@@ -18711,7 +18973,7 @@
                   <a:srgbClr val="606060"/>
                 </a:solidFill>
               </a:rPr>
-              <a:t>Schwab · Jeong · Aurelia · Choi · Eroglu — EAM Case Study ArchiHotel · C2F1G4</a:t>
+              <a:t>EAM Case Study ArchiHotel · Group C2F1G4</a:t>
             </a:r>
           </a:p>
         </p:txBody>
@@ -18805,7 +19067,7 @@
           <a:lstStyle/>
           <a:p>
             <a:r>
-              <a:t>F1 Business Layer — Reservation</a:t>
+              <a:t>F1 Business Layer: Reservation</a:t>
             </a:r>
           </a:p>
         </p:txBody>
@@ -18951,8 +19213,8 @@
         </p:nvSpPr>
         <p:spPr>
           <a:xfrm>
-            <a:off x="1050132" y="1501738"/>
-            <a:ext cx="713232" cy="219456"/>
+            <a:off x="1050132" y="1483450"/>
+            <a:ext cx="822960" cy="246888"/>
           </a:xfrm>
           <a:prstGeom prst="roundRect">
             <a:avLst>
@@ -18987,7 +19249,7 @@
           <a:p>
             <a:pPr algn="ctr"/>
             <a:r>
-              <a:rPr sz="1000" b="1">
+              <a:rPr sz="1200" b="1">
                 <a:solidFill>
                   <a:srgbClr val="FFFFFF"/>
                 </a:solidFill>
@@ -19051,8 +19313,8 @@
         </p:nvSpPr>
         <p:spPr>
           <a:xfrm>
-            <a:off x="1006611" y="2589758"/>
-            <a:ext cx="2615184" cy="219456"/>
+            <a:off x="1006611" y="2571470"/>
+            <a:ext cx="2811780" cy="246888"/>
           </a:xfrm>
           <a:prstGeom prst="roundRect">
             <a:avLst>
@@ -19087,12 +19349,12 @@
           <a:p>
             <a:pPr algn="ctr"/>
             <a:r>
-              <a:rPr sz="1000" b="1">
+              <a:rPr sz="1200" b="1">
                 <a:solidFill>
                   <a:srgbClr val="FFFFFF"/>
                 </a:solidFill>
               </a:rPr>
-              <a:t>Handle Reservation — 7 steps</a:t>
+              <a:t>Handle Reservation: 7 steps</a:t>
             </a:r>
           </a:p>
         </p:txBody>
@@ -19151,8 +19413,8 @@
         </p:nvSpPr>
         <p:spPr>
           <a:xfrm>
-            <a:off x="5315171" y="1936946"/>
-            <a:ext cx="790956" cy="219456"/>
+            <a:off x="5315171" y="1918658"/>
+            <a:ext cx="891540" cy="246888"/>
           </a:xfrm>
           <a:prstGeom prst="roundRect">
             <a:avLst>
@@ -19187,7 +19449,7 @@
           <a:p>
             <a:pPr algn="ctr"/>
             <a:r>
-              <a:rPr sz="1000" b="1">
+              <a:rPr sz="1200" b="1">
                 <a:solidFill>
                   <a:srgbClr val="FFFFFF"/>
                 </a:solidFill>
@@ -19251,8 +19513,8 @@
         </p:nvSpPr>
         <p:spPr>
           <a:xfrm>
-            <a:off x="361052" y="3764820"/>
-            <a:ext cx="1572768" cy="219456"/>
+            <a:off x="361052" y="3746532"/>
+            <a:ext cx="1755648" cy="246888"/>
           </a:xfrm>
           <a:prstGeom prst="roundRect">
             <a:avLst>
@@ -19287,7 +19549,7 @@
           <a:p>
             <a:pPr algn="ctr"/>
             <a:r>
-              <a:rPr sz="1000" b="1">
+              <a:rPr sz="1200" b="1">
                 <a:solidFill>
                   <a:srgbClr val="FFFFFF"/>
                 </a:solidFill>
@@ -19325,7 +19587,7 @@
                   <a:srgbClr val="606060"/>
                 </a:solidFill>
               </a:rPr>
-              <a:t>Schwab · Jeong · Aurelia · Choi · Eroglu — EAM Case Study ArchiHotel · C2F1G4</a:t>
+              <a:t>EAM Case Study ArchiHotel · Group C2F1G4</a:t>
             </a:r>
           </a:p>
         </p:txBody>
@@ -19747,7 +20009,7 @@
           <a:lstStyle/>
           <a:p>
             <a:r>
-              <a:t>F1 Business Layer — Check-In</a:t>
+              <a:t>F1 Business Layer: Check-In</a:t>
             </a:r>
           </a:p>
         </p:txBody>
@@ -19777,7 +20039,7 @@
         </p:nvSpPr>
         <p:spPr>
           <a:xfrm>
-            <a:off x="2515088" y="1463040"/>
+            <a:off x="1486388" y="1463040"/>
             <a:ext cx="6171222" cy="3310128"/>
           </a:xfrm>
           <a:prstGeom prst="rect">
@@ -19831,7 +20093,7 @@
         </p:blipFill>
         <p:spPr>
           <a:xfrm>
-            <a:off x="2533376" y="1481328"/>
+            <a:off x="1504676" y="1481328"/>
             <a:ext cx="6134646" cy="3273552"/>
           </a:xfrm>
           <a:prstGeom prst="rect">
@@ -19847,7 +20109,7 @@
         </p:nvSpPr>
         <p:spPr>
           <a:xfrm>
-            <a:off x="2611662" y="1564834"/>
+            <a:off x="1582962" y="1564834"/>
             <a:ext cx="824972" cy="485609"/>
           </a:xfrm>
           <a:prstGeom prst="roundRect">
@@ -19893,8 +20155,8 @@
         </p:nvSpPr>
         <p:spPr>
           <a:xfrm>
-            <a:off x="2611662" y="2059587"/>
-            <a:ext cx="1225296" cy="219456"/>
+            <a:off x="1582962" y="2059587"/>
+            <a:ext cx="1371600" cy="246888"/>
           </a:xfrm>
           <a:prstGeom prst="roundRect">
             <a:avLst>
@@ -19929,7 +20191,7 @@
           <a:p>
             <a:pPr algn="ctr"/>
             <a:r>
-              <a:rPr sz="1000" b="1">
+              <a:rPr sz="1200" b="1">
                 <a:solidFill>
                   <a:srgbClr val="FFFFFF"/>
                 </a:solidFill>
@@ -19947,7 +20209,7 @@
         </p:nvSpPr>
         <p:spPr>
           <a:xfrm>
-            <a:off x="4016104" y="2003396"/>
+            <a:off x="2987404" y="2003396"/>
             <a:ext cx="2829827" cy="1086021"/>
           </a:xfrm>
           <a:prstGeom prst="roundRect">
@@ -19993,8 +20255,8 @@
         </p:nvSpPr>
         <p:spPr>
           <a:xfrm>
-            <a:off x="4016104" y="1765652"/>
-            <a:ext cx="790956" cy="219456"/>
+            <a:off x="2987404" y="1747364"/>
+            <a:ext cx="891540" cy="246888"/>
           </a:xfrm>
           <a:prstGeom prst="roundRect">
             <a:avLst>
@@ -20029,7 +20291,7 @@
           <a:p>
             <a:pPr algn="ctr"/>
             <a:r>
-              <a:rPr sz="1000" b="1">
+              <a:rPr sz="1200" b="1">
                 <a:solidFill>
                   <a:srgbClr val="FFFFFF"/>
                 </a:solidFill>
@@ -20047,7 +20309,7 @@
         </p:nvSpPr>
         <p:spPr>
           <a:xfrm>
-            <a:off x="6840652" y="2316655"/>
+            <a:off x="5811952" y="2316655"/>
             <a:ext cx="824972" cy="485609"/>
           </a:xfrm>
           <a:prstGeom prst="roundRect">
@@ -20093,8 +20355,8 @@
         </p:nvSpPr>
         <p:spPr>
           <a:xfrm>
-            <a:off x="6840652" y="2078911"/>
-            <a:ext cx="790956" cy="219456"/>
+            <a:off x="5811952" y="2060623"/>
+            <a:ext cx="891540" cy="246888"/>
           </a:xfrm>
           <a:prstGeom prst="roundRect">
             <a:avLst>
@@ -20129,7 +20391,7 @@
           <a:p>
             <a:pPr algn="ctr"/>
             <a:r>
-              <a:rPr sz="1000" b="1">
+              <a:rPr sz="1200" b="1">
                 <a:solidFill>
                   <a:srgbClr val="FFFFFF"/>
                 </a:solidFill>
@@ -20147,7 +20409,7 @@
         </p:nvSpPr>
         <p:spPr>
           <a:xfrm>
-            <a:off x="6647476" y="4258858"/>
+            <a:off x="5618776" y="4258858"/>
             <a:ext cx="1639444" cy="527376"/>
           </a:xfrm>
           <a:prstGeom prst="roundRect">
@@ -20193,8 +20455,8 @@
         </p:nvSpPr>
         <p:spPr>
           <a:xfrm>
-            <a:off x="6647476" y="4021114"/>
-            <a:ext cx="2441448" cy="219456"/>
+            <a:off x="5618776" y="4002826"/>
+            <a:ext cx="2715768" cy="246888"/>
           </a:xfrm>
           <a:prstGeom prst="roundRect">
             <a:avLst>
@@ -20229,7 +20491,7 @@
           <a:p>
             <a:pPr algn="ctr"/>
             <a:r>
-              <a:rPr sz="1000" b="1">
+              <a:rPr sz="1200" b="1">
                 <a:solidFill>
                   <a:srgbClr val="FFFFFF"/>
                 </a:solidFill>
@@ -20247,89 +20509,6 @@
         </p:nvSpPr>
         <p:spPr>
           <a:xfrm>
-            <a:off x="274320" y="1600200"/>
-            <a:ext cx="1920240" cy="3017520"/>
-          </a:xfrm>
-          <a:prstGeom prst="rect">
-            <a:avLst/>
-          </a:prstGeom>
-          <a:noFill/>
-        </p:spPr>
-        <p:txBody>
-          <a:bodyPr wrap="square">
-            <a:spAutoFit/>
-          </a:bodyPr>
-          <a:lstStyle/>
-          <a:p>
-            <a:pPr algn="l">
-              <a:spcAft>
-                <a:spcPts val="400"/>
-              </a:spcAft>
-            </a:pPr>
-            <a:r>
-              <a:rPr sz="1050">
-                <a:solidFill>
-                  <a:srgbClr val="20252A"/>
-                </a:solidFill>
-              </a:rPr>
-              <a:t>The Receptionist is assigned to the whole process.</a:t>
-            </a:r>
-          </a:p>
-          <a:p>
-            <a:pPr algn="l">
-              <a:spcAft>
-                <a:spcPts val="400"/>
-              </a:spcAft>
-            </a:pPr>
-            <a:r>
-              <a:rPr sz="1050">
-                <a:solidFill>
-                  <a:srgbClr val="20252A"/>
-                </a:solidFill>
-              </a:rPr>
-              <a:t>Identify Reservation → Verify Guest Identity → Issue and Configure Key Card.</a:t>
-            </a:r>
-          </a:p>
-          <a:p>
-            <a:pPr algn="l">
-              <a:spcAft>
-                <a:spcPts val="400"/>
-              </a:spcAft>
-            </a:pPr>
-            <a:r>
-              <a:rPr sz="1050">
-                <a:solidFill>
-                  <a:srgbClr val="20252A"/>
-                </a:solidFill>
-              </a:rPr>
-              <a:t>Realises the Check-In/Out Service the guest sees.</a:t>
-            </a:r>
-          </a:p>
-          <a:p>
-            <a:pPr algn="l">
-              <a:spcAft>
-                <a:spcPts val="400"/>
-              </a:spcAft>
-            </a:pPr>
-            <a:r>
-              <a:rPr sz="1050">
-                <a:solidFill>
-                  <a:srgbClr val="20252A"/>
-                </a:solidFill>
-              </a:rPr>
-              <a:t>Open costs settle via the Payment Service.</a:t>
-            </a:r>
-          </a:p>
-        </p:txBody>
-      </p:sp>
-      <p:sp>
-        <p:nvSpPr>
-          <p:cNvPr id="29" name="TextBox 28"/>
-          <p:cNvSpPr txBox="1"/>
-          <p:nvPr/>
-        </p:nvSpPr>
-        <p:spPr>
-          <a:xfrm>
             <a:off x="310896" y="4864608"/>
             <a:ext cx="6949440" cy="237744"/>
           </a:xfrm>
@@ -20350,14 +20529,14 @@
                   <a:srgbClr val="606060"/>
                 </a:solidFill>
               </a:rPr>
-              <a:t>Schwab · Jeong · Aurelia · Choi · Eroglu — EAM Case Study ArchiHotel · C2F1G4</a:t>
-            </a:r>
-          </a:p>
-        </p:txBody>
-      </p:sp>
-      <p:sp>
-        <p:nvSpPr>
-          <p:cNvPr id="30" name="TextBox 29"/>
+              <a:t>EAM Case Study ArchiHotel · Group C2F1G4</a:t>
+            </a:r>
+          </a:p>
+        </p:txBody>
+      </p:sp>
+      <p:sp>
+        <p:nvSpPr>
+          <p:cNvPr id="29" name="TextBox 28"/>
           <p:cNvSpPr txBox="1"/>
           <p:nvPr/>
         </p:nvSpPr>
@@ -20751,7 +20930,7 @@
           <a:lstStyle/>
           <a:p>
             <a:r>
-              <a:t>The abstract view hid this: functions, services, events and data objects</a:t>
+              <a:t>Functions, services, events and data objects the abstract view hid</a:t>
             </a:r>
           </a:p>
         </p:txBody>
@@ -20772,7 +20951,7 @@
           <a:lstStyle/>
           <a:p>
             <a:r>
-              <a:t>F1 Application Layer — Inside the HMS</a:t>
+              <a:t>F1 Application Layer: Inside the HMS</a:t>
             </a:r>
           </a:p>
         </p:txBody>
@@ -20918,8 +21097,8 @@
         </p:nvSpPr>
         <p:spPr>
           <a:xfrm>
-            <a:off x="3519487" y="2761029"/>
-            <a:ext cx="2180844" cy="219456"/>
+            <a:off x="3519487" y="2742741"/>
+            <a:ext cx="2427732" cy="246888"/>
           </a:xfrm>
           <a:prstGeom prst="roundRect">
             <a:avLst>
@@ -20954,7 +21133,7 @@
           <a:p>
             <a:pPr algn="ctr"/>
             <a:r>
-              <a:rPr sz="1000" b="1">
+              <a:rPr sz="1200" b="1">
                 <a:solidFill>
                   <a:srgbClr val="FFFFFF"/>
                 </a:solidFill>
@@ -21018,8 +21197,8 @@
         </p:nvSpPr>
         <p:spPr>
           <a:xfrm>
-            <a:off x="2603940" y="1363614"/>
-            <a:ext cx="2180844" cy="219456"/>
+            <a:off x="2603940" y="1345326"/>
+            <a:ext cx="2427732" cy="246888"/>
           </a:xfrm>
           <a:prstGeom prst="roundRect">
             <a:avLst>
@@ -21054,7 +21233,7 @@
           <a:p>
             <a:pPr algn="ctr"/>
             <a:r>
-              <a:rPr sz="1000" b="1">
+              <a:rPr sz="1200" b="1">
                 <a:solidFill>
                   <a:srgbClr val="FFFFFF"/>
                 </a:solidFill>
@@ -21118,8 +21297,8 @@
         </p:nvSpPr>
         <p:spPr>
           <a:xfrm>
-            <a:off x="2126088" y="2110508"/>
-            <a:ext cx="1138428" cy="219456"/>
+            <a:off x="2126088" y="2092220"/>
+            <a:ext cx="1275588" cy="246888"/>
           </a:xfrm>
           <a:prstGeom prst="roundRect">
             <a:avLst>
@@ -21154,7 +21333,7 @@
           <a:p>
             <a:pPr algn="ctr"/>
             <a:r>
-              <a:rPr sz="1000" b="1">
+              <a:rPr sz="1200" b="1">
                 <a:solidFill>
                   <a:srgbClr val="FFFFFF"/>
                 </a:solidFill>
@@ -21218,8 +21397,8 @@
         </p:nvSpPr>
         <p:spPr>
           <a:xfrm>
-            <a:off x="2559769" y="4062069"/>
-            <a:ext cx="2651760" cy="219456"/>
+            <a:off x="2559769" y="4043781"/>
+            <a:ext cx="2834640" cy="246888"/>
           </a:xfrm>
           <a:prstGeom prst="roundRect">
             <a:avLst>
@@ -21254,12 +21433,12 @@
           <a:p>
             <a:pPr algn="ctr"/>
             <a:r>
-              <a:rPr sz="1000" b="1">
+              <a:rPr sz="1200" b="1">
                 <a:solidFill>
                   <a:srgbClr val="FFFFFF"/>
                 </a:solidFill>
               </a:rPr>
-              <a:t>Data object realises Reservation</a:t>
+              <a:t>Data object realizes Reservation</a:t>
             </a:r>
           </a:p>
         </p:txBody>
@@ -21292,7 +21471,7 @@
                   <a:srgbClr val="606060"/>
                 </a:solidFill>
               </a:rPr>
-              <a:t>Schwab · Jeong · Aurelia · Choi · Eroglu — EAM Case Study ArchiHotel · C2F1G4</a:t>
+              <a:t>EAM Case Study ArchiHotel · Group C2F1G4</a:t>
             </a:r>
           </a:p>
         </p:txBody>
@@ -21693,7 +21872,7 @@
           <a:lstStyle/>
           <a:p>
             <a:r>
-              <a:t>How a reservation made online becomes a door that opens</a:t>
+              <a:t>How an online reservation becomes a door that opens</a:t>
             </a:r>
           </a:p>
         </p:txBody>
@@ -21714,7 +21893,7 @@
           <a:lstStyle/>
           <a:p>
             <a:r>
-              <a:t>F1 Technology Layer — Down to the Door</a:t>
+              <a:t>F1 Technology Layer: Down to the Door</a:t>
             </a:r>
           </a:p>
         </p:txBody>
@@ -21860,8 +22039,8 @@
         </p:nvSpPr>
         <p:spPr>
           <a:xfrm>
-            <a:off x="3948129" y="1734860"/>
-            <a:ext cx="1572768" cy="219456"/>
+            <a:off x="3948129" y="1716572"/>
+            <a:ext cx="1755648" cy="246888"/>
           </a:xfrm>
           <a:prstGeom prst="roundRect">
             <a:avLst>
@@ -21896,7 +22075,7 @@
           <a:p>
             <a:pPr algn="ctr"/>
             <a:r>
-              <a:rPr sz="1000" b="1">
+              <a:rPr sz="1200" b="1">
                 <a:solidFill>
                   <a:srgbClr val="FFFFFF"/>
                 </a:solidFill>
@@ -21960,8 +22139,8 @@
         </p:nvSpPr>
         <p:spPr>
           <a:xfrm>
-            <a:off x="2231421" y="1706327"/>
-            <a:ext cx="1659636" cy="219456"/>
+            <a:off x="2231421" y="1688039"/>
+            <a:ext cx="1851660" cy="246888"/>
           </a:xfrm>
           <a:prstGeom prst="roundRect">
             <a:avLst>
@@ -21996,7 +22175,7 @@
           <a:p>
             <a:pPr algn="ctr"/>
             <a:r>
-              <a:rPr sz="1000" b="1">
+              <a:rPr sz="1200" b="1">
                 <a:solidFill>
                   <a:srgbClr val="FFFFFF"/>
                 </a:solidFill>
@@ -22060,8 +22239,8 @@
         </p:nvSpPr>
         <p:spPr>
           <a:xfrm>
-            <a:off x="1375445" y="2676433"/>
-            <a:ext cx="964692" cy="219456"/>
+            <a:off x="1375445" y="2658145"/>
+            <a:ext cx="1083564" cy="246888"/>
           </a:xfrm>
           <a:prstGeom prst="roundRect">
             <a:avLst>
@@ -22096,7 +22275,7 @@
           <a:p>
             <a:pPr algn="ctr"/>
             <a:r>
-              <a:rPr sz="1000" b="1">
+              <a:rPr sz="1200" b="1">
                 <a:solidFill>
                   <a:srgbClr val="FFFFFF"/>
                 </a:solidFill>
@@ -22161,7 +22340,7 @@
         <p:spPr>
           <a:xfrm>
             <a:off x="4461714" y="4099732"/>
-            <a:ext cx="1225296" cy="219456"/>
+            <a:ext cx="1371600" cy="246888"/>
           </a:xfrm>
           <a:prstGeom prst="roundRect">
             <a:avLst>
@@ -22196,7 +22375,7 @@
           <a:p>
             <a:pPr algn="ctr"/>
             <a:r>
-              <a:rPr sz="1000" b="1">
+              <a:rPr sz="1200" b="1">
                 <a:solidFill>
                   <a:srgbClr val="FFFFFF"/>
                 </a:solidFill>
@@ -22261,7 +22440,7 @@
         <p:spPr>
           <a:xfrm>
             <a:off x="4176389" y="4713181"/>
-            <a:ext cx="877824" cy="219456"/>
+            <a:ext cx="987552" cy="246888"/>
           </a:xfrm>
           <a:prstGeom prst="roundRect">
             <a:avLst>
@@ -22296,7 +22475,7 @@
           <a:p>
             <a:pPr algn="ctr"/>
             <a:r>
-              <a:rPr sz="1000" b="1">
+              <a:rPr sz="1200" b="1">
                 <a:solidFill>
                   <a:srgbClr val="FFFFFF"/>
                 </a:solidFill>
@@ -22334,7 +22513,7 @@
                   <a:srgbClr val="606060"/>
                 </a:solidFill>
               </a:rPr>
-              <a:t>Schwab · Jeong · Aurelia · Choi · Eroglu — EAM Case Study ArchiHotel · C2F1G4</a:t>
+              <a:t>EAM Case Study ArchiHotel · Group C2F1G4</a:t>
             </a:r>
           </a:p>
         </p:txBody>

</xml_diff>

<commit_message>
Add speaker script (md + pdf) and 6-person deck: Kelly on application layer with Fiona
Team of six with balanced ~2 min speaking blocks matching each person's part of
the model. Application layer stretched to two slides per the tutorial's advice
for larger teams.

Co-Authored-By: Claude Fable 5 <noreply@anthropic.com>
</commit_message>
<xml_diff>
--- a/slides/C2F1G4.pptx
+++ b/slides/C2F1G4.pptx
@@ -33,6 +33,7 @@
     <p:sldId id="269" r:id="rId28"/>
     <p:sldId id="270" r:id="rId29"/>
     <p:sldId id="271" r:id="rId30"/>
+    <p:sldId id="272" r:id="rId31"/>
   </p:sldIdLst>
   <p:sldSz cx="9144000" cy="5143500" type="screen16x9"/>
   <p:notesSz cx="9925050" cy="6665913"/>
@@ -924,7 +925,7 @@
           </a:p>
           <a:p>
             <a:r>
-              <a:t>Hook: "At ArchiHotel, luxury feels effortless. But behind the desk, five systems have to cooperate for every single check-in." Say the team name, then move straight on. VERIFY the name spellings before submission, the roster comes from repo commits.</a:t>
+              <a:t>Hook: "At ArchiHotel, luxury feels effortless. But behind the desk, five systems have to cooperate for every single check-in." Say the team name, then move straight on. VERIFY the name spellings before submission, most of the roster comes from repo commits.</a:t>
             </a:r>
           </a:p>
         </p:txBody>
@@ -994,12 +995,12 @@
           <a:lstStyle/>
           <a:p>
             <a:r>
-              <a:t>SPEAKER Demir, then Katrin (P5/P1), about 60 seconds.</a:t>
-            </a:r>
-          </a:p>
-          <a:p>
-            <a:r>
-              <a:t>Value: the model gives one shared picture across more than five systems, supports impact analysis (walk one example: HMS down, which services stop?), and speeds up onboarding. Limitations: it's an as-is snapshot with no governance process, it has no quantities or SLAs, and every abstraction choice hides detail on purpose.</a:t>
+              <a:t>SPEAKER Demir (P5), about 2 minutes. The technology layer is his part of the model.</a:t>
+            </a:r>
+          </a:p>
+          <a:p>
+            <a:r>
+              <a:t>CLICK 1: the guest taps the key card and the Door Card Reader detects it. CLICK 2: the Grant Room Access chain runs: Detect Card, Read Access Rights, Verify Authorization, Unlock Door, Activate Room Circuit. CLICK 3: the Door System Software reads the Access Rights artifact and writes the Access Log. CLICK 4: communication is modeled explicitly: the RFID path to the card, hotel Wi-Fi and Internet up to the AWS-hosted HMS. CLICK 5: close the loop: "This is how a reservation made online becomes a door that opens."</a:t>
             </a:r>
           </a:p>
         </p:txBody>
@@ -1069,12 +1070,12 @@
           <a:lstStyle/>
           <a:p>
             <a:r>
-              <a:t>SPEAKER Katrin (P1), about 60 seconds.</a:t>
-            </a:r>
-          </a:p>
-          <a:p>
-            <a:r>
-              <a:t>Missing: infrastructure specs for the reservation side, the interfaces to external booking platforms, and any failure or volume data. Challenges, use the real ones: choosing the abstraction level, keeping the two views consistent while both evolved, and coArchi merge conflicts from modeling in parallel. We hit that one for real and merged eleven duplicate elements late. The kickoff literally warns about it.</a:t>
+              <a:t>SPEAKER Angel (P6), about 55 seconds. He aligned the layers, so the reflection is his block.</a:t>
+            </a:r>
+          </a:p>
+          <a:p>
+            <a:r>
+              <a:t>Value: the model gives one shared picture across more than five systems, supports impact analysis (walk one example: HMS down, which services stop?), and speeds up onboarding. Limitations: it's an as-is snapshot with no governance process, it has no quantities or SLAs, and every abstraction choice hides detail on purpose.</a:t>
             </a:r>
           </a:p>
         </p:txBody>
@@ -1144,12 +1145,12 @@
           <a:lstStyle/>
           <a:p>
             <a:r>
-              <a:t>SPEAKER Katrin (P1), about 30 seconds.</a:t>
-            </a:r>
-          </a:p>
-          <a:p>
-            <a:r>
-              <a:t>Recap in three sentences: we modeled reservation handling and check-in across all three ArchiMate layers, everything converges on the HMS, and the model's value is transparency and impact analysis, with the limits of a snapshot. Thank the audience. KEEP THIS SLIDE UP during the discussion. Everyone stays up front, they will ask each member something.</a:t>
+              <a:t>SPEAKER Angel (P6), about 55 seconds. The merge conflicts are literally his war story.</a:t>
+            </a:r>
+          </a:p>
+          <a:p>
+            <a:r>
+              <a:t>Missing: infrastructure specs for the reservation side, the interfaces to external booking platforms, and any failure or volume data. Challenges, use the real ones: choosing the abstraction level, keeping the two views consistent while both evolved, and coArchi merge conflicts from modeling in parallel. We hit that one for real and merged eleven duplicate elements late. The kickoff literally warns about it.</a:t>
             </a:r>
           </a:p>
         </p:txBody>
@@ -1219,7 +1220,12 @@
           <a:lstStyle/>
           <a:p>
             <a:r>
-              <a:t>Q&amp;A backup, 5 minutes of discussion. Following slides: full detailed view, full abstract view, model facts.</a:t>
+              <a:t>SPEAKER Angel (P6), about 30 seconds.</a:t>
+            </a:r>
+          </a:p>
+          <a:p>
+            <a:r>
+              <a:t>Recap in three sentences: we modeled reservation handling and check-in across all three ArchiMate layers, everything converges on the HMS, and the model's value is transparency and impact analysis, with the limits of a snapshot. Thank the audience. KEEP THIS SLIDE UP during the discussion. Everyone stays up front, they will ask each member something.</a:t>
             </a:r>
           </a:p>
         </p:txBody>
@@ -1289,7 +1295,7 @@
           <a:lstStyle/>
           <a:p>
             <a:r>
-              <a:t>Backup: complete detailed view for zoom-in questions.</a:t>
+              <a:t>Q&amp;A backup, 5 minutes of discussion. Following slides: full detailed view, full abstract view, model facts.</a:t>
             </a:r>
           </a:p>
         </p:txBody>
@@ -1359,7 +1365,7 @@
           <a:lstStyle/>
           <a:p>
             <a:r>
-              <a:t>Backup: complete abstract view. Useful for questions about the other focus areas, like briefing, laundry or transfer.</a:t>
+              <a:t>Backup: complete detailed view for zoom-in questions.</a:t>
             </a:r>
           </a:p>
         </p:txBody>
@@ -1429,6 +1435,76 @@
           <a:lstStyle/>
           <a:p>
             <a:r>
+              <a:t>Backup: complete abstract view. Useful for questions about the other focus areas, like briefing, laundry or transfer.</a:t>
+            </a:r>
+          </a:p>
+        </p:txBody>
+      </p:sp>
+      <p:sp>
+        <p:nvSpPr>
+          <p:cNvPr id="4" name="Slide Number Placeholder 3"/>
+          <p:cNvSpPr>
+            <a:spLocks noGrp="1"/>
+          </p:cNvSpPr>
+          <p:nvPr>
+            <p:ph type="sldNum" idx="5" sz="quarter"/>
+          </p:nvPr>
+        </p:nvSpPr>
+        <p:spPr/>
+      </p:sp>
+    </p:spTree>
+  </p:cSld>
+  <p:clrMapOvr>
+    <a:masterClrMapping/>
+  </p:clrMapOvr>
+</p:notes>
+</file>
+
+<file path=ppt/notesSlides/notesSlide17.xml><?xml version="1.0" encoding="utf-8"?>
+<p:notes xmlns:a="http://schemas.openxmlformats.org/drawingml/2006/main" xmlns:p="http://schemas.openxmlformats.org/presentationml/2006/main" xmlns:r="http://schemas.openxmlformats.org/officeDocument/2006/relationships">
+  <p:cSld>
+    <p:spTree>
+      <p:nvGrpSpPr>
+        <p:cNvPr id="1" name=""/>
+        <p:cNvGrpSpPr/>
+        <p:nvPr/>
+      </p:nvGrpSpPr>
+      <p:grpSpPr>
+        <a:xfrm>
+          <a:off x="0" y="0"/>
+          <a:ext cx="0" cy="0"/>
+          <a:chOff x="0" y="0"/>
+          <a:chExt cx="0" cy="0"/>
+        </a:xfrm>
+      </p:grpSpPr>
+      <p:sp>
+        <p:nvSpPr>
+          <p:cNvPr id="2" name="Slide Image Placeholder 1"/>
+          <p:cNvSpPr>
+            <a:spLocks noGrp="1"/>
+          </p:cNvSpPr>
+          <p:nvPr>
+            <p:ph type="sldImg" idx="2"/>
+          </p:nvPr>
+        </p:nvSpPr>
+        <p:spPr/>
+      </p:sp>
+      <p:sp>
+        <p:nvSpPr>
+          <p:cNvPr id="3" name="Notes Placeholder 2"/>
+          <p:cNvSpPr>
+            <a:spLocks noGrp="1"/>
+          </p:cNvSpPr>
+          <p:nvPr>
+            <p:ph type="body" idx="3" sz="quarter"/>
+          </p:nvPr>
+        </p:nvSpPr>
+        <p:spPr/>
+        <p:txBody>
+          <a:bodyPr/>
+          <a:lstStyle/>
+          <a:p>
+            <a:r>
               <a:t>Backup: numbers and workflow facts for the discussion.</a:t>
             </a:r>
           </a:p>
@@ -1504,7 +1580,7 @@
           </a:p>
           <a:p>
             <a:r>
-              <a:t>One sentence: we split the model one layer per person. Angel kept the layers consistent with each other, and Katrin owned the abstract view and the final quality pass. This sets up the reflection answer on how we worked. Photos can replace the initials if the team prefers.</a:t>
+              <a:t>One sentence: we split the model one layer per person. Angel kept the layers consistent with each other, and Katrin owned the abstract view and the final quality pass. This sets up the reflection answer on how we worked. Fiona and Kelly shared the application layer. Photos can replace the initials if the team prefers.</a:t>
             </a:r>
           </a:p>
         </p:txBody>
@@ -1574,12 +1650,12 @@
           <a:lstStyle/>
           <a:p>
             <a:r>
-              <a:t>SPEAKER Katrin (P1), about 45 seconds.</a:t>
-            </a:r>
-          </a:p>
-          <a:p>
-            <a:r>
-              <a:t>Walk the four services: a guest books, arrives and checks in, pays, and every morning the staff aligns on one shared picture. All of it runs on the Hotel Management System. Point at the red box: our focus area F1 covers reservation handling and check-in, the guest journey from booking to arrival. Payment touches it too. Hand over to Angel.</a:t>
+              <a:t>SPEAKER Katrin (P1), about 30 seconds.</a:t>
+            </a:r>
+          </a:p>
+          <a:p>
+            <a:r>
+              <a:t>Walk the four services: a guest books, arrives and checks in, pays, and every morning the staff aligns on one shared picture. All of it runs on the Hotel Management System. Point at the red box: our focus area F1 covers reservation handling and check-in, the guest journey from booking to arrival. Payment touches it too.</a:t>
             </a:r>
           </a:p>
         </p:txBody>
@@ -1649,7 +1725,7 @@
           <a:lstStyle/>
           <a:p>
             <a:r>
-              <a:t>SPEAKER Angel (P2), about 90 seconds.</a:t>
+              <a:t>SPEAKER Katrin (P1), about 70 seconds. The abstract view is her part of the model.</a:t>
             </a:r>
           </a:p>
           <a:p>
@@ -1724,7 +1800,7 @@
           <a:lstStyle/>
           <a:p>
             <a:r>
-              <a:t>SPEAKER Soyeong (P3), about 45 seconds.</a:t>
+              <a:t>SPEAKER Soyeong (P2), about 30 seconds.</a:t>
             </a:r>
           </a:p>
           <a:p>
@@ -1799,7 +1875,7 @@
           <a:lstStyle/>
           <a:p>
             <a:r>
-              <a:t>SPEAKER Soyeong (P3), about 75 seconds.</a:t>
+              <a:t>SPEAKER Soyeong (P2), about 55 seconds. The business layer is her part of the model.</a:t>
             </a:r>
           </a:p>
           <a:p>
@@ -1874,12 +1950,12 @@
           <a:lstStyle/>
           <a:p>
             <a:r>
-              <a:t>SPEAKER Soyeong, then Fiona (P3/P4), about 75 seconds.</a:t>
-            </a:r>
-          </a:p>
-          <a:p>
-            <a:r>
-              <a:t>CLICK 1: the Receptionist is assigned to the whole Conduct Check-In/Out process. CLICK 2: three steps: Identify Reservation, Verify Guest Identity, Issue and Configure Key Card. CLICK 3: together they realize the Check-In/Out Service the guest experiences. CLICK 4: open costs settle through the Payment service, backed by the external provider. Handover line: "So much for the people. Now the systems underneath." Fiona takes over.</a:t>
+              <a:t>SPEAKER Soyeong (P2), about 55 seconds.</a:t>
+            </a:r>
+          </a:p>
+          <a:p>
+            <a:r>
+              <a:t>CLICK 1: the Receptionist is assigned to the whole Conduct Check-In/Out process. CLICK 2: three steps: Identify Reservation, Verify Guest Identity, Issue and Configure Key Card. CLICK 3: together they realize the Check-In/Out Service the guest experiences. CLICK 4: open costs settle through the Payment service, backed by the external provider. Handover line: "So much for the people. Now the systems underneath." Hand over to Fiona.</a:t>
             </a:r>
           </a:p>
         </p:txBody>
@@ -1949,12 +2025,12 @@
           <a:lstStyle/>
           <a:p>
             <a:r>
-              <a:t>SPEAKER Fiona (P4), about 90 seconds.</a:t>
-            </a:r>
-          </a:p>
-          <a:p>
-            <a:r>
-              <a:t>CLICK 1: the HMS is the central component. Its functions are modeled explicitly: Check Room Availability, Calculate Pricing, Reserve Room, Issue Key Card. CLICK 2: those functions are exposed upward as application services like Reservation Management, Check-In and Key Verification. Each one serves a business process from the previous slides. CLICK 3: application events chain the flow: Reservation Request Received, Availability Confirmed, Reservation Approved, Payment Confirmed, Check In Completed. CLICK 4: pick one realization example and explain the pattern: the Reservation data object is the digital record behind the Reservation business object. Guest profile, pricing and room status follow the same pattern.</a:t>
+              <a:t>SPEAKER Fiona (P3), about 100 seconds. She built this part of the model with Kelly.</a:t>
+            </a:r>
+          </a:p>
+          <a:p>
+            <a:r>
+              <a:t>CLICK 1: the HMS is the central component, everything on this slide lives inside or around it. CLICK 2: its functions are modeled explicitly: Check Room Availability, Calculate Pricing, Reserve Room, Issue Key Card. CLICK 3: those functions are exposed upward as application services like Reservation Management, Check-In and Key Verification. Each one serves a business process from the previous slides. Hand over to Kelly for the dynamic side.</a:t>
             </a:r>
           </a:p>
         </p:txBody>
@@ -2024,12 +2100,12 @@
           <a:lstStyle/>
           <a:p>
             <a:r>
-              <a:t>SPEAKER Demir (P5), about 90 seconds.</a:t>
-            </a:r>
-          </a:p>
-          <a:p>
-            <a:r>
-              <a:t>CLICK 1: the guest taps the key card and the Door Card Reader detects it. CLICK 2: the Grant Room Access chain runs: Detect Card, Read Access Rights, Verify Authorization, Unlock Door, Activate Room Circuit. CLICK 3: the Door System Software reads the Access Rights artifact and writes the Access Log. CLICK 4: communication is modeled explicitly: the RFID path to the card, hotel Wi-Fi and Internet up to the AWS-hosted HMS. CLICK 5: close the loop: "This is how a reservation made online becomes a door that opens."</a:t>
+              <a:t>SPEAKER Kelly (P4), about 100 seconds. She built this part of the model with Fiona.</a:t>
+            </a:r>
+          </a:p>
+          <a:p>
+            <a:r>
+              <a:t>CLICK 1: application events chain the flow: a reservation request arrives and gets processed. CLICK 2: follow it to the right: Reservation Approved, Process Payment, Payment Confirmed, and the special request follows after payment. CLICK 3: pick one realization example and explain the pattern: the Reservation data object is the digital record behind the Reservation business object. Guest profile, pricing and room status follow the same pattern. Hand over to Demir for the technology underneath.</a:t>
             </a:r>
           </a:p>
         </p:txBody>
@@ -12903,7 +12979,12 @@
           <a:lstStyle/>
           <a:p>
             <a:r>
-              <a:t>Team C2F1G4: Katrin Schwab · Soyeong Jeong · Fiona Aurelia · Angel Choi · Demir Eroglu</a:t>
+              <a:t>Team C2F1G4: Katrin Schwab · Soyeong Jeong · Fiona Aurelia Tunggalmuljo</a:t>
+            </a:r>
+          </a:p>
+          <a:p>
+            <a:r>
+              <a:t>Mingwai Kelly Bin · Angel Choi · Demir Eroglu</a:t>
             </a:r>
           </a:p>
           <a:p>
@@ -12913,12 +12994,7 @@
           </a:p>
           <a:p>
             <a:r>
-              <a:t>EAM and Reference Models, Case Study Final Presentation</a:t>
-            </a:r>
-          </a:p>
-          <a:p>
-            <a:r>
-              <a:t>Heilbronn · Room C.0.44 · 06.07.2026</a:t>
+              <a:t>EAM and Reference Models, Case Study Final Presentation · Heilbronn · Room C.0.44 · 06.07.2026</a:t>
             </a:r>
           </a:p>
         </p:txBody>
@@ -12931,8 +13007,8 @@
         </p:nvSpPr>
         <p:spPr>
           <a:xfrm>
-            <a:off x="1673352" y="2886075"/>
-            <a:ext cx="5797296" cy="1908810"/>
+            <a:off x="1880850" y="3108960"/>
+            <a:ext cx="5382299" cy="1773936"/>
           </a:xfrm>
           <a:prstGeom prst="rect">
             <a:avLst/>
@@ -12985,8 +13061,8 @@
         </p:blipFill>
         <p:spPr>
           <a:xfrm>
-            <a:off x="1691640" y="2904363"/>
-            <a:ext cx="5760720" cy="1872234"/>
+            <a:off x="1899138" y="3127248"/>
+            <a:ext cx="5345723" cy="1737360"/>
           </a:xfrm>
           <a:prstGeom prst="rect">
             <a:avLst/>
@@ -13025,7 +13101,11 @@
         <p:txBody>
           <a:bodyPr/>
           <a:lstStyle/>
-          <a:p/>
+          <a:p>
+            <a:r>
+              <a:t>How an online reservation becomes a door that opens</a:t>
+            </a:r>
+          </a:p>
         </p:txBody>
       </p:sp>
       <p:sp>
@@ -13044,7 +13124,7 @@
           <a:lstStyle/>
           <a:p>
             <a:r>
-              <a:t>Reflection: Value &amp; Limitations</a:t>
+              <a:t>F1 Technology Layer: Down to the Door</a:t>
             </a:r>
           </a:p>
         </p:txBody>
@@ -13068,24 +13148,22 @@
       </p:sp>
       <p:sp>
         <p:nvSpPr>
-          <p:cNvPr id="6" name="Rounded Rectangle 5"/>
+          <p:cNvPr id="6" name="Rectangle 5"/>
           <p:cNvSpPr/>
           <p:nvPr/>
         </p:nvSpPr>
         <p:spPr>
           <a:xfrm>
-            <a:off x="411480" y="1554480"/>
-            <a:ext cx="4069080" cy="3017520"/>
-          </a:xfrm>
-          <a:prstGeom prst="roundRect">
-            <a:avLst>
-              <a:gd name="adj" fmla="val 5000"/>
-            </a:avLst>
-          </a:prstGeom>
-          <a:solidFill>
-            <a:srgbClr val="F6F9FC"/>
-          </a:solidFill>
-          <a:ln w="9525">
+            <a:off x="1213027" y="1463040"/>
+            <a:ext cx="6717945" cy="3236976"/>
+          </a:xfrm>
+          <a:prstGeom prst="rect">
+            <a:avLst/>
+          </a:prstGeom>
+          <a:solidFill>
+            <a:srgbClr val="FFFFFF"/>
+          </a:solidFill>
+          <a:ln w="6350">
             <a:solidFill>
               <a:srgbClr val="D0D8DF"/>
             </a:solidFill>
@@ -13114,27 +13192,51 @@
           </a:p>
         </p:txBody>
       </p:sp>
-      <p:sp>
-        <p:nvSpPr>
-          <p:cNvPr id="7" name="Rounded Rectangle 6"/>
+      <p:pic>
+        <p:nvPicPr>
+          <p:cNvPr id="7" name="Picture 6" descr="tech_layer.png"/>
+          <p:cNvPicPr>
+            <a:picLocks noChangeAspect="1"/>
+          </p:cNvPicPr>
+          <p:nvPr/>
+        </p:nvPicPr>
+        <p:blipFill>
+          <a:blip r:embed="rId2"/>
+          <a:stretch>
+            <a:fillRect/>
+          </a:stretch>
+        </p:blipFill>
+        <p:spPr>
+          <a:xfrm>
+            <a:off x="1231315" y="1481328"/>
+            <a:ext cx="6681369" cy="3200400"/>
+          </a:xfrm>
+          <a:prstGeom prst="rect">
+            <a:avLst/>
+          </a:prstGeom>
+        </p:spPr>
+      </p:pic>
+      <p:sp>
+        <p:nvSpPr>
+          <p:cNvPr id="8" name="Rounded Rectangle 7"/>
           <p:cNvSpPr/>
           <p:nvPr/>
         </p:nvSpPr>
         <p:spPr>
           <a:xfrm>
-            <a:off x="411480" y="1554480"/>
-            <a:ext cx="4069080" cy="365760"/>
+            <a:off x="3948129" y="1972604"/>
+            <a:ext cx="757932" cy="448830"/>
           </a:xfrm>
           <a:prstGeom prst="roundRect">
             <a:avLst>
-              <a:gd name="adj" fmla="val 50000"/>
+              <a:gd name="adj" fmla="val 6000"/>
             </a:avLst>
           </a:prstGeom>
-          <a:solidFill>
-            <a:srgbClr val="2E8B2E"/>
-          </a:solidFill>
-          <a:ln>
-            <a:noFill/>
+          <a:noFill/>
+          <a:ln w="28575">
+            <a:solidFill>
+              <a:srgbClr val="E37A00"/>
+            </a:solidFill>
           </a:ln>
           <a:effectLst/>
         </p:spPr>
@@ -13153,86 +13255,10 @@
           </a:fontRef>
         </p:style>
         <p:txBody>
-          <a:bodyPr rtlCol="0" anchor="ctr" tIns="12700" bIns="12700"/>
+          <a:bodyPr rtlCol="0" anchor="ctr"/>
           <a:lstStyle/>
           <a:p>
             <a:pPr algn="ctr"/>
-            <a:r>
-              <a:rPr b="1" sz="1600">
-                <a:solidFill>
-                  <a:srgbClr val="FFFFFF"/>
-                </a:solidFill>
-              </a:rPr>
-              <a:t>Value</a:t>
-            </a:r>
-          </a:p>
-        </p:txBody>
-      </p:sp>
-      <p:sp>
-        <p:nvSpPr>
-          <p:cNvPr id="8" name="TextBox 7"/>
-          <p:cNvSpPr txBox="1"/>
-          <p:nvPr/>
-        </p:nvSpPr>
-        <p:spPr>
-          <a:xfrm>
-            <a:off x="502920" y="1975104"/>
-            <a:ext cx="3886200" cy="2523744"/>
-          </a:xfrm>
-          <a:prstGeom prst="rect">
-            <a:avLst/>
-          </a:prstGeom>
-          <a:noFill/>
-        </p:spPr>
-        <p:txBody>
-          <a:bodyPr wrap="square">
-            <a:spAutoFit/>
-          </a:bodyPr>
-          <a:lstStyle/>
-          <a:p>
-            <a:pPr>
-              <a:spcAft>
-                <a:spcPts val="600"/>
-              </a:spcAft>
-            </a:pPr>
-            <a:r>
-              <a:rPr sz="1600">
-                <a:solidFill>
-                  <a:srgbClr val="20252A"/>
-                </a:solidFill>
-              </a:rPr>
-              <a:t>One shared picture of five cooperating systems</a:t>
-            </a:r>
-          </a:p>
-          <a:p>
-            <a:pPr>
-              <a:spcAft>
-                <a:spcPts val="600"/>
-              </a:spcAft>
-            </a:pPr>
-            <a:r>
-              <a:rPr sz="1600">
-                <a:solidFill>
-                  <a:srgbClr val="20252A"/>
-                </a:solidFill>
-              </a:rPr>
-              <a:t>Impact analysis: what breaks if the HMS is down?</a:t>
-            </a:r>
-          </a:p>
-          <a:p>
-            <a:pPr>
-              <a:spcAft>
-                <a:spcPts val="600"/>
-              </a:spcAft>
-            </a:pPr>
-            <a:r>
-              <a:rPr sz="1600">
-                <a:solidFill>
-                  <a:srgbClr val="20252A"/>
-                </a:solidFill>
-              </a:rPr>
-              <a:t>Faster onboarding for new staff and developers</a:t>
-            </a:r>
           </a:p>
         </p:txBody>
       </p:sp>
@@ -13244,21 +13270,19 @@
         </p:nvSpPr>
         <p:spPr>
           <a:xfrm>
-            <a:off x="4663440" y="1554480"/>
-            <a:ext cx="4069080" cy="3017520"/>
+            <a:off x="3948129" y="1716572"/>
+            <a:ext cx="1755648" cy="246888"/>
           </a:xfrm>
           <a:prstGeom prst="roundRect">
             <a:avLst>
-              <a:gd name="adj" fmla="val 5000"/>
+              <a:gd name="adj" fmla="val 50000"/>
             </a:avLst>
           </a:prstGeom>
           <a:solidFill>
-            <a:srgbClr val="F6F9FC"/>
-          </a:solidFill>
-          <a:ln w="9525">
-            <a:solidFill>
-              <a:srgbClr val="D0D8DF"/>
-            </a:solidFill>
+            <a:srgbClr val="E37A00"/>
+          </a:solidFill>
+          <a:ln>
+            <a:noFill/>
           </a:ln>
           <a:effectLst/>
         </p:spPr>
@@ -13277,10 +13301,18 @@
           </a:fontRef>
         </p:style>
         <p:txBody>
-          <a:bodyPr rtlCol="0" anchor="ctr"/>
+          <a:bodyPr rtlCol="0" anchor="ctr" lIns="50800" rIns="50800" tIns="0" bIns="0"/>
           <a:lstStyle/>
           <a:p>
             <a:pPr algn="ctr"/>
+            <a:r>
+              <a:rPr sz="1200" b="1">
+                <a:solidFill>
+                  <a:srgbClr val="FFFFFF"/>
+                </a:solidFill>
+              </a:rPr>
+              <a:t>Door Card Reader</a:t>
+            </a:r>
           </a:p>
         </p:txBody>
       </p:sp>
@@ -13292,19 +13324,19 @@
         </p:nvSpPr>
         <p:spPr>
           <a:xfrm>
-            <a:off x="4663440" y="1554480"/>
-            <a:ext cx="4069080" cy="365760"/>
+            <a:off x="2231421" y="1944071"/>
+            <a:ext cx="1447469" cy="2503173"/>
           </a:xfrm>
           <a:prstGeom prst="roundRect">
             <a:avLst>
-              <a:gd name="adj" fmla="val 50000"/>
+              <a:gd name="adj" fmla="val 6000"/>
             </a:avLst>
           </a:prstGeom>
-          <a:solidFill>
-            <a:srgbClr val="C40000"/>
-          </a:solidFill>
-          <a:ln>
-            <a:noFill/>
+          <a:noFill/>
+          <a:ln w="28575">
+            <a:solidFill>
+              <a:srgbClr val="C40000"/>
+            </a:solidFill>
           </a:ln>
           <a:effectLst/>
         </p:spPr>
@@ -13323,92 +13355,370 @@
           </a:fontRef>
         </p:style>
         <p:txBody>
-          <a:bodyPr rtlCol="0" anchor="ctr" tIns="12700" bIns="12700"/>
+          <a:bodyPr rtlCol="0" anchor="ctr"/>
           <a:lstStyle/>
           <a:p>
             <a:pPr algn="ctr"/>
-            <a:r>
-              <a:rPr b="1" sz="1600">
+          </a:p>
+        </p:txBody>
+      </p:sp>
+      <p:sp>
+        <p:nvSpPr>
+          <p:cNvPr id="11" name="Rounded Rectangle 10"/>
+          <p:cNvSpPr/>
+          <p:nvPr/>
+        </p:nvSpPr>
+        <p:spPr>
+          <a:xfrm>
+            <a:off x="2231421" y="1688039"/>
+            <a:ext cx="1851660" cy="246888"/>
+          </a:xfrm>
+          <a:prstGeom prst="roundRect">
+            <a:avLst>
+              <a:gd name="adj" fmla="val 50000"/>
+            </a:avLst>
+          </a:prstGeom>
+          <a:solidFill>
+            <a:srgbClr val="C40000"/>
+          </a:solidFill>
+          <a:ln>
+            <a:noFill/>
+          </a:ln>
+          <a:effectLst/>
+        </p:spPr>
+        <p:style>
+          <a:lnRef idx="1">
+            <a:schemeClr val="accent1"/>
+          </a:lnRef>
+          <a:fillRef idx="3">
+            <a:schemeClr val="accent1"/>
+          </a:fillRef>
+          <a:effectRef idx="2">
+            <a:schemeClr val="accent1"/>
+          </a:effectRef>
+          <a:fontRef idx="minor">
+            <a:schemeClr val="lt1"/>
+          </a:fontRef>
+        </p:style>
+        <p:txBody>
+          <a:bodyPr rtlCol="0" anchor="ctr" lIns="50800" rIns="50800" tIns="0" bIns="0"/>
+          <a:lstStyle/>
+          <a:p>
+            <a:pPr algn="ctr"/>
+            <a:r>
+              <a:rPr sz="1200" b="1">
                 <a:solidFill>
                   <a:srgbClr val="FFFFFF"/>
                 </a:solidFill>
               </a:rPr>
-              <a:t>Limitations</a:t>
-            </a:r>
-          </a:p>
-        </p:txBody>
-      </p:sp>
-      <p:sp>
-        <p:nvSpPr>
-          <p:cNvPr id="11" name="TextBox 10"/>
-          <p:cNvSpPr txBox="1"/>
+              <a:t>Grant Room Access</a:t>
+            </a:r>
+          </a:p>
+        </p:txBody>
+      </p:sp>
+      <p:sp>
+        <p:nvSpPr>
+          <p:cNvPr id="12" name="Rounded Rectangle 11"/>
+          <p:cNvSpPr/>
           <p:nvPr/>
         </p:nvSpPr>
         <p:spPr>
           <a:xfrm>
-            <a:off x="4754879" y="1975104"/>
-            <a:ext cx="3886200" cy="2523744"/>
-          </a:xfrm>
-          <a:prstGeom prst="rect">
-            <a:avLst/>
+            <a:off x="1375445" y="2914177"/>
+            <a:ext cx="757932" cy="848286"/>
+          </a:xfrm>
+          <a:prstGeom prst="roundRect">
+            <a:avLst>
+              <a:gd name="adj" fmla="val 6000"/>
+            </a:avLst>
           </a:prstGeom>
           <a:noFill/>
-        </p:spPr>
-        <p:txBody>
-          <a:bodyPr wrap="square">
-            <a:spAutoFit/>
-          </a:bodyPr>
-          <a:lstStyle/>
-          <a:p>
-            <a:pPr>
-              <a:spcAft>
-                <a:spcPts val="600"/>
-              </a:spcAft>
-            </a:pPr>
-            <a:r>
-              <a:rPr sz="1600">
+          <a:ln w="28575">
+            <a:solidFill>
+              <a:srgbClr val="6A3D9A"/>
+            </a:solidFill>
+          </a:ln>
+          <a:effectLst/>
+        </p:spPr>
+        <p:style>
+          <a:lnRef idx="1">
+            <a:schemeClr val="accent1"/>
+          </a:lnRef>
+          <a:fillRef idx="3">
+            <a:schemeClr val="accent1"/>
+          </a:fillRef>
+          <a:effectRef idx="2">
+            <a:schemeClr val="accent1"/>
+          </a:effectRef>
+          <a:fontRef idx="minor">
+            <a:schemeClr val="lt1"/>
+          </a:fontRef>
+        </p:style>
+        <p:txBody>
+          <a:bodyPr rtlCol="0" anchor="ctr"/>
+          <a:lstStyle/>
+          <a:p>
+            <a:pPr algn="ctr"/>
+          </a:p>
+        </p:txBody>
+      </p:sp>
+      <p:sp>
+        <p:nvSpPr>
+          <p:cNvPr id="13" name="Rounded Rectangle 12"/>
+          <p:cNvSpPr/>
+          <p:nvPr/>
+        </p:nvSpPr>
+        <p:spPr>
+          <a:xfrm>
+            <a:off x="1375445" y="2658145"/>
+            <a:ext cx="1083564" cy="246888"/>
+          </a:xfrm>
+          <a:prstGeom prst="roundRect">
+            <a:avLst>
+              <a:gd name="adj" fmla="val 50000"/>
+            </a:avLst>
+          </a:prstGeom>
+          <a:solidFill>
+            <a:srgbClr val="6A3D9A"/>
+          </a:solidFill>
+          <a:ln>
+            <a:noFill/>
+          </a:ln>
+          <a:effectLst/>
+        </p:spPr>
+        <p:style>
+          <a:lnRef idx="1">
+            <a:schemeClr val="accent1"/>
+          </a:lnRef>
+          <a:fillRef idx="3">
+            <a:schemeClr val="accent1"/>
+          </a:fillRef>
+          <a:effectRef idx="2">
+            <a:schemeClr val="accent1"/>
+          </a:effectRef>
+          <a:fontRef idx="minor">
+            <a:schemeClr val="lt1"/>
+          </a:fontRef>
+        </p:style>
+        <p:txBody>
+          <a:bodyPr rtlCol="0" anchor="ctr" lIns="50800" rIns="50800" tIns="0" bIns="0"/>
+          <a:lstStyle/>
+          <a:p>
+            <a:pPr algn="ctr"/>
+            <a:r>
+              <a:rPr sz="1200" b="1">
                 <a:solidFill>
-                  <a:srgbClr val="20252A"/>
+                  <a:srgbClr val="FFFFFF"/>
                 </a:solidFill>
               </a:rPr>
-              <a:t>A snapshot, with no process to keep it current</a:t>
-            </a:r>
-          </a:p>
-          <a:p>
-            <a:pPr>
-              <a:spcAft>
-                <a:spcPts val="600"/>
-              </a:spcAft>
-            </a:pPr>
-            <a:r>
-              <a:rPr sz="1600">
+              <a:t>Artifacts</a:t>
+            </a:r>
+          </a:p>
+        </p:txBody>
+      </p:sp>
+      <p:sp>
+        <p:nvSpPr>
+          <p:cNvPr id="14" name="Rounded Rectangle 13"/>
+          <p:cNvSpPr/>
+          <p:nvPr/>
+        </p:nvSpPr>
+        <p:spPr>
+          <a:xfrm>
+            <a:off x="4461714" y="3470562"/>
+            <a:ext cx="2431842" cy="620025"/>
+          </a:xfrm>
+          <a:prstGeom prst="roundRect">
+            <a:avLst>
+              <a:gd name="adj" fmla="val 6000"/>
+            </a:avLst>
+          </a:prstGeom>
+          <a:noFill/>
+          <a:ln w="28575">
+            <a:solidFill>
+              <a:srgbClr val="2E8B2E"/>
+            </a:solidFill>
+          </a:ln>
+          <a:effectLst/>
+        </p:spPr>
+        <p:style>
+          <a:lnRef idx="1">
+            <a:schemeClr val="accent1"/>
+          </a:lnRef>
+          <a:fillRef idx="3">
+            <a:schemeClr val="accent1"/>
+          </a:fillRef>
+          <a:effectRef idx="2">
+            <a:schemeClr val="accent1"/>
+          </a:effectRef>
+          <a:fontRef idx="minor">
+            <a:schemeClr val="lt1"/>
+          </a:fontRef>
+        </p:style>
+        <p:txBody>
+          <a:bodyPr rtlCol="0" anchor="ctr"/>
+          <a:lstStyle/>
+          <a:p>
+            <a:pPr algn="ctr"/>
+          </a:p>
+        </p:txBody>
+      </p:sp>
+      <p:sp>
+        <p:nvSpPr>
+          <p:cNvPr id="15" name="Rounded Rectangle 14"/>
+          <p:cNvSpPr/>
+          <p:nvPr/>
+        </p:nvSpPr>
+        <p:spPr>
+          <a:xfrm>
+            <a:off x="4461714" y="4099732"/>
+            <a:ext cx="1371600" cy="246888"/>
+          </a:xfrm>
+          <a:prstGeom prst="roundRect">
+            <a:avLst>
+              <a:gd name="adj" fmla="val 50000"/>
+            </a:avLst>
+          </a:prstGeom>
+          <a:solidFill>
+            <a:srgbClr val="2E8B2E"/>
+          </a:solidFill>
+          <a:ln>
+            <a:noFill/>
+          </a:ln>
+          <a:effectLst/>
+        </p:spPr>
+        <p:style>
+          <a:lnRef idx="1">
+            <a:schemeClr val="accent1"/>
+          </a:lnRef>
+          <a:fillRef idx="3">
+            <a:schemeClr val="accent1"/>
+          </a:fillRef>
+          <a:effectRef idx="2">
+            <a:schemeClr val="accent1"/>
+          </a:effectRef>
+          <a:fontRef idx="minor">
+            <a:schemeClr val="lt1"/>
+          </a:fontRef>
+        </p:style>
+        <p:txBody>
+          <a:bodyPr rtlCol="0" anchor="ctr" lIns="50800" rIns="50800" tIns="0" bIns="0"/>
+          <a:lstStyle/>
+          <a:p>
+            <a:pPr algn="ctr"/>
+            <a:r>
+              <a:rPr sz="1200" b="1">
                 <a:solidFill>
-                  <a:srgbClr val="20252A"/>
+                  <a:srgbClr val="FFFFFF"/>
                 </a:solidFill>
               </a:rPr>
-              <a:t>No quantities, no SLAs, no capacity answers</a:t>
-            </a:r>
-          </a:p>
-          <a:p>
-            <a:pPr>
-              <a:spcAft>
-                <a:spcPts val="600"/>
-              </a:spcAft>
-            </a:pPr>
-            <a:r>
-              <a:rPr sz="1600">
+              <a:t>RFID · Wi-Fi</a:t>
+            </a:r>
+          </a:p>
+        </p:txBody>
+      </p:sp>
+      <p:sp>
+        <p:nvSpPr>
+          <p:cNvPr id="16" name="Rounded Rectangle 15"/>
+          <p:cNvSpPr/>
+          <p:nvPr/>
+        </p:nvSpPr>
+        <p:spPr>
+          <a:xfrm>
+            <a:off x="4176389" y="4255207"/>
+            <a:ext cx="757932" cy="448830"/>
+          </a:xfrm>
+          <a:prstGeom prst="roundRect">
+            <a:avLst>
+              <a:gd name="adj" fmla="val 6000"/>
+            </a:avLst>
+          </a:prstGeom>
+          <a:noFill/>
+          <a:ln w="28575">
+            <a:solidFill>
+              <a:srgbClr val="B09A00"/>
+            </a:solidFill>
+          </a:ln>
+          <a:effectLst/>
+        </p:spPr>
+        <p:style>
+          <a:lnRef idx="1">
+            <a:schemeClr val="accent1"/>
+          </a:lnRef>
+          <a:fillRef idx="3">
+            <a:schemeClr val="accent1"/>
+          </a:fillRef>
+          <a:effectRef idx="2">
+            <a:schemeClr val="accent1"/>
+          </a:effectRef>
+          <a:fontRef idx="minor">
+            <a:schemeClr val="lt1"/>
+          </a:fontRef>
+        </p:style>
+        <p:txBody>
+          <a:bodyPr rtlCol="0" anchor="ctr"/>
+          <a:lstStyle/>
+          <a:p>
+            <a:pPr algn="ctr"/>
+          </a:p>
+        </p:txBody>
+      </p:sp>
+      <p:sp>
+        <p:nvSpPr>
+          <p:cNvPr id="17" name="Rounded Rectangle 16"/>
+          <p:cNvSpPr/>
+          <p:nvPr/>
+        </p:nvSpPr>
+        <p:spPr>
+          <a:xfrm>
+            <a:off x="4176389" y="4713181"/>
+            <a:ext cx="987552" cy="246888"/>
+          </a:xfrm>
+          <a:prstGeom prst="roundRect">
+            <a:avLst>
+              <a:gd name="adj" fmla="val 50000"/>
+            </a:avLst>
+          </a:prstGeom>
+          <a:solidFill>
+            <a:srgbClr val="B09A00"/>
+          </a:solidFill>
+          <a:ln>
+            <a:noFill/>
+          </a:ln>
+          <a:effectLst/>
+        </p:spPr>
+        <p:style>
+          <a:lnRef idx="1">
+            <a:schemeClr val="accent1"/>
+          </a:lnRef>
+          <a:fillRef idx="3">
+            <a:schemeClr val="accent1"/>
+          </a:fillRef>
+          <a:effectRef idx="2">
+            <a:schemeClr val="accent1"/>
+          </a:effectRef>
+          <a:fontRef idx="minor">
+            <a:schemeClr val="lt1"/>
+          </a:fontRef>
+        </p:style>
+        <p:txBody>
+          <a:bodyPr rtlCol="0" anchor="ctr" lIns="50800" rIns="50800" tIns="0" bIns="0"/>
+          <a:lstStyle/>
+          <a:p>
+            <a:pPr algn="ctr"/>
+            <a:r>
+              <a:rPr sz="1200" b="1">
                 <a:solidFill>
-                  <a:srgbClr val="20252A"/>
+                  <a:srgbClr val="FFFFFF"/>
                 </a:solidFill>
               </a:rPr>
-              <a:t>Abstraction hides detail by design</a:t>
-            </a:r>
-          </a:p>
-        </p:txBody>
-      </p:sp>
-      <p:sp>
-        <p:nvSpPr>
-          <p:cNvPr id="12" name="TextBox 11"/>
+              <a:t>Key Card</a:t>
+            </a:r>
+          </a:p>
+        </p:txBody>
+      </p:sp>
+      <p:sp>
+        <p:nvSpPr>
+          <p:cNvPr id="34" name="TextBox 33"/>
           <p:cNvSpPr txBox="1"/>
           <p:nvPr/>
         </p:nvSpPr>
@@ -13441,7 +13751,7 @@
       </p:sp>
       <p:sp>
         <p:nvSpPr>
-          <p:cNvPr id="13" name="TextBox 12"/>
+          <p:cNvPr id="35" name="TextBox 34"/>
           <p:cNvSpPr txBox="1"/>
           <p:nvPr/>
         </p:nvSpPr>
@@ -13478,6 +13788,408 @@
   <p:clrMapOvr>
     <a:masterClrMapping/>
   </p:clrMapOvr>
+  <p:timing>
+    <p:tnLst>
+      <p:par>
+        <p:cTn id="1" dur="indefinite" restart="never" nodeType="tmRoot">
+          <p:childTnLst>
+            <p:seq concurrent="1" nextAc="seek">
+              <p:cTn id="3" dur="indefinite" nodeType="mainSeq">
+                <p:childTnLst>
+                  <p:par>
+                    <p:cTn id="4" fill="hold">
+                      <p:stCondLst>
+                        <p:cond delay="indefinite"/>
+                      </p:stCondLst>
+                      <p:childTnLst>
+                        <p:par>
+                          <p:cTn id="5" fill="hold">
+                            <p:stCondLst>
+                              <p:cond delay="0"/>
+                            </p:stCondLst>
+                            <p:childTnLst>
+                              <p:par>
+                                <p:cTn id="6" presetID="1" presetClass="entr" presetSubtype="0" fill="hold" grpId="0" nodeType="clickEffect">
+                                  <p:stCondLst>
+                                    <p:cond delay="0"/>
+                                  </p:stCondLst>
+                                  <p:childTnLst>
+                                    <p:set>
+                                      <p:cBhvr>
+                                        <p:cTn id="7" dur="1" fill="hold">
+                                          <p:stCondLst>
+                                            <p:cond delay="0"/>
+                                          </p:stCondLst>
+                                        </p:cTn>
+                                        <p:tgtEl>
+                                          <p:spTgt spid="8"/>
+                                        </p:tgtEl>
+                                        <p:attrNameLst>
+                                          <p:attrName>style.visibility</p:attrName>
+                                        </p:attrNameLst>
+                                      </p:cBhvr>
+                                      <p:to>
+                                        <p:strVal val="visible"/>
+                                      </p:to>
+                                    </p:set>
+                                  </p:childTnLst>
+                                </p:cTn>
+                              </p:par>
+                              <p:par>
+                                <p:cTn id="8" presetID="1" presetClass="entr" presetSubtype="0" fill="hold" grpId="0" nodeType="withEffect">
+                                  <p:stCondLst>
+                                    <p:cond delay="0"/>
+                                  </p:stCondLst>
+                                  <p:childTnLst>
+                                    <p:set>
+                                      <p:cBhvr>
+                                        <p:cTn id="9" dur="1" fill="hold">
+                                          <p:stCondLst>
+                                            <p:cond delay="0"/>
+                                          </p:stCondLst>
+                                        </p:cTn>
+                                        <p:tgtEl>
+                                          <p:spTgt spid="9"/>
+                                        </p:tgtEl>
+                                        <p:attrNameLst>
+                                          <p:attrName>style.visibility</p:attrName>
+                                        </p:attrNameLst>
+                                      </p:cBhvr>
+                                      <p:to>
+                                        <p:strVal val="visible"/>
+                                      </p:to>
+                                    </p:set>
+                                  </p:childTnLst>
+                                </p:cTn>
+                              </p:par>
+                            </p:childTnLst>
+                          </p:cTn>
+                        </p:par>
+                      </p:childTnLst>
+                    </p:cTn>
+                  </p:par>
+                  <p:par>
+                    <p:cTn id="10" fill="hold">
+                      <p:stCondLst>
+                        <p:cond delay="indefinite"/>
+                      </p:stCondLst>
+                      <p:childTnLst>
+                        <p:par>
+                          <p:cTn id="11" fill="hold">
+                            <p:stCondLst>
+                              <p:cond delay="0"/>
+                            </p:stCondLst>
+                            <p:childTnLst>
+                              <p:par>
+                                <p:cTn id="12" presetID="1" presetClass="entr" presetSubtype="0" fill="hold" grpId="0" nodeType="clickEffect">
+                                  <p:stCondLst>
+                                    <p:cond delay="0"/>
+                                  </p:stCondLst>
+                                  <p:childTnLst>
+                                    <p:set>
+                                      <p:cBhvr>
+                                        <p:cTn id="13" dur="1" fill="hold">
+                                          <p:stCondLst>
+                                            <p:cond delay="0"/>
+                                          </p:stCondLst>
+                                        </p:cTn>
+                                        <p:tgtEl>
+                                          <p:spTgt spid="10"/>
+                                        </p:tgtEl>
+                                        <p:attrNameLst>
+                                          <p:attrName>style.visibility</p:attrName>
+                                        </p:attrNameLst>
+                                      </p:cBhvr>
+                                      <p:to>
+                                        <p:strVal val="visible"/>
+                                      </p:to>
+                                    </p:set>
+                                  </p:childTnLst>
+                                </p:cTn>
+                              </p:par>
+                              <p:par>
+                                <p:cTn id="14" presetID="1" presetClass="entr" presetSubtype="0" fill="hold" grpId="0" nodeType="withEffect">
+                                  <p:stCondLst>
+                                    <p:cond delay="0"/>
+                                  </p:stCondLst>
+                                  <p:childTnLst>
+                                    <p:set>
+                                      <p:cBhvr>
+                                        <p:cTn id="15" dur="1" fill="hold">
+                                          <p:stCondLst>
+                                            <p:cond delay="0"/>
+                                          </p:stCondLst>
+                                        </p:cTn>
+                                        <p:tgtEl>
+                                          <p:spTgt spid="11"/>
+                                        </p:tgtEl>
+                                        <p:attrNameLst>
+                                          <p:attrName>style.visibility</p:attrName>
+                                        </p:attrNameLst>
+                                      </p:cBhvr>
+                                      <p:to>
+                                        <p:strVal val="visible"/>
+                                      </p:to>
+                                    </p:set>
+                                  </p:childTnLst>
+                                </p:cTn>
+                              </p:par>
+                            </p:childTnLst>
+                          </p:cTn>
+                        </p:par>
+                      </p:childTnLst>
+                    </p:cTn>
+                  </p:par>
+                  <p:par>
+                    <p:cTn id="16" fill="hold">
+                      <p:stCondLst>
+                        <p:cond delay="indefinite"/>
+                      </p:stCondLst>
+                      <p:childTnLst>
+                        <p:par>
+                          <p:cTn id="17" fill="hold">
+                            <p:stCondLst>
+                              <p:cond delay="0"/>
+                            </p:stCondLst>
+                            <p:childTnLst>
+                              <p:par>
+                                <p:cTn id="18" presetID="1" presetClass="entr" presetSubtype="0" fill="hold" grpId="0" nodeType="clickEffect">
+                                  <p:stCondLst>
+                                    <p:cond delay="0"/>
+                                  </p:stCondLst>
+                                  <p:childTnLst>
+                                    <p:set>
+                                      <p:cBhvr>
+                                        <p:cTn id="19" dur="1" fill="hold">
+                                          <p:stCondLst>
+                                            <p:cond delay="0"/>
+                                          </p:stCondLst>
+                                        </p:cTn>
+                                        <p:tgtEl>
+                                          <p:spTgt spid="12"/>
+                                        </p:tgtEl>
+                                        <p:attrNameLst>
+                                          <p:attrName>style.visibility</p:attrName>
+                                        </p:attrNameLst>
+                                      </p:cBhvr>
+                                      <p:to>
+                                        <p:strVal val="visible"/>
+                                      </p:to>
+                                    </p:set>
+                                  </p:childTnLst>
+                                </p:cTn>
+                              </p:par>
+                              <p:par>
+                                <p:cTn id="20" presetID="1" presetClass="entr" presetSubtype="0" fill="hold" grpId="0" nodeType="withEffect">
+                                  <p:stCondLst>
+                                    <p:cond delay="0"/>
+                                  </p:stCondLst>
+                                  <p:childTnLst>
+                                    <p:set>
+                                      <p:cBhvr>
+                                        <p:cTn id="21" dur="1" fill="hold">
+                                          <p:stCondLst>
+                                            <p:cond delay="0"/>
+                                          </p:stCondLst>
+                                        </p:cTn>
+                                        <p:tgtEl>
+                                          <p:spTgt spid="13"/>
+                                        </p:tgtEl>
+                                        <p:attrNameLst>
+                                          <p:attrName>style.visibility</p:attrName>
+                                        </p:attrNameLst>
+                                      </p:cBhvr>
+                                      <p:to>
+                                        <p:strVal val="visible"/>
+                                      </p:to>
+                                    </p:set>
+                                  </p:childTnLst>
+                                </p:cTn>
+                              </p:par>
+                            </p:childTnLst>
+                          </p:cTn>
+                        </p:par>
+                      </p:childTnLst>
+                    </p:cTn>
+                  </p:par>
+                  <p:par>
+                    <p:cTn id="22" fill="hold">
+                      <p:stCondLst>
+                        <p:cond delay="indefinite"/>
+                      </p:stCondLst>
+                      <p:childTnLst>
+                        <p:par>
+                          <p:cTn id="23" fill="hold">
+                            <p:stCondLst>
+                              <p:cond delay="0"/>
+                            </p:stCondLst>
+                            <p:childTnLst>
+                              <p:par>
+                                <p:cTn id="24" presetID="1" presetClass="entr" presetSubtype="0" fill="hold" grpId="0" nodeType="clickEffect">
+                                  <p:stCondLst>
+                                    <p:cond delay="0"/>
+                                  </p:stCondLst>
+                                  <p:childTnLst>
+                                    <p:set>
+                                      <p:cBhvr>
+                                        <p:cTn id="25" dur="1" fill="hold">
+                                          <p:stCondLst>
+                                            <p:cond delay="0"/>
+                                          </p:stCondLst>
+                                        </p:cTn>
+                                        <p:tgtEl>
+                                          <p:spTgt spid="14"/>
+                                        </p:tgtEl>
+                                        <p:attrNameLst>
+                                          <p:attrName>style.visibility</p:attrName>
+                                        </p:attrNameLst>
+                                      </p:cBhvr>
+                                      <p:to>
+                                        <p:strVal val="visible"/>
+                                      </p:to>
+                                    </p:set>
+                                  </p:childTnLst>
+                                </p:cTn>
+                              </p:par>
+                              <p:par>
+                                <p:cTn id="26" presetID="1" presetClass="entr" presetSubtype="0" fill="hold" grpId="0" nodeType="withEffect">
+                                  <p:stCondLst>
+                                    <p:cond delay="0"/>
+                                  </p:stCondLst>
+                                  <p:childTnLst>
+                                    <p:set>
+                                      <p:cBhvr>
+                                        <p:cTn id="27" dur="1" fill="hold">
+                                          <p:stCondLst>
+                                            <p:cond delay="0"/>
+                                          </p:stCondLst>
+                                        </p:cTn>
+                                        <p:tgtEl>
+                                          <p:spTgt spid="15"/>
+                                        </p:tgtEl>
+                                        <p:attrNameLst>
+                                          <p:attrName>style.visibility</p:attrName>
+                                        </p:attrNameLst>
+                                      </p:cBhvr>
+                                      <p:to>
+                                        <p:strVal val="visible"/>
+                                      </p:to>
+                                    </p:set>
+                                  </p:childTnLst>
+                                </p:cTn>
+                              </p:par>
+                            </p:childTnLst>
+                          </p:cTn>
+                        </p:par>
+                      </p:childTnLst>
+                    </p:cTn>
+                  </p:par>
+                  <p:par>
+                    <p:cTn id="28" fill="hold">
+                      <p:stCondLst>
+                        <p:cond delay="indefinite"/>
+                      </p:stCondLst>
+                      <p:childTnLst>
+                        <p:par>
+                          <p:cTn id="29" fill="hold">
+                            <p:stCondLst>
+                              <p:cond delay="0"/>
+                            </p:stCondLst>
+                            <p:childTnLst>
+                              <p:par>
+                                <p:cTn id="30" presetID="1" presetClass="entr" presetSubtype="0" fill="hold" grpId="0" nodeType="clickEffect">
+                                  <p:stCondLst>
+                                    <p:cond delay="0"/>
+                                  </p:stCondLst>
+                                  <p:childTnLst>
+                                    <p:set>
+                                      <p:cBhvr>
+                                        <p:cTn id="31" dur="1" fill="hold">
+                                          <p:stCondLst>
+                                            <p:cond delay="0"/>
+                                          </p:stCondLst>
+                                        </p:cTn>
+                                        <p:tgtEl>
+                                          <p:spTgt spid="16"/>
+                                        </p:tgtEl>
+                                        <p:attrNameLst>
+                                          <p:attrName>style.visibility</p:attrName>
+                                        </p:attrNameLst>
+                                      </p:cBhvr>
+                                      <p:to>
+                                        <p:strVal val="visible"/>
+                                      </p:to>
+                                    </p:set>
+                                  </p:childTnLst>
+                                </p:cTn>
+                              </p:par>
+                              <p:par>
+                                <p:cTn id="32" presetID="1" presetClass="entr" presetSubtype="0" fill="hold" grpId="0" nodeType="withEffect">
+                                  <p:stCondLst>
+                                    <p:cond delay="0"/>
+                                  </p:stCondLst>
+                                  <p:childTnLst>
+                                    <p:set>
+                                      <p:cBhvr>
+                                        <p:cTn id="33" dur="1" fill="hold">
+                                          <p:stCondLst>
+                                            <p:cond delay="0"/>
+                                          </p:stCondLst>
+                                        </p:cTn>
+                                        <p:tgtEl>
+                                          <p:spTgt spid="17"/>
+                                        </p:tgtEl>
+                                        <p:attrNameLst>
+                                          <p:attrName>style.visibility</p:attrName>
+                                        </p:attrNameLst>
+                                      </p:cBhvr>
+                                      <p:to>
+                                        <p:strVal val="visible"/>
+                                      </p:to>
+                                    </p:set>
+                                  </p:childTnLst>
+                                </p:cTn>
+                              </p:par>
+                            </p:childTnLst>
+                          </p:cTn>
+                        </p:par>
+                      </p:childTnLst>
+                    </p:cTn>
+                  </p:par>
+                </p:childTnLst>
+              </p:cTn>
+              <p:prevCondLst>
+                <p:cond evt="onPrev" delay="0">
+                  <p:tgtEl>
+                    <p:sldTgt/>
+                  </p:tgtEl>
+                </p:cond>
+              </p:prevCondLst>
+              <p:nextCondLst>
+                <p:cond evt="onNext" delay="0">
+                  <p:tgtEl>
+                    <p:sldTgt/>
+                  </p:tgtEl>
+                </p:cond>
+              </p:nextCondLst>
+            </p:seq>
+          </p:childTnLst>
+        </p:cTn>
+      </p:par>
+    </p:tnLst>
+    <p:bldLst>
+      <p:bldP spid="8" grpId="0"/>
+      <p:bldP spid="9" grpId="0"/>
+      <p:bldP spid="10" grpId="0"/>
+      <p:bldP spid="11" grpId="0"/>
+      <p:bldP spid="12" grpId="0"/>
+      <p:bldP spid="13" grpId="0"/>
+      <p:bldP spid="14" grpId="0"/>
+      <p:bldP spid="15" grpId="0"/>
+      <p:bldP spid="16" grpId="0"/>
+      <p:bldP spid="17" grpId="0"/>
+    </p:bldLst>
+  </p:timing>
 </p:sld>
 </file>
 
@@ -13524,7 +14236,7 @@
           <a:lstStyle/>
           <a:p>
             <a:r>
-              <a:t>Reflection: Missing Information &amp; Challenges</a:t>
+              <a:t>Reflection: Value &amp; Limitations</a:t>
             </a:r>
           </a:p>
         </p:txBody>
@@ -13611,7 +14323,7 @@
             </a:avLst>
           </a:prstGeom>
           <a:solidFill>
-            <a:srgbClr val="E37A00"/>
+            <a:srgbClr val="2E8B2E"/>
           </a:solidFill>
           <a:ln>
             <a:noFill/>
@@ -13643,7 +14355,7 @@
                   <a:srgbClr val="FFFFFF"/>
                 </a:solidFill>
               </a:rPr>
-              <a:t>Missing in the case material</a:t>
+              <a:t>Value</a:t>
             </a:r>
           </a:p>
         </p:txBody>
@@ -13681,7 +14393,7 @@
                   <a:srgbClr val="20252A"/>
                 </a:solidFill>
               </a:rPr>
-              <a:t>No infrastructure specs for the reservation side</a:t>
+              <a:t>One shared picture of five cooperating systems</a:t>
             </a:r>
           </a:p>
           <a:p>
@@ -13696,7 +14408,7 @@
                   <a:srgbClr val="20252A"/>
                 </a:solidFill>
               </a:rPr>
-              <a:t>Interfaces to external booking platforms unclear</a:t>
+              <a:t>Impact analysis: what breaks if the HMS is down?</a:t>
             </a:r>
           </a:p>
           <a:p>
@@ -13711,7 +14423,7 @@
                   <a:srgbClr val="20252A"/>
                 </a:solidFill>
               </a:rPr>
-              <a:t>No failure or volume data</a:t>
+              <a:t>Faster onboarding for new staff and developers</a:t>
             </a:r>
           </a:p>
         </p:txBody>
@@ -13781,7 +14493,7 @@
             </a:avLst>
           </a:prstGeom>
           <a:solidFill>
-            <a:srgbClr val="0065BD"/>
+            <a:srgbClr val="C40000"/>
           </a:solidFill>
           <a:ln>
             <a:noFill/>
@@ -13813,7 +14525,7 @@
                   <a:srgbClr val="FFFFFF"/>
                 </a:solidFill>
               </a:rPr>
-              <a:t>Our real challenges</a:t>
+              <a:t>Limitations</a:t>
             </a:r>
           </a:p>
         </p:txBody>
@@ -13851,7 +14563,7 @@
                   <a:srgbClr val="20252A"/>
                 </a:solidFill>
               </a:rPr>
-              <a:t>Finding the right abstraction level</a:t>
+              <a:t>A snapshot, with no process to keep it current</a:t>
             </a:r>
           </a:p>
           <a:p>
@@ -13866,7 +14578,7 @@
                   <a:srgbClr val="20252A"/>
                 </a:solidFill>
               </a:rPr>
-              <a:t>Keeping the abstract and detailed views consistent</a:t>
+              <a:t>No quantities, no SLAs, no capacity answers</a:t>
             </a:r>
           </a:p>
           <a:p>
@@ -13881,7 +14593,7 @@
                   <a:srgbClr val="20252A"/>
                 </a:solidFill>
               </a:rPr>
-              <a:t>Merge conflicts and duplicates from modeling in parallel</a:t>
+              <a:t>Abstraction hides detail by design</a:t>
             </a:r>
           </a:p>
         </p:txBody>
@@ -13985,11 +14697,7 @@
         <p:txBody>
           <a:bodyPr/>
           <a:lstStyle/>
-          <a:p>
-            <a:r>
-              <a:t>Thank you! Questions?</a:t>
-            </a:r>
-          </a:p>
+          <a:p/>
         </p:txBody>
       </p:sp>
       <p:sp>
@@ -14008,7 +14716,7 @@
           <a:lstStyle/>
           <a:p>
             <a:r>
-              <a:t>Summary</a:t>
+              <a:t>Reflection: Missing Information &amp; Challenges</a:t>
             </a:r>
           </a:p>
         </p:txBody>
@@ -14032,120 +14740,24 @@
       </p:sp>
       <p:sp>
         <p:nvSpPr>
-          <p:cNvPr id="6" name="TextBox 5"/>
-          <p:cNvSpPr txBox="1"/>
-          <p:nvPr/>
-        </p:nvSpPr>
-        <p:spPr>
-          <a:xfrm>
-            <a:off x="411480" y="1691640"/>
-            <a:ext cx="4480560" cy="3017520"/>
-          </a:xfrm>
-          <a:prstGeom prst="rect">
-            <a:avLst/>
-          </a:prstGeom>
-          <a:noFill/>
-        </p:spPr>
-        <p:txBody>
-          <a:bodyPr wrap="square">
-            <a:spAutoFit/>
-          </a:bodyPr>
-          <a:lstStyle/>
-          <a:p>
-            <a:pPr algn="l">
-              <a:spcAft>
-                <a:spcPts val="1000"/>
-              </a:spcAft>
-            </a:pPr>
-            <a:r>
-              <a:rPr sz="1700">
-                <a:solidFill>
-                  <a:srgbClr val="20252A"/>
-                </a:solidFill>
-              </a:rPr>
-              <a:t>F1 modeled across all three layers</a:t>
-            </a:r>
-          </a:p>
-          <a:p>
-            <a:pPr algn="l">
-              <a:spcAft>
-                <a:spcPts val="1000"/>
-              </a:spcAft>
-            </a:pPr>
-            <a:r>
-              <a:rPr sz="1700">
-                <a:solidFill>
-                  <a:srgbClr val="20252A"/>
-                </a:solidFill>
-              </a:rPr>
-              <a:t>Everything converges on the HMS</a:t>
-            </a:r>
-          </a:p>
-          <a:p>
-            <a:pPr algn="l">
-              <a:spcAft>
-                <a:spcPts val="1000"/>
-              </a:spcAft>
-            </a:pPr>
-            <a:r>
-              <a:rPr sz="1700">
-                <a:solidFill>
-                  <a:srgbClr val="20252A"/>
-                </a:solidFill>
-              </a:rPr>
-              <a:t>The map first, then one story per layer</a:t>
-            </a:r>
-          </a:p>
-          <a:p>
-            <a:pPr algn="l">
-              <a:spcAft>
-                <a:spcPts val="1000"/>
-              </a:spcAft>
-            </a:pPr>
-            <a:r>
-              <a:rPr sz="1700">
-                <a:solidFill>
-                  <a:srgbClr val="20252A"/>
-                </a:solidFill>
-              </a:rPr>
-              <a:t>Value: transparency and impact analysis</a:t>
-            </a:r>
-          </a:p>
-          <a:p>
-            <a:pPr algn="l">
-              <a:spcAft>
-                <a:spcPts val="1000"/>
-              </a:spcAft>
-            </a:pPr>
-            <a:r>
-              <a:rPr sz="1700">
-                <a:solidFill>
-                  <a:srgbClr val="20252A"/>
-                </a:solidFill>
-              </a:rPr>
-              <a:t>Limits: a snapshot, no quantities</a:t>
-            </a:r>
-          </a:p>
-        </p:txBody>
-      </p:sp>
-      <p:sp>
-        <p:nvSpPr>
-          <p:cNvPr id="7" name="Rectangle 6"/>
+          <p:cNvPr id="6" name="Rounded Rectangle 5"/>
           <p:cNvSpPr/>
           <p:nvPr/>
         </p:nvSpPr>
         <p:spPr>
           <a:xfrm>
-            <a:off x="5102352" y="1861468"/>
-            <a:ext cx="3785615" cy="2586422"/>
-          </a:xfrm>
-          <a:prstGeom prst="rect">
-            <a:avLst/>
-          </a:prstGeom>
-          <a:solidFill>
-            <a:srgbClr val="FFFFFF"/>
-          </a:solidFill>
-          <a:ln w="6350">
+            <a:off x="411480" y="1554480"/>
+            <a:ext cx="4069080" cy="3017520"/>
+          </a:xfrm>
+          <a:prstGeom prst="roundRect">
+            <a:avLst>
+              <a:gd name="adj" fmla="val 5000"/>
+            </a:avLst>
+          </a:prstGeom>
+          <a:solidFill>
+            <a:srgbClr val="F6F9FC"/>
+          </a:solidFill>
+          <a:ln w="9525">
             <a:solidFill>
               <a:srgbClr val="D0D8DF"/>
             </a:solidFill>
@@ -14174,33 +14786,301 @@
           </a:p>
         </p:txBody>
       </p:sp>
-      <p:pic>
-        <p:nvPicPr>
-          <p:cNvPr id="8" name="Picture 7" descr="abstract_full.png"/>
-          <p:cNvPicPr>
-            <a:picLocks noChangeAspect="1"/>
-          </p:cNvPicPr>
+      <p:sp>
+        <p:nvSpPr>
+          <p:cNvPr id="7" name="Rounded Rectangle 6"/>
+          <p:cNvSpPr/>
           <p:nvPr/>
-        </p:nvPicPr>
-        <p:blipFill>
-          <a:blip r:embed="rId2"/>
-          <a:stretch>
-            <a:fillRect/>
-          </a:stretch>
-        </p:blipFill>
-        <p:spPr>
-          <a:xfrm>
-            <a:off x="5120640" y="1879756"/>
-            <a:ext cx="3749039" cy="2549846"/>
+        </p:nvSpPr>
+        <p:spPr>
+          <a:xfrm>
+            <a:off x="411480" y="1554480"/>
+            <a:ext cx="4069080" cy="365760"/>
+          </a:xfrm>
+          <a:prstGeom prst="roundRect">
+            <a:avLst>
+              <a:gd name="adj" fmla="val 50000"/>
+            </a:avLst>
+          </a:prstGeom>
+          <a:solidFill>
+            <a:srgbClr val="E37A00"/>
+          </a:solidFill>
+          <a:ln>
+            <a:noFill/>
+          </a:ln>
+          <a:effectLst/>
+        </p:spPr>
+        <p:style>
+          <a:lnRef idx="1">
+            <a:schemeClr val="accent1"/>
+          </a:lnRef>
+          <a:fillRef idx="3">
+            <a:schemeClr val="accent1"/>
+          </a:fillRef>
+          <a:effectRef idx="2">
+            <a:schemeClr val="accent1"/>
+          </a:effectRef>
+          <a:fontRef idx="minor">
+            <a:schemeClr val="lt1"/>
+          </a:fontRef>
+        </p:style>
+        <p:txBody>
+          <a:bodyPr rtlCol="0" anchor="ctr" tIns="12700" bIns="12700"/>
+          <a:lstStyle/>
+          <a:p>
+            <a:pPr algn="ctr"/>
+            <a:r>
+              <a:rPr b="1" sz="1600">
+                <a:solidFill>
+                  <a:srgbClr val="FFFFFF"/>
+                </a:solidFill>
+              </a:rPr>
+              <a:t>Missing in the case material</a:t>
+            </a:r>
+          </a:p>
+        </p:txBody>
+      </p:sp>
+      <p:sp>
+        <p:nvSpPr>
+          <p:cNvPr id="8" name="TextBox 7"/>
+          <p:cNvSpPr txBox="1"/>
+          <p:nvPr/>
+        </p:nvSpPr>
+        <p:spPr>
+          <a:xfrm>
+            <a:off x="502920" y="1975104"/>
+            <a:ext cx="3886200" cy="2523744"/>
           </a:xfrm>
           <a:prstGeom prst="rect">
             <a:avLst/>
           </a:prstGeom>
-        </p:spPr>
-      </p:pic>
-      <p:sp>
-        <p:nvSpPr>
-          <p:cNvPr id="9" name="TextBox 8"/>
+          <a:noFill/>
+        </p:spPr>
+        <p:txBody>
+          <a:bodyPr wrap="square">
+            <a:spAutoFit/>
+          </a:bodyPr>
+          <a:lstStyle/>
+          <a:p>
+            <a:pPr>
+              <a:spcAft>
+                <a:spcPts val="600"/>
+              </a:spcAft>
+            </a:pPr>
+            <a:r>
+              <a:rPr sz="1600">
+                <a:solidFill>
+                  <a:srgbClr val="20252A"/>
+                </a:solidFill>
+              </a:rPr>
+              <a:t>No infrastructure specs for the reservation side</a:t>
+            </a:r>
+          </a:p>
+          <a:p>
+            <a:pPr>
+              <a:spcAft>
+                <a:spcPts val="600"/>
+              </a:spcAft>
+            </a:pPr>
+            <a:r>
+              <a:rPr sz="1600">
+                <a:solidFill>
+                  <a:srgbClr val="20252A"/>
+                </a:solidFill>
+              </a:rPr>
+              <a:t>Interfaces to external booking platforms unclear</a:t>
+            </a:r>
+          </a:p>
+          <a:p>
+            <a:pPr>
+              <a:spcAft>
+                <a:spcPts val="600"/>
+              </a:spcAft>
+            </a:pPr>
+            <a:r>
+              <a:rPr sz="1600">
+                <a:solidFill>
+                  <a:srgbClr val="20252A"/>
+                </a:solidFill>
+              </a:rPr>
+              <a:t>No failure or volume data</a:t>
+            </a:r>
+          </a:p>
+        </p:txBody>
+      </p:sp>
+      <p:sp>
+        <p:nvSpPr>
+          <p:cNvPr id="9" name="Rounded Rectangle 8"/>
+          <p:cNvSpPr/>
+          <p:nvPr/>
+        </p:nvSpPr>
+        <p:spPr>
+          <a:xfrm>
+            <a:off x="4663440" y="1554480"/>
+            <a:ext cx="4069080" cy="3017520"/>
+          </a:xfrm>
+          <a:prstGeom prst="roundRect">
+            <a:avLst>
+              <a:gd name="adj" fmla="val 5000"/>
+            </a:avLst>
+          </a:prstGeom>
+          <a:solidFill>
+            <a:srgbClr val="F6F9FC"/>
+          </a:solidFill>
+          <a:ln w="9525">
+            <a:solidFill>
+              <a:srgbClr val="D0D8DF"/>
+            </a:solidFill>
+          </a:ln>
+          <a:effectLst/>
+        </p:spPr>
+        <p:style>
+          <a:lnRef idx="1">
+            <a:schemeClr val="accent1"/>
+          </a:lnRef>
+          <a:fillRef idx="3">
+            <a:schemeClr val="accent1"/>
+          </a:fillRef>
+          <a:effectRef idx="2">
+            <a:schemeClr val="accent1"/>
+          </a:effectRef>
+          <a:fontRef idx="minor">
+            <a:schemeClr val="lt1"/>
+          </a:fontRef>
+        </p:style>
+        <p:txBody>
+          <a:bodyPr rtlCol="0" anchor="ctr"/>
+          <a:lstStyle/>
+          <a:p>
+            <a:pPr algn="ctr"/>
+          </a:p>
+        </p:txBody>
+      </p:sp>
+      <p:sp>
+        <p:nvSpPr>
+          <p:cNvPr id="10" name="Rounded Rectangle 9"/>
+          <p:cNvSpPr/>
+          <p:nvPr/>
+        </p:nvSpPr>
+        <p:spPr>
+          <a:xfrm>
+            <a:off x="4663440" y="1554480"/>
+            <a:ext cx="4069080" cy="365760"/>
+          </a:xfrm>
+          <a:prstGeom prst="roundRect">
+            <a:avLst>
+              <a:gd name="adj" fmla="val 50000"/>
+            </a:avLst>
+          </a:prstGeom>
+          <a:solidFill>
+            <a:srgbClr val="0065BD"/>
+          </a:solidFill>
+          <a:ln>
+            <a:noFill/>
+          </a:ln>
+          <a:effectLst/>
+        </p:spPr>
+        <p:style>
+          <a:lnRef idx="1">
+            <a:schemeClr val="accent1"/>
+          </a:lnRef>
+          <a:fillRef idx="3">
+            <a:schemeClr val="accent1"/>
+          </a:fillRef>
+          <a:effectRef idx="2">
+            <a:schemeClr val="accent1"/>
+          </a:effectRef>
+          <a:fontRef idx="minor">
+            <a:schemeClr val="lt1"/>
+          </a:fontRef>
+        </p:style>
+        <p:txBody>
+          <a:bodyPr rtlCol="0" anchor="ctr" tIns="12700" bIns="12700"/>
+          <a:lstStyle/>
+          <a:p>
+            <a:pPr algn="ctr"/>
+            <a:r>
+              <a:rPr b="1" sz="1600">
+                <a:solidFill>
+                  <a:srgbClr val="FFFFFF"/>
+                </a:solidFill>
+              </a:rPr>
+              <a:t>Our real challenges</a:t>
+            </a:r>
+          </a:p>
+        </p:txBody>
+      </p:sp>
+      <p:sp>
+        <p:nvSpPr>
+          <p:cNvPr id="11" name="TextBox 10"/>
+          <p:cNvSpPr txBox="1"/>
+          <p:nvPr/>
+        </p:nvSpPr>
+        <p:spPr>
+          <a:xfrm>
+            <a:off x="4754879" y="1975104"/>
+            <a:ext cx="3886200" cy="2523744"/>
+          </a:xfrm>
+          <a:prstGeom prst="rect">
+            <a:avLst/>
+          </a:prstGeom>
+          <a:noFill/>
+        </p:spPr>
+        <p:txBody>
+          <a:bodyPr wrap="square">
+            <a:spAutoFit/>
+          </a:bodyPr>
+          <a:lstStyle/>
+          <a:p>
+            <a:pPr>
+              <a:spcAft>
+                <a:spcPts val="600"/>
+              </a:spcAft>
+            </a:pPr>
+            <a:r>
+              <a:rPr sz="1600">
+                <a:solidFill>
+                  <a:srgbClr val="20252A"/>
+                </a:solidFill>
+              </a:rPr>
+              <a:t>Finding the right abstraction level</a:t>
+            </a:r>
+          </a:p>
+          <a:p>
+            <a:pPr>
+              <a:spcAft>
+                <a:spcPts val="600"/>
+              </a:spcAft>
+            </a:pPr>
+            <a:r>
+              <a:rPr sz="1600">
+                <a:solidFill>
+                  <a:srgbClr val="20252A"/>
+                </a:solidFill>
+              </a:rPr>
+              <a:t>Keeping the abstract and detailed views consistent</a:t>
+            </a:r>
+          </a:p>
+          <a:p>
+            <a:pPr>
+              <a:spcAft>
+                <a:spcPts val="600"/>
+              </a:spcAft>
+            </a:pPr>
+            <a:r>
+              <a:rPr sz="1600">
+                <a:solidFill>
+                  <a:srgbClr val="20252A"/>
+                </a:solidFill>
+              </a:rPr>
+              <a:t>Merge conflicts and duplicates from modeling in parallel</a:t>
+            </a:r>
+          </a:p>
+        </p:txBody>
+      </p:sp>
+      <p:sp>
+        <p:nvSpPr>
+          <p:cNvPr id="12" name="TextBox 11"/>
           <p:cNvSpPr txBox="1"/>
           <p:nvPr/>
         </p:nvSpPr>
@@ -14233,7 +15113,7 @@
       </p:sp>
       <p:sp>
         <p:nvSpPr>
-          <p:cNvPr id="10" name="TextBox 9"/>
+          <p:cNvPr id="13" name="TextBox 12"/>
           <p:cNvSpPr txBox="1"/>
           <p:nvPr/>
         </p:nvSpPr>
@@ -14285,7 +15165,28 @@
       <p:grpSpPr/>
       <p:sp>
         <p:nvSpPr>
-          <p:cNvPr id="2" name="Title 1"/>
+          <p:cNvPr id="3" name="Text Placeholder 2"/>
+          <p:cNvSpPr>
+            <a:spLocks noGrp="1"/>
+          </p:cNvSpPr>
+          <p:nvPr>
+            <p:ph type="body" idx="13" sz="quarter"/>
+          </p:nvPr>
+        </p:nvSpPr>
+        <p:spPr/>
+        <p:txBody>
+          <a:bodyPr/>
+          <a:lstStyle/>
+          <a:p>
+            <a:r>
+              <a:t>Thank you! Questions?</a:t>
+            </a:r>
+          </a:p>
+        </p:txBody>
+      </p:sp>
+      <p:sp>
+        <p:nvSpPr>
+          <p:cNvPr id="4" name="Title 3"/>
           <p:cNvSpPr>
             <a:spLocks noGrp="1"/>
           </p:cNvSpPr>
@@ -14299,7 +15200,259 @@
           <a:lstStyle/>
           <a:p>
             <a:r>
-              <a:t>Backup</a:t>
+              <a:t>Summary</a:t>
+            </a:r>
+          </a:p>
+        </p:txBody>
+      </p:sp>
+      <p:sp>
+        <p:nvSpPr>
+          <p:cNvPr id="5" name="Text Placeholder 4"/>
+          <p:cNvSpPr>
+            <a:spLocks noGrp="1"/>
+          </p:cNvSpPr>
+          <p:nvPr>
+            <p:ph type="body" idx="14" sz="quarter"/>
+          </p:nvPr>
+        </p:nvSpPr>
+        <p:spPr/>
+        <p:txBody>
+          <a:bodyPr/>
+          <a:lstStyle/>
+          <a:p/>
+        </p:txBody>
+      </p:sp>
+      <p:sp>
+        <p:nvSpPr>
+          <p:cNvPr id="6" name="TextBox 5"/>
+          <p:cNvSpPr txBox="1"/>
+          <p:nvPr/>
+        </p:nvSpPr>
+        <p:spPr>
+          <a:xfrm>
+            <a:off x="411480" y="1691640"/>
+            <a:ext cx="4480560" cy="3017520"/>
+          </a:xfrm>
+          <a:prstGeom prst="rect">
+            <a:avLst/>
+          </a:prstGeom>
+          <a:noFill/>
+        </p:spPr>
+        <p:txBody>
+          <a:bodyPr wrap="square">
+            <a:spAutoFit/>
+          </a:bodyPr>
+          <a:lstStyle/>
+          <a:p>
+            <a:pPr algn="l">
+              <a:spcAft>
+                <a:spcPts val="1000"/>
+              </a:spcAft>
+            </a:pPr>
+            <a:r>
+              <a:rPr sz="1700">
+                <a:solidFill>
+                  <a:srgbClr val="20252A"/>
+                </a:solidFill>
+              </a:rPr>
+              <a:t>F1 modeled across all three layers</a:t>
+            </a:r>
+          </a:p>
+          <a:p>
+            <a:pPr algn="l">
+              <a:spcAft>
+                <a:spcPts val="1000"/>
+              </a:spcAft>
+            </a:pPr>
+            <a:r>
+              <a:rPr sz="1700">
+                <a:solidFill>
+                  <a:srgbClr val="20252A"/>
+                </a:solidFill>
+              </a:rPr>
+              <a:t>Everything converges on the HMS</a:t>
+            </a:r>
+          </a:p>
+          <a:p>
+            <a:pPr algn="l">
+              <a:spcAft>
+                <a:spcPts val="1000"/>
+              </a:spcAft>
+            </a:pPr>
+            <a:r>
+              <a:rPr sz="1700">
+                <a:solidFill>
+                  <a:srgbClr val="20252A"/>
+                </a:solidFill>
+              </a:rPr>
+              <a:t>The map first, then one story per layer</a:t>
+            </a:r>
+          </a:p>
+          <a:p>
+            <a:pPr algn="l">
+              <a:spcAft>
+                <a:spcPts val="1000"/>
+              </a:spcAft>
+            </a:pPr>
+            <a:r>
+              <a:rPr sz="1700">
+                <a:solidFill>
+                  <a:srgbClr val="20252A"/>
+                </a:solidFill>
+              </a:rPr>
+              <a:t>Value: transparency and impact analysis</a:t>
+            </a:r>
+          </a:p>
+          <a:p>
+            <a:pPr algn="l">
+              <a:spcAft>
+                <a:spcPts val="1000"/>
+              </a:spcAft>
+            </a:pPr>
+            <a:r>
+              <a:rPr sz="1700">
+                <a:solidFill>
+                  <a:srgbClr val="20252A"/>
+                </a:solidFill>
+              </a:rPr>
+              <a:t>Limits: a snapshot, no quantities</a:t>
+            </a:r>
+          </a:p>
+        </p:txBody>
+      </p:sp>
+      <p:sp>
+        <p:nvSpPr>
+          <p:cNvPr id="7" name="Rectangle 6"/>
+          <p:cNvSpPr/>
+          <p:nvPr/>
+        </p:nvSpPr>
+        <p:spPr>
+          <a:xfrm>
+            <a:off x="5102352" y="1861468"/>
+            <a:ext cx="3785615" cy="2586422"/>
+          </a:xfrm>
+          <a:prstGeom prst="rect">
+            <a:avLst/>
+          </a:prstGeom>
+          <a:solidFill>
+            <a:srgbClr val="FFFFFF"/>
+          </a:solidFill>
+          <a:ln w="6350">
+            <a:solidFill>
+              <a:srgbClr val="D0D8DF"/>
+            </a:solidFill>
+          </a:ln>
+          <a:effectLst/>
+        </p:spPr>
+        <p:style>
+          <a:lnRef idx="1">
+            <a:schemeClr val="accent1"/>
+          </a:lnRef>
+          <a:fillRef idx="3">
+            <a:schemeClr val="accent1"/>
+          </a:fillRef>
+          <a:effectRef idx="2">
+            <a:schemeClr val="accent1"/>
+          </a:effectRef>
+          <a:fontRef idx="minor">
+            <a:schemeClr val="lt1"/>
+          </a:fontRef>
+        </p:style>
+        <p:txBody>
+          <a:bodyPr rtlCol="0" anchor="ctr"/>
+          <a:lstStyle/>
+          <a:p>
+            <a:pPr algn="ctr"/>
+          </a:p>
+        </p:txBody>
+      </p:sp>
+      <p:pic>
+        <p:nvPicPr>
+          <p:cNvPr id="8" name="Picture 7" descr="abstract_full.png"/>
+          <p:cNvPicPr>
+            <a:picLocks noChangeAspect="1"/>
+          </p:cNvPicPr>
+          <p:nvPr/>
+        </p:nvPicPr>
+        <p:blipFill>
+          <a:blip r:embed="rId2"/>
+          <a:stretch>
+            <a:fillRect/>
+          </a:stretch>
+        </p:blipFill>
+        <p:spPr>
+          <a:xfrm>
+            <a:off x="5120640" y="1879756"/>
+            <a:ext cx="3749039" cy="2549846"/>
+          </a:xfrm>
+          <a:prstGeom prst="rect">
+            <a:avLst/>
+          </a:prstGeom>
+        </p:spPr>
+      </p:pic>
+      <p:sp>
+        <p:nvSpPr>
+          <p:cNvPr id="9" name="TextBox 8"/>
+          <p:cNvSpPr txBox="1"/>
+          <p:nvPr/>
+        </p:nvSpPr>
+        <p:spPr>
+          <a:xfrm>
+            <a:off x="310896" y="4864608"/>
+            <a:ext cx="6949440" cy="237744"/>
+          </a:xfrm>
+          <a:prstGeom prst="rect">
+            <a:avLst/>
+          </a:prstGeom>
+          <a:noFill/>
+        </p:spPr>
+        <p:txBody>
+          <a:bodyPr wrap="none">
+            <a:spAutoFit/>
+          </a:bodyPr>
+          <a:lstStyle/>
+          <a:p>
+            <a:r>
+              <a:rPr sz="800">
+                <a:solidFill>
+                  <a:srgbClr val="606060"/>
+                </a:solidFill>
+              </a:rPr>
+              <a:t>EAM Case Study ArchiHotel · Group C2F1G4</a:t>
+            </a:r>
+          </a:p>
+        </p:txBody>
+      </p:sp>
+      <p:sp>
+        <p:nvSpPr>
+          <p:cNvPr id="10" name="TextBox 9"/>
+          <p:cNvSpPr txBox="1"/>
+          <p:nvPr/>
+        </p:nvSpPr>
+        <p:spPr>
+          <a:xfrm>
+            <a:off x="8321040" y="4864608"/>
+            <a:ext cx="548640" cy="237744"/>
+          </a:xfrm>
+          <a:prstGeom prst="rect">
+            <a:avLst/>
+          </a:prstGeom>
+          <a:noFill/>
+        </p:spPr>
+        <p:txBody>
+          <a:bodyPr wrap="none">
+            <a:spAutoFit/>
+          </a:bodyPr>
+          <a:lstStyle/>
+          <a:p>
+            <a:pPr algn="r"/>
+            <a:r>
+              <a:rPr sz="800">
+                <a:solidFill>
+                  <a:srgbClr val="606060"/>
+                </a:solidFill>
+              </a:rPr>
+              <a:t>13</a:t>
             </a:r>
           </a:p>
         </p:txBody>
@@ -14324,28 +15477,7 @@
       <p:grpSpPr/>
       <p:sp>
         <p:nvSpPr>
-          <p:cNvPr id="3" name="Text Placeholder 2"/>
-          <p:cNvSpPr>
-            <a:spLocks noGrp="1"/>
-          </p:cNvSpPr>
-          <p:nvPr>
-            <p:ph type="body" idx="13" sz="quarter"/>
-          </p:nvPr>
-        </p:nvSpPr>
-        <p:spPr/>
-        <p:txBody>
-          <a:bodyPr/>
-          <a:lstStyle/>
-          <a:p>
-            <a:r>
-              <a:t>Detailed · F1 Reservation &amp; Check-In · 86 objects · 160 connections</a:t>
-            </a:r>
-          </a:p>
-        </p:txBody>
-      </p:sp>
-      <p:sp>
-        <p:nvSpPr>
-          <p:cNvPr id="4" name="Title 3"/>
+          <p:cNvPr id="2" name="Title 1"/>
           <p:cNvSpPr>
             <a:spLocks noGrp="1"/>
           </p:cNvSpPr>
@@ -14359,161 +15491,7 @@
           <a:lstStyle/>
           <a:p>
             <a:r>
-              <a:t>Backup: Detailed View, Complete</a:t>
-            </a:r>
-          </a:p>
-        </p:txBody>
-      </p:sp>
-      <p:sp>
-        <p:nvSpPr>
-          <p:cNvPr id="5" name="Text Placeholder 4"/>
-          <p:cNvSpPr>
-            <a:spLocks noGrp="1"/>
-          </p:cNvSpPr>
-          <p:nvPr>
-            <p:ph type="body" idx="14" sz="quarter"/>
-          </p:nvPr>
-        </p:nvSpPr>
-        <p:spPr/>
-        <p:txBody>
-          <a:bodyPr/>
-          <a:lstStyle/>
-          <a:p/>
-        </p:txBody>
-      </p:sp>
-      <p:sp>
-        <p:nvSpPr>
-          <p:cNvPr id="6" name="Rectangle 5"/>
-          <p:cNvSpPr/>
-          <p:nvPr/>
-        </p:nvSpPr>
-        <p:spPr>
-          <a:xfrm>
-            <a:off x="3312768" y="1463040"/>
-            <a:ext cx="2701342" cy="3438144"/>
-          </a:xfrm>
-          <a:prstGeom prst="rect">
-            <a:avLst/>
-          </a:prstGeom>
-          <a:solidFill>
-            <a:srgbClr val="FFFFFF"/>
-          </a:solidFill>
-          <a:ln w="6350">
-            <a:solidFill>
-              <a:srgbClr val="D0D8DF"/>
-            </a:solidFill>
-          </a:ln>
-          <a:effectLst/>
-        </p:spPr>
-        <p:style>
-          <a:lnRef idx="1">
-            <a:schemeClr val="accent1"/>
-          </a:lnRef>
-          <a:fillRef idx="3">
-            <a:schemeClr val="accent1"/>
-          </a:fillRef>
-          <a:effectRef idx="2">
-            <a:schemeClr val="accent1"/>
-          </a:effectRef>
-          <a:fontRef idx="minor">
-            <a:schemeClr val="lt1"/>
-          </a:fontRef>
-        </p:style>
-        <p:txBody>
-          <a:bodyPr rtlCol="0" anchor="ctr"/>
-          <a:lstStyle/>
-          <a:p>
-            <a:pPr algn="ctr"/>
-          </a:p>
-        </p:txBody>
-      </p:sp>
-      <p:pic>
-        <p:nvPicPr>
-          <p:cNvPr id="7" name="Picture 6" descr="detailed_full.png"/>
-          <p:cNvPicPr>
-            <a:picLocks noChangeAspect="1"/>
-          </p:cNvPicPr>
-          <p:nvPr/>
-        </p:nvPicPr>
-        <p:blipFill>
-          <a:blip r:embed="rId2"/>
-          <a:stretch>
-            <a:fillRect/>
-          </a:stretch>
-        </p:blipFill>
-        <p:spPr>
-          <a:xfrm>
-            <a:off x="3331056" y="1481328"/>
-            <a:ext cx="2664766" cy="3401568"/>
-          </a:xfrm>
-          <a:prstGeom prst="rect">
-            <a:avLst/>
-          </a:prstGeom>
-        </p:spPr>
-      </p:pic>
-      <p:sp>
-        <p:nvSpPr>
-          <p:cNvPr id="8" name="TextBox 7"/>
-          <p:cNvSpPr txBox="1"/>
-          <p:nvPr/>
-        </p:nvSpPr>
-        <p:spPr>
-          <a:xfrm>
-            <a:off x="310896" y="4864608"/>
-            <a:ext cx="6949440" cy="237744"/>
-          </a:xfrm>
-          <a:prstGeom prst="rect">
-            <a:avLst/>
-          </a:prstGeom>
-          <a:noFill/>
-        </p:spPr>
-        <p:txBody>
-          <a:bodyPr wrap="none">
-            <a:spAutoFit/>
-          </a:bodyPr>
-          <a:lstStyle/>
-          <a:p>
-            <a:r>
-              <a:rPr sz="800">
-                <a:solidFill>
-                  <a:srgbClr val="606060"/>
-                </a:solidFill>
-              </a:rPr>
-              <a:t>EAM Case Study ArchiHotel · Group C2F1G4</a:t>
-            </a:r>
-          </a:p>
-        </p:txBody>
-      </p:sp>
-      <p:sp>
-        <p:nvSpPr>
-          <p:cNvPr id="9" name="TextBox 8"/>
-          <p:cNvSpPr txBox="1"/>
-          <p:nvPr/>
-        </p:nvSpPr>
-        <p:spPr>
-          <a:xfrm>
-            <a:off x="8321040" y="4864608"/>
-            <a:ext cx="548640" cy="237744"/>
-          </a:xfrm>
-          <a:prstGeom prst="rect">
-            <a:avLst/>
-          </a:prstGeom>
-          <a:noFill/>
-        </p:spPr>
-        <p:txBody>
-          <a:bodyPr wrap="none">
-            <a:spAutoFit/>
-          </a:bodyPr>
-          <a:lstStyle/>
-          <a:p>
-            <a:pPr algn="r"/>
-            <a:r>
-              <a:rPr sz="800">
-                <a:solidFill>
-                  <a:srgbClr val="606060"/>
-                </a:solidFill>
-              </a:rPr>
-              <a:t>14</a:t>
+              <a:t>Backup</a:t>
             </a:r>
           </a:p>
         </p:txBody>
@@ -14552,7 +15530,7 @@
           <a:lstStyle/>
           <a:p>
             <a:r>
-              <a:t>Abstract · ArchiHotel EA · 72 objects · 98 connections</a:t>
+              <a:t>Detailed · F1 Reservation &amp; Check-In · 86 objects · 160 connections</a:t>
             </a:r>
           </a:p>
         </p:txBody>
@@ -14573,7 +15551,7 @@
           <a:lstStyle/>
           <a:p>
             <a:r>
-              <a:t>Backup: Abstract View, Complete</a:t>
+              <a:t>Backup: Detailed View, Complete</a:t>
             </a:r>
           </a:p>
         </p:txBody>
@@ -14603,8 +15581,8 @@
         </p:nvSpPr>
         <p:spPr>
           <a:xfrm>
-            <a:off x="2053048" y="1463040"/>
-            <a:ext cx="5037903" cy="3438144"/>
+            <a:off x="3312768" y="1463040"/>
+            <a:ext cx="2701342" cy="3438144"/>
           </a:xfrm>
           <a:prstGeom prst="rect">
             <a:avLst/>
@@ -14643,7 +15621,7 @@
       </p:sp>
       <p:pic>
         <p:nvPicPr>
-          <p:cNvPr id="7" name="Picture 6" descr="abstract_full.png"/>
+          <p:cNvPr id="7" name="Picture 6" descr="detailed_full.png"/>
           <p:cNvPicPr>
             <a:picLocks noChangeAspect="1"/>
           </p:cNvPicPr>
@@ -14657,8 +15635,8 @@
         </p:blipFill>
         <p:spPr>
           <a:xfrm>
-            <a:off x="2071336" y="1481328"/>
-            <a:ext cx="5001327" cy="3401568"/>
+            <a:off x="3331056" y="1481328"/>
+            <a:ext cx="2664766" cy="3401568"/>
           </a:xfrm>
           <a:prstGeom prst="rect">
             <a:avLst/>
@@ -14764,7 +15742,11 @@
         <p:txBody>
           <a:bodyPr/>
           <a:lstStyle/>
-          <a:p/>
+          <a:p>
+            <a:r>
+              <a:t>Abstract · ArchiHotel EA · 72 objects · 98 connections</a:t>
+            </a:r>
+          </a:p>
         </p:txBody>
       </p:sp>
       <p:sp>
@@ -14783,7 +15765,7 @@
           <a:lstStyle/>
           <a:p>
             <a:r>
-              <a:t>Backup: Model Facts</a:t>
+              <a:t>Backup: Abstract View, Complete</a:t>
             </a:r>
           </a:p>
         </p:txBody>
@@ -14807,6 +15789,216 @@
       </p:sp>
       <p:sp>
         <p:nvSpPr>
+          <p:cNvPr id="6" name="Rectangle 5"/>
+          <p:cNvSpPr/>
+          <p:nvPr/>
+        </p:nvSpPr>
+        <p:spPr>
+          <a:xfrm>
+            <a:off x="2053048" y="1463040"/>
+            <a:ext cx="5037903" cy="3438144"/>
+          </a:xfrm>
+          <a:prstGeom prst="rect">
+            <a:avLst/>
+          </a:prstGeom>
+          <a:solidFill>
+            <a:srgbClr val="FFFFFF"/>
+          </a:solidFill>
+          <a:ln w="6350">
+            <a:solidFill>
+              <a:srgbClr val="D0D8DF"/>
+            </a:solidFill>
+          </a:ln>
+          <a:effectLst/>
+        </p:spPr>
+        <p:style>
+          <a:lnRef idx="1">
+            <a:schemeClr val="accent1"/>
+          </a:lnRef>
+          <a:fillRef idx="3">
+            <a:schemeClr val="accent1"/>
+          </a:fillRef>
+          <a:effectRef idx="2">
+            <a:schemeClr val="accent1"/>
+          </a:effectRef>
+          <a:fontRef idx="minor">
+            <a:schemeClr val="lt1"/>
+          </a:fontRef>
+        </p:style>
+        <p:txBody>
+          <a:bodyPr rtlCol="0" anchor="ctr"/>
+          <a:lstStyle/>
+          <a:p>
+            <a:pPr algn="ctr"/>
+          </a:p>
+        </p:txBody>
+      </p:sp>
+      <p:pic>
+        <p:nvPicPr>
+          <p:cNvPr id="7" name="Picture 6" descr="abstract_full.png"/>
+          <p:cNvPicPr>
+            <a:picLocks noChangeAspect="1"/>
+          </p:cNvPicPr>
+          <p:nvPr/>
+        </p:nvPicPr>
+        <p:blipFill>
+          <a:blip r:embed="rId2"/>
+          <a:stretch>
+            <a:fillRect/>
+          </a:stretch>
+        </p:blipFill>
+        <p:spPr>
+          <a:xfrm>
+            <a:off x="2071336" y="1481328"/>
+            <a:ext cx="5001327" cy="3401568"/>
+          </a:xfrm>
+          <a:prstGeom prst="rect">
+            <a:avLst/>
+          </a:prstGeom>
+        </p:spPr>
+      </p:pic>
+      <p:sp>
+        <p:nvSpPr>
+          <p:cNvPr id="8" name="TextBox 7"/>
+          <p:cNvSpPr txBox="1"/>
+          <p:nvPr/>
+        </p:nvSpPr>
+        <p:spPr>
+          <a:xfrm>
+            <a:off x="310896" y="4864608"/>
+            <a:ext cx="6949440" cy="237744"/>
+          </a:xfrm>
+          <a:prstGeom prst="rect">
+            <a:avLst/>
+          </a:prstGeom>
+          <a:noFill/>
+        </p:spPr>
+        <p:txBody>
+          <a:bodyPr wrap="none">
+            <a:spAutoFit/>
+          </a:bodyPr>
+          <a:lstStyle/>
+          <a:p>
+            <a:r>
+              <a:rPr sz="800">
+                <a:solidFill>
+                  <a:srgbClr val="606060"/>
+                </a:solidFill>
+              </a:rPr>
+              <a:t>EAM Case Study ArchiHotel · Group C2F1G4</a:t>
+            </a:r>
+          </a:p>
+        </p:txBody>
+      </p:sp>
+      <p:sp>
+        <p:nvSpPr>
+          <p:cNvPr id="9" name="TextBox 8"/>
+          <p:cNvSpPr txBox="1"/>
+          <p:nvPr/>
+        </p:nvSpPr>
+        <p:spPr>
+          <a:xfrm>
+            <a:off x="8321040" y="4864608"/>
+            <a:ext cx="548640" cy="237744"/>
+          </a:xfrm>
+          <a:prstGeom prst="rect">
+            <a:avLst/>
+          </a:prstGeom>
+          <a:noFill/>
+        </p:spPr>
+        <p:txBody>
+          <a:bodyPr wrap="none">
+            <a:spAutoFit/>
+          </a:bodyPr>
+          <a:lstStyle/>
+          <a:p>
+            <a:pPr algn="r"/>
+            <a:r>
+              <a:rPr sz="800">
+                <a:solidFill>
+                  <a:srgbClr val="606060"/>
+                </a:solidFill>
+              </a:rPr>
+              <a:t>16</a:t>
+            </a:r>
+          </a:p>
+        </p:txBody>
+      </p:sp>
+    </p:spTree>
+  </p:cSld>
+  <p:clrMapOvr>
+    <a:masterClrMapping/>
+  </p:clrMapOvr>
+</p:sld>
+</file>
+
+<file path=ppt/slides/slide17.xml><?xml version="1.0" encoding="utf-8"?>
+<p:sld xmlns:a="http://schemas.openxmlformats.org/drawingml/2006/main" xmlns:p="http://schemas.openxmlformats.org/presentationml/2006/main" xmlns:r="http://schemas.openxmlformats.org/officeDocument/2006/relationships">
+  <p:cSld>
+    <p:spTree>
+      <p:nvGrpSpPr>
+        <p:cNvPr id="1" name=""/>
+        <p:cNvGrpSpPr/>
+        <p:nvPr/>
+      </p:nvGrpSpPr>
+      <p:grpSpPr/>
+      <p:sp>
+        <p:nvSpPr>
+          <p:cNvPr id="3" name="Text Placeholder 2"/>
+          <p:cNvSpPr>
+            <a:spLocks noGrp="1"/>
+          </p:cNvSpPr>
+          <p:nvPr>
+            <p:ph type="body" idx="13" sz="quarter"/>
+          </p:nvPr>
+        </p:nvSpPr>
+        <p:spPr/>
+        <p:txBody>
+          <a:bodyPr/>
+          <a:lstStyle/>
+          <a:p/>
+        </p:txBody>
+      </p:sp>
+      <p:sp>
+        <p:nvSpPr>
+          <p:cNvPr id="4" name="Title 3"/>
+          <p:cNvSpPr>
+            <a:spLocks noGrp="1"/>
+          </p:cNvSpPr>
+          <p:nvPr>
+            <p:ph type="title"/>
+          </p:nvPr>
+        </p:nvSpPr>
+        <p:spPr/>
+        <p:txBody>
+          <a:bodyPr/>
+          <a:lstStyle/>
+          <a:p>
+            <a:r>
+              <a:t>Backup: Model Facts</a:t>
+            </a:r>
+          </a:p>
+        </p:txBody>
+      </p:sp>
+      <p:sp>
+        <p:nvSpPr>
+          <p:cNvPr id="5" name="Text Placeholder 4"/>
+          <p:cNvSpPr>
+            <a:spLocks noGrp="1"/>
+          </p:cNvSpPr>
+          <p:nvPr>
+            <p:ph type="body" idx="14" sz="quarter"/>
+          </p:nvPr>
+        </p:nvSpPr>
+        <p:spPr/>
+        <p:txBody>
+          <a:bodyPr/>
+          <a:lstStyle/>
+          <a:p/>
+        </p:txBody>
+      </p:sp>
+      <p:sp>
+        <p:nvSpPr>
           <p:cNvPr id="6" name="Rounded Rectangle 5"/>
           <p:cNvSpPr/>
           <p:nvPr/>
@@ -15140,7 +16332,7 @@
                   <a:srgbClr val="20252A"/>
                 </a:solidFill>
               </a:rPr>
-              <a:t>One layer per person, regular alignment</a:t>
+              <a:t>One layer per team pair or person, regular alignment</a:t>
             </a:r>
           </a:p>
           <a:p>
@@ -15222,7 +16414,7 @@
                   <a:srgbClr val="606060"/>
                 </a:solidFill>
               </a:rPr>
-              <a:t>16</a:t>
+              <a:t>17</a:t>
             </a:r>
           </a:p>
         </p:txBody>
@@ -15312,7 +16504,7 @@
         </p:nvSpPr>
         <p:spPr>
           <a:xfrm>
-            <a:off x="676655" y="1691640"/>
+            <a:off x="493776" y="1691640"/>
             <a:ext cx="841248" cy="841248"/>
           </a:xfrm>
           <a:prstGeom prst="ellipse">
@@ -15364,8 +16556,8 @@
         </p:nvSpPr>
         <p:spPr>
           <a:xfrm>
-            <a:off x="228599" y="2670048"/>
-            <a:ext cx="1737360" cy="1371600"/>
+            <a:off x="173736" y="2670048"/>
+            <a:ext cx="1481328" cy="1371600"/>
           </a:xfrm>
           <a:prstGeom prst="rect">
             <a:avLst/>
@@ -15417,7 +16609,7 @@
         </p:nvSpPr>
         <p:spPr>
           <a:xfrm>
-            <a:off x="2414015" y="1691640"/>
+            <a:off x="1956816" y="1691640"/>
             <a:ext cx="841248" cy="841248"/>
           </a:xfrm>
           <a:prstGeom prst="ellipse">
@@ -15469,8 +16661,8 @@
         </p:nvSpPr>
         <p:spPr>
           <a:xfrm>
-            <a:off x="1965959" y="2670048"/>
-            <a:ext cx="1737360" cy="1371600"/>
+            <a:off x="1636776" y="2670048"/>
+            <a:ext cx="1481328" cy="1371600"/>
           </a:xfrm>
           <a:prstGeom prst="rect">
             <a:avLst/>
@@ -15522,7 +16714,7 @@
         </p:nvSpPr>
         <p:spPr>
           <a:xfrm>
-            <a:off x="4151375" y="1691640"/>
+            <a:off x="3419856" y="1691640"/>
             <a:ext cx="841248" cy="841248"/>
           </a:xfrm>
           <a:prstGeom prst="ellipse">
@@ -15574,8 +16766,8 @@
         </p:nvSpPr>
         <p:spPr>
           <a:xfrm>
-            <a:off x="3703320" y="2670048"/>
-            <a:ext cx="1737360" cy="1371600"/>
+            <a:off x="3099816" y="2670048"/>
+            <a:ext cx="1481328" cy="1371600"/>
           </a:xfrm>
           <a:prstGeom prst="rect">
             <a:avLst/>
@@ -15599,7 +16791,7 @@
                   <a:srgbClr val="20252A"/>
                 </a:solidFill>
               </a:rPr>
-              <a:t>Fiona Aurelia</a:t>
+              <a:t>Fiona Aurelia Tunggalmuljo</a:t>
             </a:r>
           </a:p>
           <a:p>
@@ -15627,7 +16819,112 @@
         </p:nvSpPr>
         <p:spPr>
           <a:xfrm>
-            <a:off x="5888735" y="1691640"/>
+            <a:off x="4882896" y="1691640"/>
+            <a:ext cx="841248" cy="841248"/>
+          </a:xfrm>
+          <a:prstGeom prst="ellipse">
+            <a:avLst/>
+          </a:prstGeom>
+          <a:solidFill>
+            <a:srgbClr val="0065BD"/>
+          </a:solidFill>
+          <a:ln>
+            <a:noFill/>
+          </a:ln>
+          <a:effectLst/>
+        </p:spPr>
+        <p:style>
+          <a:lnRef idx="1">
+            <a:schemeClr val="accent1"/>
+          </a:lnRef>
+          <a:fillRef idx="3">
+            <a:schemeClr val="accent1"/>
+          </a:fillRef>
+          <a:effectRef idx="2">
+            <a:schemeClr val="accent1"/>
+          </a:effectRef>
+          <a:fontRef idx="minor">
+            <a:schemeClr val="lt1"/>
+          </a:fontRef>
+        </p:style>
+        <p:txBody>
+          <a:bodyPr rtlCol="0" anchor="ctr" wrap="none" lIns="0" rIns="0" tIns="0" bIns="0"/>
+          <a:lstStyle/>
+          <a:p>
+            <a:pPr algn="ctr"/>
+            <a:r>
+              <a:rPr sz="2400" b="1">
+                <a:solidFill>
+                  <a:srgbClr val="FFFFFF"/>
+                </a:solidFill>
+              </a:rPr>
+              <a:t>KB</a:t>
+            </a:r>
+          </a:p>
+        </p:txBody>
+      </p:sp>
+      <p:sp>
+        <p:nvSpPr>
+          <p:cNvPr id="13" name="TextBox 12"/>
+          <p:cNvSpPr txBox="1"/>
+          <p:nvPr/>
+        </p:nvSpPr>
+        <p:spPr>
+          <a:xfrm>
+            <a:off x="4562856" y="2670048"/>
+            <a:ext cx="1481328" cy="1371600"/>
+          </a:xfrm>
+          <a:prstGeom prst="rect">
+            <a:avLst/>
+          </a:prstGeom>
+          <a:noFill/>
+        </p:spPr>
+        <p:txBody>
+          <a:bodyPr wrap="square">
+            <a:spAutoFit/>
+          </a:bodyPr>
+          <a:lstStyle/>
+          <a:p>
+            <a:pPr algn="ctr">
+              <a:spcAft>
+                <a:spcPts val="400"/>
+              </a:spcAft>
+            </a:pPr>
+            <a:r>
+              <a:rPr sz="1250" b="1">
+                <a:solidFill>
+                  <a:srgbClr val="20252A"/>
+                </a:solidFill>
+              </a:rPr>
+              <a:t>Mingwai Kelly Bin</a:t>
+            </a:r>
+          </a:p>
+          <a:p>
+            <a:pPr algn="ctr">
+              <a:spcAft>
+                <a:spcPts val="400"/>
+              </a:spcAft>
+            </a:pPr>
+            <a:r>
+              <a:rPr sz="1150">
+                <a:solidFill>
+                  <a:srgbClr val="606060"/>
+                </a:solidFill>
+              </a:rPr>
+              <a:t>Application layer</a:t>
+            </a:r>
+          </a:p>
+        </p:txBody>
+      </p:sp>
+      <p:sp>
+        <p:nvSpPr>
+          <p:cNvPr id="14" name="Oval 13"/>
+          <p:cNvSpPr/>
+          <p:nvPr/>
+        </p:nvSpPr>
+        <p:spPr>
+          <a:xfrm>
+            <a:off x="6345936" y="1691640"/>
             <a:ext cx="841248" cy="841248"/>
           </a:xfrm>
           <a:prstGeom prst="ellipse">
@@ -15673,14 +16970,14 @@
       </p:sp>
       <p:sp>
         <p:nvSpPr>
-          <p:cNvPr id="13" name="TextBox 12"/>
+          <p:cNvPr id="15" name="TextBox 14"/>
           <p:cNvSpPr txBox="1"/>
           <p:nvPr/>
         </p:nvSpPr>
         <p:spPr>
           <a:xfrm>
-            <a:off x="5440679" y="2670048"/>
-            <a:ext cx="1737360" cy="1371600"/>
+            <a:off x="6025896" y="2670048"/>
+            <a:ext cx="1481328" cy="1371600"/>
           </a:xfrm>
           <a:prstGeom prst="rect">
             <a:avLst/>
@@ -15726,13 +17023,13 @@
       </p:sp>
       <p:sp>
         <p:nvSpPr>
-          <p:cNvPr id="14" name="Oval 13"/>
+          <p:cNvPr id="16" name="Oval 15"/>
           <p:cNvSpPr/>
           <p:nvPr/>
         </p:nvSpPr>
         <p:spPr>
           <a:xfrm>
-            <a:off x="7626095" y="1691640"/>
+            <a:off x="7808975" y="1691640"/>
             <a:ext cx="841248" cy="841248"/>
           </a:xfrm>
           <a:prstGeom prst="ellipse">
@@ -15778,14 +17075,14 @@
       </p:sp>
       <p:sp>
         <p:nvSpPr>
-          <p:cNvPr id="15" name="TextBox 14"/>
+          <p:cNvPr id="17" name="TextBox 16"/>
           <p:cNvSpPr txBox="1"/>
           <p:nvPr/>
         </p:nvSpPr>
         <p:spPr>
           <a:xfrm>
-            <a:off x="7178040" y="2670048"/>
-            <a:ext cx="1737360" cy="1371600"/>
+            <a:off x="7488936" y="2670048"/>
+            <a:ext cx="1481328" cy="1371600"/>
           </a:xfrm>
           <a:prstGeom prst="rect">
             <a:avLst/>
@@ -15831,7 +17128,7 @@
       </p:sp>
       <p:sp>
         <p:nvSpPr>
-          <p:cNvPr id="16" name="TextBox 15"/>
+          <p:cNvPr id="18" name="TextBox 17"/>
           <p:cNvSpPr txBox="1"/>
           <p:nvPr/>
         </p:nvSpPr>
@@ -15864,7 +17161,7 @@
       </p:sp>
       <p:sp>
         <p:nvSpPr>
-          <p:cNvPr id="17" name="TextBox 16"/>
+          <p:cNvPr id="19" name="TextBox 18"/>
           <p:cNvSpPr txBox="1"/>
           <p:nvPr/>
         </p:nvSpPr>
@@ -20930,7 +22227,7 @@
           <a:lstStyle/>
           <a:p>
             <a:r>
-              <a:t>Functions, services, events and data objects the abstract view hid</a:t>
+              <a:t>The functions and services behind the business processes</a:t>
             </a:r>
           </a:p>
         </p:txBody>
@@ -21151,6 +22448,106 @@
         </p:nvSpPr>
         <p:spPr>
           <a:xfrm>
+            <a:off x="2318835" y="2733746"/>
+            <a:ext cx="699579" cy="390381"/>
+          </a:xfrm>
+          <a:prstGeom prst="roundRect">
+            <a:avLst>
+              <a:gd name="adj" fmla="val 6000"/>
+            </a:avLst>
+          </a:prstGeom>
+          <a:noFill/>
+          <a:ln w="28575">
+            <a:solidFill>
+              <a:srgbClr val="E37A00"/>
+            </a:solidFill>
+          </a:ln>
+          <a:effectLst/>
+        </p:spPr>
+        <p:style>
+          <a:lnRef idx="1">
+            <a:schemeClr val="accent1"/>
+          </a:lnRef>
+          <a:fillRef idx="3">
+            <a:schemeClr val="accent1"/>
+          </a:fillRef>
+          <a:effectRef idx="2">
+            <a:schemeClr val="accent1"/>
+          </a:effectRef>
+          <a:fontRef idx="minor">
+            <a:schemeClr val="lt1"/>
+          </a:fontRef>
+        </p:style>
+        <p:txBody>
+          <a:bodyPr rtlCol="0" anchor="ctr"/>
+          <a:lstStyle/>
+          <a:p>
+            <a:pPr algn="ctr"/>
+          </a:p>
+        </p:txBody>
+      </p:sp>
+      <p:sp>
+        <p:nvSpPr>
+          <p:cNvPr id="11" name="Rounded Rectangle 10"/>
+          <p:cNvSpPr/>
+          <p:nvPr/>
+        </p:nvSpPr>
+        <p:spPr>
+          <a:xfrm>
+            <a:off x="2318835" y="2477714"/>
+            <a:ext cx="1947672" cy="246888"/>
+          </a:xfrm>
+          <a:prstGeom prst="roundRect">
+            <a:avLst>
+              <a:gd name="adj" fmla="val 50000"/>
+            </a:avLst>
+          </a:prstGeom>
+          <a:solidFill>
+            <a:srgbClr val="E37A00"/>
+          </a:solidFill>
+          <a:ln>
+            <a:noFill/>
+          </a:ln>
+          <a:effectLst/>
+        </p:spPr>
+        <p:style>
+          <a:lnRef idx="1">
+            <a:schemeClr val="accent1"/>
+          </a:lnRef>
+          <a:fillRef idx="3">
+            <a:schemeClr val="accent1"/>
+          </a:fillRef>
+          <a:effectRef idx="2">
+            <a:schemeClr val="accent1"/>
+          </a:effectRef>
+          <a:fontRef idx="minor">
+            <a:schemeClr val="lt1"/>
+          </a:fontRef>
+        </p:style>
+        <p:txBody>
+          <a:bodyPr rtlCol="0" anchor="ctr" lIns="50800" rIns="50800" tIns="0" bIns="0"/>
+          <a:lstStyle/>
+          <a:p>
+            <a:pPr algn="ctr"/>
+            <a:r>
+              <a:rPr sz="1200" b="1">
+                <a:solidFill>
+                  <a:srgbClr val="FFFFFF"/>
+                </a:solidFill>
+              </a:rPr>
+              <a:t>Internal functions</a:t>
+            </a:r>
+          </a:p>
+        </p:txBody>
+      </p:sp>
+      <p:sp>
+        <p:nvSpPr>
+          <p:cNvPr id="12" name="Rounded Rectangle 11"/>
+          <p:cNvSpPr/>
+          <p:nvPr/>
+        </p:nvSpPr>
+        <p:spPr>
+          <a:xfrm>
             <a:off x="2603940" y="1601358"/>
             <a:ext cx="731703" cy="390381"/>
           </a:xfrm>
@@ -21191,7 +22588,7 @@
       </p:sp>
       <p:sp>
         <p:nvSpPr>
-          <p:cNvPr id="11" name="Rounded Rectangle 10"/>
+          <p:cNvPr id="13" name="Rounded Rectangle 12"/>
           <p:cNvSpPr/>
           <p:nvPr/>
         </p:nvSpPr>
@@ -21245,207 +22642,7 @@
       </p:sp>
       <p:sp>
         <p:nvSpPr>
-          <p:cNvPr id="12" name="Rounded Rectangle 11"/>
-          <p:cNvSpPr/>
-          <p:nvPr/>
-        </p:nvSpPr>
-        <p:spPr>
-          <a:xfrm>
-            <a:off x="2126088" y="2348252"/>
-            <a:ext cx="1374192" cy="390381"/>
-          </a:xfrm>
-          <a:prstGeom prst="roundRect">
-            <a:avLst>
-              <a:gd name="adj" fmla="val 6000"/>
-            </a:avLst>
-          </a:prstGeom>
-          <a:noFill/>
-          <a:ln w="28575">
-            <a:solidFill>
-              <a:srgbClr val="E37A00"/>
-            </a:solidFill>
-          </a:ln>
-          <a:effectLst/>
-        </p:spPr>
-        <p:style>
-          <a:lnRef idx="1">
-            <a:schemeClr val="accent1"/>
-          </a:lnRef>
-          <a:fillRef idx="3">
-            <a:schemeClr val="accent1"/>
-          </a:fillRef>
-          <a:effectRef idx="2">
-            <a:schemeClr val="accent1"/>
-          </a:effectRef>
-          <a:fontRef idx="minor">
-            <a:schemeClr val="lt1"/>
-          </a:fontRef>
-        </p:style>
-        <p:txBody>
-          <a:bodyPr rtlCol="0" anchor="ctr"/>
-          <a:lstStyle/>
-          <a:p>
-            <a:pPr algn="ctr"/>
-          </a:p>
-        </p:txBody>
-      </p:sp>
-      <p:sp>
-        <p:nvSpPr>
-          <p:cNvPr id="13" name="Rounded Rectangle 12"/>
-          <p:cNvSpPr/>
-          <p:nvPr/>
-        </p:nvSpPr>
-        <p:spPr>
-          <a:xfrm>
-            <a:off x="2126088" y="2092220"/>
-            <a:ext cx="1275588" cy="246888"/>
-          </a:xfrm>
-          <a:prstGeom prst="roundRect">
-            <a:avLst>
-              <a:gd name="adj" fmla="val 50000"/>
-            </a:avLst>
-          </a:prstGeom>
-          <a:solidFill>
-            <a:srgbClr val="E37A00"/>
-          </a:solidFill>
-          <a:ln>
-            <a:noFill/>
-          </a:ln>
-          <a:effectLst/>
-        </p:spPr>
-        <p:style>
-          <a:lnRef idx="1">
-            <a:schemeClr val="accent1"/>
-          </a:lnRef>
-          <a:fillRef idx="3">
-            <a:schemeClr val="accent1"/>
-          </a:fillRef>
-          <a:effectRef idx="2">
-            <a:schemeClr val="accent1"/>
-          </a:effectRef>
-          <a:fontRef idx="minor">
-            <a:schemeClr val="lt1"/>
-          </a:fontRef>
-        </p:style>
-        <p:txBody>
-          <a:bodyPr rtlCol="0" anchor="ctr" lIns="50800" rIns="50800" tIns="0" bIns="0"/>
-          <a:lstStyle/>
-          <a:p>
-            <a:pPr algn="ctr"/>
-            <a:r>
-              <a:rPr sz="1200" b="1">
-                <a:solidFill>
-                  <a:srgbClr val="FFFFFF"/>
-                </a:solidFill>
-              </a:rPr>
-              <a:t>Event chain</a:t>
-            </a:r>
-          </a:p>
-        </p:txBody>
-      </p:sp>
-      <p:sp>
-        <p:nvSpPr>
-          <p:cNvPr id="14" name="Rounded Rectangle 13"/>
-          <p:cNvSpPr/>
-          <p:nvPr/>
-        </p:nvSpPr>
-        <p:spPr>
-          <a:xfrm>
-            <a:off x="2559769" y="4299813"/>
-            <a:ext cx="651392" cy="390381"/>
-          </a:xfrm>
-          <a:prstGeom prst="roundRect">
-            <a:avLst>
-              <a:gd name="adj" fmla="val 6000"/>
-            </a:avLst>
-          </a:prstGeom>
-          <a:noFill/>
-          <a:ln w="28575">
-            <a:solidFill>
-              <a:srgbClr val="6A3D9A"/>
-            </a:solidFill>
-          </a:ln>
-          <a:effectLst/>
-        </p:spPr>
-        <p:style>
-          <a:lnRef idx="1">
-            <a:schemeClr val="accent1"/>
-          </a:lnRef>
-          <a:fillRef idx="3">
-            <a:schemeClr val="accent1"/>
-          </a:fillRef>
-          <a:effectRef idx="2">
-            <a:schemeClr val="accent1"/>
-          </a:effectRef>
-          <a:fontRef idx="minor">
-            <a:schemeClr val="lt1"/>
-          </a:fontRef>
-        </p:style>
-        <p:txBody>
-          <a:bodyPr rtlCol="0" anchor="ctr"/>
-          <a:lstStyle/>
-          <a:p>
-            <a:pPr algn="ctr"/>
-          </a:p>
-        </p:txBody>
-      </p:sp>
-      <p:sp>
-        <p:nvSpPr>
-          <p:cNvPr id="15" name="Rounded Rectangle 14"/>
-          <p:cNvSpPr/>
-          <p:nvPr/>
-        </p:nvSpPr>
-        <p:spPr>
-          <a:xfrm>
-            <a:off x="2559769" y="4043781"/>
-            <a:ext cx="2834640" cy="246888"/>
-          </a:xfrm>
-          <a:prstGeom prst="roundRect">
-            <a:avLst>
-              <a:gd name="adj" fmla="val 50000"/>
-            </a:avLst>
-          </a:prstGeom>
-          <a:solidFill>
-            <a:srgbClr val="6A3D9A"/>
-          </a:solidFill>
-          <a:ln>
-            <a:noFill/>
-          </a:ln>
-          <a:effectLst/>
-        </p:spPr>
-        <p:style>
-          <a:lnRef idx="1">
-            <a:schemeClr val="accent1"/>
-          </a:lnRef>
-          <a:fillRef idx="3">
-            <a:schemeClr val="accent1"/>
-          </a:fillRef>
-          <a:effectRef idx="2">
-            <a:schemeClr val="accent1"/>
-          </a:effectRef>
-          <a:fontRef idx="minor">
-            <a:schemeClr val="lt1"/>
-          </a:fontRef>
-        </p:style>
-        <p:txBody>
-          <a:bodyPr rtlCol="0" anchor="ctr" lIns="50800" rIns="50800" tIns="0" bIns="0"/>
-          <a:lstStyle/>
-          <a:p>
-            <a:pPr algn="ctr"/>
-            <a:r>
-              <a:rPr sz="1200" b="1">
-                <a:solidFill>
-                  <a:srgbClr val="FFFFFF"/>
-                </a:solidFill>
-              </a:rPr>
-              <a:t>Data object realizes Reservation</a:t>
-            </a:r>
-          </a:p>
-        </p:txBody>
-      </p:sp>
-      <p:sp>
-        <p:nvSpPr>
-          <p:cNvPr id="28" name="TextBox 27"/>
+          <p:cNvPr id="22" name="TextBox 21"/>
           <p:cNvSpPr txBox="1"/>
           <p:nvPr/>
         </p:nvSpPr>
@@ -21478,7 +22675,7 @@
       </p:sp>
       <p:sp>
         <p:nvSpPr>
-          <p:cNvPr id="29" name="TextBox 28"/>
+          <p:cNvPr id="23" name="TextBox 22"/>
           <p:cNvSpPr txBox="1"/>
           <p:nvPr/>
         </p:nvSpPr>
@@ -21739,78 +22936,6 @@
                       </p:childTnLst>
                     </p:cTn>
                   </p:par>
-                  <p:par>
-                    <p:cTn id="22" fill="hold">
-                      <p:stCondLst>
-                        <p:cond delay="indefinite"/>
-                      </p:stCondLst>
-                      <p:childTnLst>
-                        <p:par>
-                          <p:cTn id="23" fill="hold">
-                            <p:stCondLst>
-                              <p:cond delay="0"/>
-                            </p:stCondLst>
-                            <p:childTnLst>
-                              <p:par>
-                                <p:cTn id="24" presetID="1" presetClass="entr" presetSubtype="0" fill="hold" grpId="0" nodeType="clickEffect">
-                                  <p:stCondLst>
-                                    <p:cond delay="0"/>
-                                  </p:stCondLst>
-                                  <p:childTnLst>
-                                    <p:set>
-                                      <p:cBhvr>
-                                        <p:cTn id="25" dur="1" fill="hold">
-                                          <p:stCondLst>
-                                            <p:cond delay="0"/>
-                                          </p:stCondLst>
-                                        </p:cTn>
-                                        <p:tgtEl>
-                                          <p:spTgt spid="14"/>
-                                        </p:tgtEl>
-                                        <p:attrNameLst>
-                                          <p:attrName>style.visibility</p:attrName>
-                                        </p:attrNameLst>
-                                      </p:cBhvr>
-                                      <p:to>
-                                        <p:strVal val="visible"/>
-                                      </p:to>
-                                    </p:set>
-                                  </p:childTnLst>
-                                </p:cTn>
-                              </p:par>
-                              <p:par>
-                                <p:cTn id="26" presetID="1" presetClass="entr" presetSubtype="0" fill="hold" grpId="0" nodeType="withEffect">
-                                  <p:stCondLst>
-                                    <p:cond delay="0"/>
-                                  </p:stCondLst>
-                                  <p:childTnLst>
-                                    <p:set>
-                                      <p:cBhvr>
-                                        <p:cTn id="27" dur="1" fill="hold">
-                                          <p:stCondLst>
-                                            <p:cond delay="0"/>
-                                          </p:stCondLst>
-                                        </p:cTn>
-                                        <p:tgtEl>
-                                          <p:spTgt spid="15"/>
-                                        </p:tgtEl>
-                                        <p:attrNameLst>
-                                          <p:attrName>style.visibility</p:attrName>
-                                        </p:attrNameLst>
-                                      </p:cBhvr>
-                                      <p:to>
-                                        <p:strVal val="visible"/>
-                                      </p:to>
-                                    </p:set>
-                                  </p:childTnLst>
-                                </p:cTn>
-                              </p:par>
-                            </p:childTnLst>
-                          </p:cTn>
-                        </p:par>
-                      </p:childTnLst>
-                    </p:cTn>
-                  </p:par>
                 </p:childTnLst>
               </p:cTn>
               <p:prevCondLst>
@@ -21839,8 +22964,6 @@
       <p:bldP spid="11" grpId="0"/>
       <p:bldP spid="12" grpId="0"/>
       <p:bldP spid="13" grpId="0"/>
-      <p:bldP spid="14" grpId="0"/>
-      <p:bldP spid="15" grpId="0"/>
     </p:bldLst>
   </p:timing>
 </p:sld>
@@ -21872,7 +22995,7 @@
           <a:lstStyle/>
           <a:p>
             <a:r>
-              <a:t>How an online reservation becomes a door that opens</a:t>
+              <a:t>How one reservation flows through the system</a:t>
             </a:r>
           </a:p>
         </p:txBody>
@@ -21893,7 +23016,7 @@
           <a:lstStyle/>
           <a:p>
             <a:r>
-              <a:t>F1 Technology Layer: Down to the Door</a:t>
+              <a:t>F1 Application Layer: Events &amp; Data</a:t>
             </a:r>
           </a:p>
         </p:txBody>
@@ -21923,8 +23046,8 @@
         </p:nvSpPr>
         <p:spPr>
           <a:xfrm>
-            <a:off x="1213027" y="1463040"/>
-            <a:ext cx="6717945" cy="3236976"/>
+            <a:off x="730900" y="1463040"/>
+            <a:ext cx="7682199" cy="3236976"/>
           </a:xfrm>
           <a:prstGeom prst="rect">
             <a:avLst/>
@@ -21963,7 +23086,7 @@
       </p:sp>
       <p:pic>
         <p:nvPicPr>
-          <p:cNvPr id="7" name="Picture 6" descr="tech_layer.png"/>
+          <p:cNvPr id="7" name="Picture 6" descr="app_layer.png"/>
           <p:cNvPicPr>
             <a:picLocks noChangeAspect="1"/>
           </p:cNvPicPr>
@@ -21977,8 +23100,8 @@
         </p:blipFill>
         <p:spPr>
           <a:xfrm>
-            <a:off x="1231315" y="1481328"/>
-            <a:ext cx="6681369" cy="3200400"/>
+            <a:off x="749188" y="1481328"/>
+            <a:ext cx="7645623" cy="3200400"/>
           </a:xfrm>
           <a:prstGeom prst="rect">
             <a:avLst/>
@@ -21993,8 +23116,8 @@
         </p:nvSpPr>
         <p:spPr>
           <a:xfrm>
-            <a:off x="3948129" y="1972604"/>
-            <a:ext cx="757932" cy="448830"/>
+            <a:off x="2126088" y="2348252"/>
+            <a:ext cx="1374192" cy="390381"/>
           </a:xfrm>
           <a:prstGeom prst="roundRect">
             <a:avLst>
@@ -22039,8 +23162,8 @@
         </p:nvSpPr>
         <p:spPr>
           <a:xfrm>
-            <a:off x="3948129" y="1716572"/>
-            <a:ext cx="1755648" cy="246888"/>
+            <a:off x="2126088" y="2092220"/>
+            <a:ext cx="1275588" cy="246888"/>
           </a:xfrm>
           <a:prstGeom prst="roundRect">
             <a:avLst>
@@ -22080,7 +23203,7 @@
                   <a:srgbClr val="FFFFFF"/>
                 </a:solidFill>
               </a:rPr>
-              <a:t>Door Card Reader</a:t>
+              <a:t>Event chain</a:t>
             </a:r>
           </a:p>
         </p:txBody>
@@ -22093,8 +23216,8 @@
         </p:nvSpPr>
         <p:spPr>
           <a:xfrm>
-            <a:off x="2231421" y="1944071"/>
-            <a:ext cx="1447469" cy="2503173"/>
+            <a:off x="6366518" y="3384266"/>
+            <a:ext cx="1374192" cy="799968"/>
           </a:xfrm>
           <a:prstGeom prst="roundRect">
             <a:avLst>
@@ -22104,7 +23227,7 @@
           <a:noFill/>
           <a:ln w="28575">
             <a:solidFill>
-              <a:srgbClr val="C40000"/>
+              <a:srgbClr val="2E8B2E"/>
             </a:solidFill>
           </a:ln>
           <a:effectLst/>
@@ -22139,8 +23262,8 @@
         </p:nvSpPr>
         <p:spPr>
           <a:xfrm>
-            <a:off x="2231421" y="1688039"/>
-            <a:ext cx="1851660" cy="246888"/>
+            <a:off x="6366518" y="3128234"/>
+            <a:ext cx="2619756" cy="246888"/>
           </a:xfrm>
           <a:prstGeom prst="roundRect">
             <a:avLst>
@@ -22148,7 +23271,7 @@
             </a:avLst>
           </a:prstGeom>
           <a:solidFill>
-            <a:srgbClr val="C40000"/>
+            <a:srgbClr val="2E8B2E"/>
           </a:solidFill>
           <a:ln>
             <a:noFill/>
@@ -22180,7 +23303,7 @@
                   <a:srgbClr val="FFFFFF"/>
                 </a:solidFill>
               </a:rPr>
-              <a:t>Grant Room Access</a:t>
+              <a:t>Approval &amp; payment events</a:t>
             </a:r>
           </a:p>
         </p:txBody>
@@ -22193,8 +23316,8 @@
         </p:nvSpPr>
         <p:spPr>
           <a:xfrm>
-            <a:off x="1375445" y="2914177"/>
-            <a:ext cx="757932" cy="848286"/>
+            <a:off x="2559769" y="4299813"/>
+            <a:ext cx="651392" cy="390381"/>
           </a:xfrm>
           <a:prstGeom prst="roundRect">
             <a:avLst>
@@ -22239,8 +23362,8 @@
         </p:nvSpPr>
         <p:spPr>
           <a:xfrm>
-            <a:off x="1375445" y="2658145"/>
-            <a:ext cx="1083564" cy="246888"/>
+            <a:off x="2559769" y="4043781"/>
+            <a:ext cx="2834640" cy="246888"/>
           </a:xfrm>
           <a:prstGeom prst="roundRect">
             <a:avLst>
@@ -22280,214 +23403,14 @@
                   <a:srgbClr val="FFFFFF"/>
                 </a:solidFill>
               </a:rPr>
-              <a:t>Artifacts</a:t>
-            </a:r>
-          </a:p>
-        </p:txBody>
-      </p:sp>
-      <p:sp>
-        <p:nvSpPr>
-          <p:cNvPr id="14" name="Rounded Rectangle 13"/>
-          <p:cNvSpPr/>
-          <p:nvPr/>
-        </p:nvSpPr>
-        <p:spPr>
-          <a:xfrm>
-            <a:off x="4461714" y="3470562"/>
-            <a:ext cx="2431842" cy="620025"/>
-          </a:xfrm>
-          <a:prstGeom prst="roundRect">
-            <a:avLst>
-              <a:gd name="adj" fmla="val 6000"/>
-            </a:avLst>
-          </a:prstGeom>
-          <a:noFill/>
-          <a:ln w="28575">
-            <a:solidFill>
-              <a:srgbClr val="2E8B2E"/>
-            </a:solidFill>
-          </a:ln>
-          <a:effectLst/>
-        </p:spPr>
-        <p:style>
-          <a:lnRef idx="1">
-            <a:schemeClr val="accent1"/>
-          </a:lnRef>
-          <a:fillRef idx="3">
-            <a:schemeClr val="accent1"/>
-          </a:fillRef>
-          <a:effectRef idx="2">
-            <a:schemeClr val="accent1"/>
-          </a:effectRef>
-          <a:fontRef idx="minor">
-            <a:schemeClr val="lt1"/>
-          </a:fontRef>
-        </p:style>
-        <p:txBody>
-          <a:bodyPr rtlCol="0" anchor="ctr"/>
-          <a:lstStyle/>
-          <a:p>
-            <a:pPr algn="ctr"/>
-          </a:p>
-        </p:txBody>
-      </p:sp>
-      <p:sp>
-        <p:nvSpPr>
-          <p:cNvPr id="15" name="Rounded Rectangle 14"/>
-          <p:cNvSpPr/>
-          <p:nvPr/>
-        </p:nvSpPr>
-        <p:spPr>
-          <a:xfrm>
-            <a:off x="4461714" y="4099732"/>
-            <a:ext cx="1371600" cy="246888"/>
-          </a:xfrm>
-          <a:prstGeom prst="roundRect">
-            <a:avLst>
-              <a:gd name="adj" fmla="val 50000"/>
-            </a:avLst>
-          </a:prstGeom>
-          <a:solidFill>
-            <a:srgbClr val="2E8B2E"/>
-          </a:solidFill>
-          <a:ln>
-            <a:noFill/>
-          </a:ln>
-          <a:effectLst/>
-        </p:spPr>
-        <p:style>
-          <a:lnRef idx="1">
-            <a:schemeClr val="accent1"/>
-          </a:lnRef>
-          <a:fillRef idx="3">
-            <a:schemeClr val="accent1"/>
-          </a:fillRef>
-          <a:effectRef idx="2">
-            <a:schemeClr val="accent1"/>
-          </a:effectRef>
-          <a:fontRef idx="minor">
-            <a:schemeClr val="lt1"/>
-          </a:fontRef>
-        </p:style>
-        <p:txBody>
-          <a:bodyPr rtlCol="0" anchor="ctr" lIns="50800" rIns="50800" tIns="0" bIns="0"/>
-          <a:lstStyle/>
-          <a:p>
-            <a:pPr algn="ctr"/>
-            <a:r>
-              <a:rPr sz="1200" b="1">
-                <a:solidFill>
-                  <a:srgbClr val="FFFFFF"/>
-                </a:solidFill>
-              </a:rPr>
-              <a:t>RFID · Wi-Fi</a:t>
-            </a:r>
-          </a:p>
-        </p:txBody>
-      </p:sp>
-      <p:sp>
-        <p:nvSpPr>
-          <p:cNvPr id="16" name="Rounded Rectangle 15"/>
-          <p:cNvSpPr/>
-          <p:nvPr/>
-        </p:nvSpPr>
-        <p:spPr>
-          <a:xfrm>
-            <a:off x="4176389" y="4255207"/>
-            <a:ext cx="757932" cy="448830"/>
-          </a:xfrm>
-          <a:prstGeom prst="roundRect">
-            <a:avLst>
-              <a:gd name="adj" fmla="val 6000"/>
-            </a:avLst>
-          </a:prstGeom>
-          <a:noFill/>
-          <a:ln w="28575">
-            <a:solidFill>
-              <a:srgbClr val="B09A00"/>
-            </a:solidFill>
-          </a:ln>
-          <a:effectLst/>
-        </p:spPr>
-        <p:style>
-          <a:lnRef idx="1">
-            <a:schemeClr val="accent1"/>
-          </a:lnRef>
-          <a:fillRef idx="3">
-            <a:schemeClr val="accent1"/>
-          </a:fillRef>
-          <a:effectRef idx="2">
-            <a:schemeClr val="accent1"/>
-          </a:effectRef>
-          <a:fontRef idx="minor">
-            <a:schemeClr val="lt1"/>
-          </a:fontRef>
-        </p:style>
-        <p:txBody>
-          <a:bodyPr rtlCol="0" anchor="ctr"/>
-          <a:lstStyle/>
-          <a:p>
-            <a:pPr algn="ctr"/>
-          </a:p>
-        </p:txBody>
-      </p:sp>
-      <p:sp>
-        <p:nvSpPr>
-          <p:cNvPr id="17" name="Rounded Rectangle 16"/>
-          <p:cNvSpPr/>
-          <p:nvPr/>
-        </p:nvSpPr>
-        <p:spPr>
-          <a:xfrm>
-            <a:off x="4176389" y="4713181"/>
-            <a:ext cx="987552" cy="246888"/>
-          </a:xfrm>
-          <a:prstGeom prst="roundRect">
-            <a:avLst>
-              <a:gd name="adj" fmla="val 50000"/>
-            </a:avLst>
-          </a:prstGeom>
-          <a:solidFill>
-            <a:srgbClr val="B09A00"/>
-          </a:solidFill>
-          <a:ln>
-            <a:noFill/>
-          </a:ln>
-          <a:effectLst/>
-        </p:spPr>
-        <p:style>
-          <a:lnRef idx="1">
-            <a:schemeClr val="accent1"/>
-          </a:lnRef>
-          <a:fillRef idx="3">
-            <a:schemeClr val="accent1"/>
-          </a:fillRef>
-          <a:effectRef idx="2">
-            <a:schemeClr val="accent1"/>
-          </a:effectRef>
-          <a:fontRef idx="minor">
-            <a:schemeClr val="lt1"/>
-          </a:fontRef>
-        </p:style>
-        <p:txBody>
-          <a:bodyPr rtlCol="0" anchor="ctr" lIns="50800" rIns="50800" tIns="0" bIns="0"/>
-          <a:lstStyle/>
-          <a:p>
-            <a:pPr algn="ctr"/>
-            <a:r>
-              <a:rPr sz="1200" b="1">
-                <a:solidFill>
-                  <a:srgbClr val="FFFFFF"/>
-                </a:solidFill>
-              </a:rPr>
-              <a:t>Key Card</a:t>
-            </a:r>
-          </a:p>
-        </p:txBody>
-      </p:sp>
-      <p:sp>
-        <p:nvSpPr>
-          <p:cNvPr id="34" name="TextBox 33"/>
+              <a:t>Data object realizes Reservation</a:t>
+            </a:r>
+          </a:p>
+        </p:txBody>
+      </p:sp>
+      <p:sp>
+        <p:nvSpPr>
+          <p:cNvPr id="22" name="TextBox 21"/>
           <p:cNvSpPr txBox="1"/>
           <p:nvPr/>
         </p:nvSpPr>
@@ -22520,7 +23443,7 @@
       </p:sp>
       <p:sp>
         <p:nvSpPr>
-          <p:cNvPr id="35" name="TextBox 34"/>
+          <p:cNvPr id="23" name="TextBox 22"/>
           <p:cNvSpPr txBox="1"/>
           <p:nvPr/>
         </p:nvSpPr>
@@ -22781,150 +23704,6 @@
                       </p:childTnLst>
                     </p:cTn>
                   </p:par>
-                  <p:par>
-                    <p:cTn id="22" fill="hold">
-                      <p:stCondLst>
-                        <p:cond delay="indefinite"/>
-                      </p:stCondLst>
-                      <p:childTnLst>
-                        <p:par>
-                          <p:cTn id="23" fill="hold">
-                            <p:stCondLst>
-                              <p:cond delay="0"/>
-                            </p:stCondLst>
-                            <p:childTnLst>
-                              <p:par>
-                                <p:cTn id="24" presetID="1" presetClass="entr" presetSubtype="0" fill="hold" grpId="0" nodeType="clickEffect">
-                                  <p:stCondLst>
-                                    <p:cond delay="0"/>
-                                  </p:stCondLst>
-                                  <p:childTnLst>
-                                    <p:set>
-                                      <p:cBhvr>
-                                        <p:cTn id="25" dur="1" fill="hold">
-                                          <p:stCondLst>
-                                            <p:cond delay="0"/>
-                                          </p:stCondLst>
-                                        </p:cTn>
-                                        <p:tgtEl>
-                                          <p:spTgt spid="14"/>
-                                        </p:tgtEl>
-                                        <p:attrNameLst>
-                                          <p:attrName>style.visibility</p:attrName>
-                                        </p:attrNameLst>
-                                      </p:cBhvr>
-                                      <p:to>
-                                        <p:strVal val="visible"/>
-                                      </p:to>
-                                    </p:set>
-                                  </p:childTnLst>
-                                </p:cTn>
-                              </p:par>
-                              <p:par>
-                                <p:cTn id="26" presetID="1" presetClass="entr" presetSubtype="0" fill="hold" grpId="0" nodeType="withEffect">
-                                  <p:stCondLst>
-                                    <p:cond delay="0"/>
-                                  </p:stCondLst>
-                                  <p:childTnLst>
-                                    <p:set>
-                                      <p:cBhvr>
-                                        <p:cTn id="27" dur="1" fill="hold">
-                                          <p:stCondLst>
-                                            <p:cond delay="0"/>
-                                          </p:stCondLst>
-                                        </p:cTn>
-                                        <p:tgtEl>
-                                          <p:spTgt spid="15"/>
-                                        </p:tgtEl>
-                                        <p:attrNameLst>
-                                          <p:attrName>style.visibility</p:attrName>
-                                        </p:attrNameLst>
-                                      </p:cBhvr>
-                                      <p:to>
-                                        <p:strVal val="visible"/>
-                                      </p:to>
-                                    </p:set>
-                                  </p:childTnLst>
-                                </p:cTn>
-                              </p:par>
-                            </p:childTnLst>
-                          </p:cTn>
-                        </p:par>
-                      </p:childTnLst>
-                    </p:cTn>
-                  </p:par>
-                  <p:par>
-                    <p:cTn id="28" fill="hold">
-                      <p:stCondLst>
-                        <p:cond delay="indefinite"/>
-                      </p:stCondLst>
-                      <p:childTnLst>
-                        <p:par>
-                          <p:cTn id="29" fill="hold">
-                            <p:stCondLst>
-                              <p:cond delay="0"/>
-                            </p:stCondLst>
-                            <p:childTnLst>
-                              <p:par>
-                                <p:cTn id="30" presetID="1" presetClass="entr" presetSubtype="0" fill="hold" grpId="0" nodeType="clickEffect">
-                                  <p:stCondLst>
-                                    <p:cond delay="0"/>
-                                  </p:stCondLst>
-                                  <p:childTnLst>
-                                    <p:set>
-                                      <p:cBhvr>
-                                        <p:cTn id="31" dur="1" fill="hold">
-                                          <p:stCondLst>
-                                            <p:cond delay="0"/>
-                                          </p:stCondLst>
-                                        </p:cTn>
-                                        <p:tgtEl>
-                                          <p:spTgt spid="16"/>
-                                        </p:tgtEl>
-                                        <p:attrNameLst>
-                                          <p:attrName>style.visibility</p:attrName>
-                                        </p:attrNameLst>
-                                      </p:cBhvr>
-                                      <p:to>
-                                        <p:strVal val="visible"/>
-                                      </p:to>
-                                    </p:set>
-                                  </p:childTnLst>
-                                </p:cTn>
-                              </p:par>
-                              <p:par>
-                                <p:cTn id="32" presetID="1" presetClass="entr" presetSubtype="0" fill="hold" grpId="0" nodeType="withEffect">
-                                  <p:stCondLst>
-                                    <p:cond delay="0"/>
-                                  </p:stCondLst>
-                                  <p:childTnLst>
-                                    <p:set>
-                                      <p:cBhvr>
-                                        <p:cTn id="33" dur="1" fill="hold">
-                                          <p:stCondLst>
-                                            <p:cond delay="0"/>
-                                          </p:stCondLst>
-                                        </p:cTn>
-                                        <p:tgtEl>
-                                          <p:spTgt spid="17"/>
-                                        </p:tgtEl>
-                                        <p:attrNameLst>
-                                          <p:attrName>style.visibility</p:attrName>
-                                        </p:attrNameLst>
-                                      </p:cBhvr>
-                                      <p:to>
-                                        <p:strVal val="visible"/>
-                                      </p:to>
-                                    </p:set>
-                                  </p:childTnLst>
-                                </p:cTn>
-                              </p:par>
-                            </p:childTnLst>
-                          </p:cTn>
-                        </p:par>
-                      </p:childTnLst>
-                    </p:cTn>
-                  </p:par>
                 </p:childTnLst>
               </p:cTn>
               <p:prevCondLst>
@@ -22953,10 +23732,6 @@
       <p:bldP spid="11" grpId="0"/>
       <p:bldP spid="12" grpId="0"/>
       <p:bldP spid="13" grpId="0"/>
-      <p:bldP spid="14" grpId="0"/>
-      <p:bldP spid="15" grpId="0"/>
-      <p:bldP spid="16" grpId="0"/>
-      <p:bldP spid="17" grpId="0"/>
     </p:bldLst>
   </p:timing>
 </p:sld>

</xml_diff>